<commit_message>
Implement dual momentum mechanics tape
</commit_message>
<xml_diff>
--- a/literature_studies/presentations/gen5_lit_mom_03_1_dual_momentum_study.pptx
+++ b/literature_studies/presentations/gen5_lit_mom_03_1_dual_momentum_study.pptx
@@ -2,26 +2,30 @@
 <file path=ppt/presentation.xml><?xml version="1.0" encoding="utf-8"?>
 <p:presentation xmlns:p="http://schemas.openxmlformats.org/presentationml/2006/main">
   <p:sldMasterIdLst>
-    <p:sldMasterId xmlns:r="http://schemas.openxmlformats.org/officeDocument/2006/relationships" id="2147483648" r:id="R4d4eac06176140d4"/>
+    <p:sldMasterId xmlns:r="http://schemas.openxmlformats.org/officeDocument/2006/relationships" id="2147483648" r:id="R18cd756b67c74bba"/>
   </p:sldMasterIdLst>
   <p:notesMasterIdLst>
-    <p:notesMasterId xmlns:r="http://schemas.openxmlformats.org/officeDocument/2006/relationships" r:id="Re1820572d6824c52"/>
+    <p:notesMasterId xmlns:r="http://schemas.openxmlformats.org/officeDocument/2006/relationships" r:id="Rc099882b3f7d4749"/>
   </p:notesMasterIdLst>
   <p:sldIdLst>
-    <p:sldId xmlns:r="http://schemas.openxmlformats.org/officeDocument/2006/relationships" id="256" r:id="R37cd1d8c7aa2492b"/>
-    <p:sldId xmlns:r="http://schemas.openxmlformats.org/officeDocument/2006/relationships" id="257" r:id="R9e3ee2a0b6db41d8"/>
-    <p:sldId xmlns:r="http://schemas.openxmlformats.org/officeDocument/2006/relationships" id="258" r:id="Rb97da3b1116b4969"/>
-    <p:sldId xmlns:r="http://schemas.openxmlformats.org/officeDocument/2006/relationships" id="259" r:id="R3132b9159281465d"/>
-    <p:sldId xmlns:r="http://schemas.openxmlformats.org/officeDocument/2006/relationships" id="260" r:id="Rbe91e4cd08224d05"/>
-    <p:sldId xmlns:r="http://schemas.openxmlformats.org/officeDocument/2006/relationships" id="261" r:id="R14e6c2701558448b"/>
-    <p:sldId xmlns:r="http://schemas.openxmlformats.org/officeDocument/2006/relationships" id="262" r:id="Ra70de3d85e654510"/>
-    <p:sldId xmlns:r="http://schemas.openxmlformats.org/officeDocument/2006/relationships" id="263" r:id="Rd00dcc64f7bc42f5"/>
-    <p:sldId xmlns:r="http://schemas.openxmlformats.org/officeDocument/2006/relationships" id="264" r:id="R85dba230932940fa"/>
-    <p:sldId xmlns:r="http://schemas.openxmlformats.org/officeDocument/2006/relationships" id="265" r:id="R63714a69dc8f42c6"/>
-    <p:sldId xmlns:r="http://schemas.openxmlformats.org/officeDocument/2006/relationships" id="266" r:id="R5c8b0d59df0c467f"/>
-    <p:sldId xmlns:r="http://schemas.openxmlformats.org/officeDocument/2006/relationships" id="267" r:id="Rdc3aca56bd80478c"/>
-    <p:sldId xmlns:r="http://schemas.openxmlformats.org/officeDocument/2006/relationships" id="268" r:id="R241ef376bf1c43f6"/>
-    <p:sldId xmlns:r="http://schemas.openxmlformats.org/officeDocument/2006/relationships" id="269" r:id="R8007c4bce9824cf7"/>
+    <p:sldId xmlns:r="http://schemas.openxmlformats.org/officeDocument/2006/relationships" id="256" r:id="R67d377d24c4a46c5"/>
+    <p:sldId xmlns:r="http://schemas.openxmlformats.org/officeDocument/2006/relationships" id="257" r:id="R57d388cc5d7348ea"/>
+    <p:sldId xmlns:r="http://schemas.openxmlformats.org/officeDocument/2006/relationships" id="258" r:id="R6874ec18b93647af"/>
+    <p:sldId xmlns:r="http://schemas.openxmlformats.org/officeDocument/2006/relationships" id="259" r:id="Re5d6524ae56c4892"/>
+    <p:sldId xmlns:r="http://schemas.openxmlformats.org/officeDocument/2006/relationships" id="260" r:id="Racaa33e15d8a46b8"/>
+    <p:sldId xmlns:r="http://schemas.openxmlformats.org/officeDocument/2006/relationships" id="261" r:id="Rf772bcf2c3c64f2e"/>
+    <p:sldId xmlns:r="http://schemas.openxmlformats.org/officeDocument/2006/relationships" id="262" r:id="R1228e3d941964d65"/>
+    <p:sldId xmlns:r="http://schemas.openxmlformats.org/officeDocument/2006/relationships" id="263" r:id="Ra4b80999d6374d60"/>
+    <p:sldId xmlns:r="http://schemas.openxmlformats.org/officeDocument/2006/relationships" id="264" r:id="R3bb208c373ce4cc8"/>
+    <p:sldId xmlns:r="http://schemas.openxmlformats.org/officeDocument/2006/relationships" id="265" r:id="Rc0079dbb22444b13"/>
+    <p:sldId xmlns:r="http://schemas.openxmlformats.org/officeDocument/2006/relationships" id="266" r:id="Rb333aafb64ce4f4b"/>
+    <p:sldId xmlns:r="http://schemas.openxmlformats.org/officeDocument/2006/relationships" id="267" r:id="Rf022bfe8617b431c"/>
+    <p:sldId xmlns:r="http://schemas.openxmlformats.org/officeDocument/2006/relationships" id="268" r:id="R4836f034c74e4b80"/>
+    <p:sldId xmlns:r="http://schemas.openxmlformats.org/officeDocument/2006/relationships" id="269" r:id="R9932f5473614495f"/>
+    <p:sldId xmlns:r="http://schemas.openxmlformats.org/officeDocument/2006/relationships" id="270" r:id="Rc9be82d4d6ec416a"/>
+    <p:sldId xmlns:r="http://schemas.openxmlformats.org/officeDocument/2006/relationships" id="271" r:id="Rcaa56087912e4056"/>
+    <p:sldId xmlns:r="http://schemas.openxmlformats.org/officeDocument/2006/relationships" id="272" r:id="Ra81fc72b50914992"/>
+    <p:sldId xmlns:r="http://schemas.openxmlformats.org/officeDocument/2006/relationships" id="273" r:id="Rd27da6db26b849d7"/>
   </p:sldIdLst>
   <p:sldSz cx="12192000" cy="6858000"/>
   <p:notesSz cx="6858000" cy="9144000"/>
@@ -1005,6 +1009,416 @@
 </p:notes>
 </file>
 
+<file path=ppt/notesSlides/notesSlide15.xml><?xml version="1.0" encoding="utf-8"?>
+<p:notes xmlns:p="http://schemas.openxmlformats.org/presentationml/2006/main">
+  <p:cSld>
+    <p:spTree>
+      <p:nvGrpSpPr>
+        <p:cNvPr id="1" name=""/>
+        <p:cNvGrpSpPr/>
+        <p:nvPr/>
+      </p:nvGrpSpPr>
+      <p:grpSpPr>
+        <a:xfrm xmlns:a="http://schemas.openxmlformats.org/drawingml/2006/main"/>
+      </p:grpSpPr>
+      <p:sp>
+        <p:nvSpPr>
+          <p:cNvPr id="2" name="Slide Image Placeholder 1"/>
+          <p:cNvSpPr>
+            <a:spLocks xmlns:a="http://schemas.openxmlformats.org/drawingml/2006/main" noGrp="1"/>
+          </p:cNvSpPr>
+          <p:nvPr>
+            <p:ph type="sldImg" idx="0"/>
+          </p:nvPr>
+        </p:nvSpPr>
+        <p:spPr/>
+      </p:sp>
+      <p:sp>
+        <p:nvSpPr>
+          <p:cNvPr id="3" name="Notes Placeholder 2"/>
+          <p:cNvSpPr>
+            <a:spLocks xmlns:a="http://schemas.openxmlformats.org/drawingml/2006/main" noGrp="1"/>
+          </p:cNvSpPr>
+          <p:nvPr>
+            <p:ph type="body" idx="1"/>
+          </p:nvPr>
+        </p:nvSpPr>
+        <p:spPr/>
+        <p:txBody>
+          <a:bodyPr xmlns:a="http://schemas.openxmlformats.org/drawingml/2006/main"/>
+          <a:lstStyle xmlns:a="http://schemas.openxmlformats.org/drawingml/2006/main"/>
+          <a:p xmlns:a="http://schemas.openxmlformats.org/drawingml/2006/main">
+            <a:r>
+              <a:t>The source-described ranking and allocation rule was reproduced on the clean locally admitted window. The attempted refresh did not supply pre-2016 coverage, so the published 2008-2026 span remains an explicit STOP.</a:t>
+            </a:r>
+          </a:p>
+          <a:p xmlns:a="http://schemas.openxmlformats.org/drawingml/2006/main">
+            <a:r>
+              <a:t/>
+            </a:r>
+          </a:p>
+          <a:p xmlns:a="http://schemas.openxmlformats.org/drawingml/2006/main">
+            <a:r>
+              <a:t>[Sources]</a:t>
+            </a:r>
+          </a:p>
+          <a:p xmlns:a="http://schemas.openxmlformats.org/drawingml/2006/main">
+            <a:r>
+              <a:t>- C:/Users/Franc/OneDrive/Documents/Francis/Peltata Project/Time-Series-Modeling-Gen5/runs/research_workbench/literature_grounded/lit_mom_03_1_dual_momentum_mechanics_20260902/mom031_report.md</a:t>
+            </a:r>
+          </a:p>
+          <a:p xmlns:a="http://schemas.openxmlformats.org/drawingml/2006/main">
+            <a:r>
+              <a:t>- C:/Users/Franc/OneDrive/Documents/Francis/Peltata Project/Time-Series-Modeling-Gen5/literature_studies/R/gen5_lit_mom_03_1_dual_momentum_mechanics.R</a:t>
+            </a:r>
+          </a:p>
+          <a:p xmlns:a="http://schemas.openxmlformats.org/drawingml/2006/main">
+            <a:r>
+              <a:t>- C:/Users/Franc/OneDrive/Documents/Francis/Peltata Project/Time-Series-Modeling-Gen5/literature_studies/scripts/run_gen5_lit_mom_03_1_dual_momentum_mechanics.R</a:t>
+            </a:r>
+          </a:p>
+          <a:p xmlns:a="http://schemas.openxmlformats.org/drawingml/2006/main">
+            <a:r>
+              <a:t>- https://quantpedia.com/active-dual-momentum-gtaa-strategy/</a:t>
+            </a:r>
+          </a:p>
+          <a:p xmlns:a="http://schemas.openxmlformats.org/drawingml/2006/main">
+            <a:r>
+              <a:t>- Codex task conversation, 2026-09-02 (operator approval and mechanics readout)</a:t>
+            </a:r>
+          </a:p>
+        </p:txBody>
+      </p:sp>
+      <p:sp>
+        <p:nvSpPr>
+          <p:cNvPr id="4" name="Slide Number Placeholder 3"/>
+          <p:cNvSpPr>
+            <a:spLocks xmlns:a="http://schemas.openxmlformats.org/drawingml/2006/main" noGrp="1"/>
+          </p:cNvSpPr>
+          <p:nvPr>
+            <p:ph type="sldNum" idx="5"/>
+          </p:nvPr>
+        </p:nvSpPr>
+        <p:spPr/>
+        <p:txBody>
+          <a:bodyPr xmlns:a="http://schemas.openxmlformats.org/drawingml/2006/main"/>
+          <a:lstStyle xmlns:a="http://schemas.openxmlformats.org/drawingml/2006/main"/>
+          <a:p xmlns:a="http://schemas.openxmlformats.org/drawingml/2006/main"/>
+        </p:txBody>
+      </p:sp>
+    </p:spTree>
+  </p:cSld>
+  <p:clrMapOvr>
+    <a:masterClrMapping xmlns:a="http://schemas.openxmlformats.org/drawingml/2006/main"/>
+  </p:clrMapOvr>
+</p:notes>
+</file>
+
+<file path=ppt/notesSlides/notesSlide16.xml><?xml version="1.0" encoding="utf-8"?>
+<p:notes xmlns:p="http://schemas.openxmlformats.org/presentationml/2006/main">
+  <p:cSld>
+    <p:spTree>
+      <p:nvGrpSpPr>
+        <p:cNvPr id="1" name=""/>
+        <p:cNvGrpSpPr/>
+        <p:nvPr/>
+      </p:nvGrpSpPr>
+      <p:grpSpPr>
+        <a:xfrm xmlns:a="http://schemas.openxmlformats.org/drawingml/2006/main"/>
+      </p:grpSpPr>
+      <p:sp>
+        <p:nvSpPr>
+          <p:cNvPr id="2" name="Slide Image Placeholder 1"/>
+          <p:cNvSpPr>
+            <a:spLocks xmlns:a="http://schemas.openxmlformats.org/drawingml/2006/main" noGrp="1"/>
+          </p:cNvSpPr>
+          <p:nvPr>
+            <p:ph type="sldImg" idx="0"/>
+          </p:nvPr>
+        </p:nvSpPr>
+        <p:spPr/>
+      </p:sp>
+      <p:sp>
+        <p:nvSpPr>
+          <p:cNvPr id="3" name="Notes Placeholder 2"/>
+          <p:cNvSpPr>
+            <a:spLocks xmlns:a="http://schemas.openxmlformats.org/drawingml/2006/main" noGrp="1"/>
+          </p:cNvSpPr>
+          <p:nvPr>
+            <p:ph type="body" idx="1"/>
+          </p:nvPr>
+        </p:nvSpPr>
+        <p:spPr/>
+        <p:txBody>
+          <a:bodyPr xmlns:a="http://schemas.openxmlformats.org/drawingml/2006/main"/>
+          <a:lstStyle xmlns:a="http://schemas.openxmlformats.org/drawingml/2006/main"/>
+          <a:p xmlns:a="http://schemas.openxmlformats.org/drawingml/2006/main">
+            <a:r>
+              <a:t>The chart displays target allocations only. It is not an equity curve and contains no return outcome. Cash appears when one or more top-ranked assets have non-positive momentum in their sleeve.</a:t>
+            </a:r>
+          </a:p>
+          <a:p xmlns:a="http://schemas.openxmlformats.org/drawingml/2006/main">
+            <a:r>
+              <a:t/>
+            </a:r>
+          </a:p>
+          <a:p xmlns:a="http://schemas.openxmlformats.org/drawingml/2006/main">
+            <a:r>
+              <a:t>[Sources]</a:t>
+            </a:r>
+          </a:p>
+          <a:p xmlns:a="http://schemas.openxmlformats.org/drawingml/2006/main">
+            <a:r>
+              <a:t>- C:/Users/Franc/OneDrive/Documents/Francis/Peltata Project/Time-Series-Modeling-Gen5/runs/research_workbench/literature_grounded/lit_mom_03_1_dual_momentum_mechanics_20260902/mom031_report.md</a:t>
+            </a:r>
+          </a:p>
+          <a:p xmlns:a="http://schemas.openxmlformats.org/drawingml/2006/main">
+            <a:r>
+              <a:t>- C:/Users/Franc/OneDrive/Documents/Francis/Peltata Project/Time-Series-Modeling-Gen5/runs/research_workbench/literature_grounded/lit_mom_03_1_dual_momentum_mechanics_20260902/mom031_mechanics_summary.csv</a:t>
+            </a:r>
+          </a:p>
+          <a:p xmlns:a="http://schemas.openxmlformats.org/drawingml/2006/main">
+            <a:r>
+              <a:t>- C:/Users/Franc/OneDrive/Documents/Francis/Peltata Project/Time-Series-Modeling-Gen5/runs/research_workbench/literature_grounded/lit_mom_03_1_dual_momentum_mechanics_20260902/visuals/mom031_allocation_timeline.png</a:t>
+            </a:r>
+          </a:p>
+          <a:p xmlns:a="http://schemas.openxmlformats.org/drawingml/2006/main">
+            <a:r>
+              <a:t>- Codex task conversation, 2026-09-02 (operator approval and mechanics readout)</a:t>
+            </a:r>
+          </a:p>
+        </p:txBody>
+      </p:sp>
+      <p:sp>
+        <p:nvSpPr>
+          <p:cNvPr id="4" name="Slide Number Placeholder 3"/>
+          <p:cNvSpPr>
+            <a:spLocks xmlns:a="http://schemas.openxmlformats.org/drawingml/2006/main" noGrp="1"/>
+          </p:cNvSpPr>
+          <p:nvPr>
+            <p:ph type="sldNum" idx="5"/>
+          </p:nvPr>
+        </p:nvSpPr>
+        <p:spPr/>
+        <p:txBody>
+          <a:bodyPr xmlns:a="http://schemas.openxmlformats.org/drawingml/2006/main"/>
+          <a:lstStyle xmlns:a="http://schemas.openxmlformats.org/drawingml/2006/main"/>
+          <a:p xmlns:a="http://schemas.openxmlformats.org/drawingml/2006/main"/>
+        </p:txBody>
+      </p:sp>
+    </p:spTree>
+  </p:cSld>
+  <p:clrMapOvr>
+    <a:masterClrMapping xmlns:a="http://schemas.openxmlformats.org/drawingml/2006/main"/>
+  </p:clrMapOvr>
+</p:notes>
+</file>
+
+<file path=ppt/notesSlides/notesSlide17.xml><?xml version="1.0" encoding="utf-8"?>
+<p:notes xmlns:p="http://schemas.openxmlformats.org/presentationml/2006/main">
+  <p:cSld>
+    <p:spTree>
+      <p:nvGrpSpPr>
+        <p:cNvPr id="1" name=""/>
+        <p:cNvGrpSpPr/>
+        <p:nvPr/>
+      </p:nvGrpSpPr>
+      <p:grpSpPr>
+        <a:xfrm xmlns:a="http://schemas.openxmlformats.org/drawingml/2006/main"/>
+      </p:grpSpPr>
+      <p:sp>
+        <p:nvSpPr>
+          <p:cNvPr id="2" name="Slide Image Placeholder 1"/>
+          <p:cNvSpPr>
+            <a:spLocks xmlns:a="http://schemas.openxmlformats.org/drawingml/2006/main" noGrp="1"/>
+          </p:cNvSpPr>
+          <p:nvPr>
+            <p:ph type="sldImg" idx="0"/>
+          </p:nvPr>
+        </p:nvSpPr>
+        <p:spPr/>
+      </p:sp>
+      <p:sp>
+        <p:nvSpPr>
+          <p:cNvPr id="3" name="Notes Placeholder 2"/>
+          <p:cNvSpPr>
+            <a:spLocks xmlns:a="http://schemas.openxmlformats.org/drawingml/2006/main" noGrp="1"/>
+          </p:cNvSpPr>
+          <p:nvPr>
+            <p:ph type="body" idx="1"/>
+          </p:nvPr>
+        </p:nvSpPr>
+        <p:spPr/>
+        <p:txBody>
+          <a:bodyPr xmlns:a="http://schemas.openxmlformats.org/drawingml/2006/main"/>
+          <a:lstStyle xmlns:a="http://schemas.openxmlformats.org/drawingml/2006/main"/>
+          <a:p xmlns:a="http://schemas.openxmlformats.org/drawingml/2006/main">
+            <a:r>
+              <a:t>Representative dates were frozen before rendering the slide. The overlap count is descriptive of allocation mechanics and does not establish that overlap helped returns.</a:t>
+            </a:r>
+          </a:p>
+          <a:p xmlns:a="http://schemas.openxmlformats.org/drawingml/2006/main">
+            <a:r>
+              <a:t/>
+            </a:r>
+          </a:p>
+          <a:p xmlns:a="http://schemas.openxmlformats.org/drawingml/2006/main">
+            <a:r>
+              <a:t>[Sources]</a:t>
+            </a:r>
+          </a:p>
+          <a:p xmlns:a="http://schemas.openxmlformats.org/drawingml/2006/main">
+            <a:r>
+              <a:t>- C:/Users/Franc/OneDrive/Documents/Francis/Peltata Project/Time-Series-Modeling-Gen5/runs/research_workbench/literature_grounded/lit_mom_03_1_dual_momentum_mechanics_20260902/mom031_report.md</a:t>
+            </a:r>
+          </a:p>
+          <a:p xmlns:a="http://schemas.openxmlformats.org/drawingml/2006/main">
+            <a:r>
+              <a:t>- C:/Users/Franc/OneDrive/Documents/Francis/Peltata Project/Time-Series-Modeling-Gen5/runs/research_workbench/literature_grounded/lit_mom_03_1_dual_momentum_mechanics_20260902/mom031_representative_allocations.csv</a:t>
+            </a:r>
+          </a:p>
+          <a:p xmlns:a="http://schemas.openxmlformats.org/drawingml/2006/main">
+            <a:r>
+              <a:t>- C:/Users/Franc/OneDrive/Documents/Francis/Peltata Project/Time-Series-Modeling-Gen5/runs/research_workbench/literature_grounded/lit_mom_03_1_dual_momentum_mechanics_20260902/mom031_weekly_allocation_tape.csv</a:t>
+            </a:r>
+          </a:p>
+          <a:p xmlns:a="http://schemas.openxmlformats.org/drawingml/2006/main">
+            <a:r>
+              <a:t>- Codex task conversation, 2026-09-02 (operator approval and mechanics readout)</a:t>
+            </a:r>
+          </a:p>
+        </p:txBody>
+      </p:sp>
+      <p:sp>
+        <p:nvSpPr>
+          <p:cNvPr id="4" name="Slide Number Placeholder 3"/>
+          <p:cNvSpPr>
+            <a:spLocks xmlns:a="http://schemas.openxmlformats.org/drawingml/2006/main" noGrp="1"/>
+          </p:cNvSpPr>
+          <p:nvPr>
+            <p:ph type="sldNum" idx="5"/>
+          </p:nvPr>
+        </p:nvSpPr>
+        <p:spPr/>
+        <p:txBody>
+          <a:bodyPr xmlns:a="http://schemas.openxmlformats.org/drawingml/2006/main"/>
+          <a:lstStyle xmlns:a="http://schemas.openxmlformats.org/drawingml/2006/main"/>
+          <a:p xmlns:a="http://schemas.openxmlformats.org/drawingml/2006/main"/>
+        </p:txBody>
+      </p:sp>
+    </p:spTree>
+  </p:cSld>
+  <p:clrMapOvr>
+    <a:masterClrMapping xmlns:a="http://schemas.openxmlformats.org/drawingml/2006/main"/>
+  </p:clrMapOvr>
+</p:notes>
+</file>
+
+<file path=ppt/notesSlides/notesSlide18.xml><?xml version="1.0" encoding="utf-8"?>
+<p:notes xmlns:p="http://schemas.openxmlformats.org/presentationml/2006/main">
+  <p:cSld>
+    <p:spTree>
+      <p:nvGrpSpPr>
+        <p:cNvPr id="1" name=""/>
+        <p:cNvGrpSpPr/>
+        <p:nvPr/>
+      </p:nvGrpSpPr>
+      <p:grpSpPr>
+        <a:xfrm xmlns:a="http://schemas.openxmlformats.org/drawingml/2006/main"/>
+      </p:grpSpPr>
+      <p:sp>
+        <p:nvSpPr>
+          <p:cNvPr id="2" name="Slide Image Placeholder 1"/>
+          <p:cNvSpPr>
+            <a:spLocks xmlns:a="http://schemas.openxmlformats.org/drawingml/2006/main" noGrp="1"/>
+          </p:cNvSpPr>
+          <p:nvPr>
+            <p:ph type="sldImg" idx="0"/>
+          </p:nvPr>
+        </p:nvSpPr>
+        <p:spPr/>
+      </p:sp>
+      <p:sp>
+        <p:nvSpPr>
+          <p:cNvPr id="3" name="Notes Placeholder 2"/>
+          <p:cNvSpPr>
+            <a:spLocks xmlns:a="http://schemas.openxmlformats.org/drawingml/2006/main" noGrp="1"/>
+          </p:cNvSpPr>
+          <p:nvPr>
+            <p:ph type="body" idx="1"/>
+          </p:nvPr>
+        </p:nvSpPr>
+        <p:spPr/>
+        <p:txBody>
+          <a:bodyPr xmlns:a="http://schemas.openxmlformats.org/drawingml/2006/main"/>
+          <a:lstStyle xmlns:a="http://schemas.openxmlformats.org/drawingml/2006/main"/>
+          <a:p xmlns:a="http://schemas.openxmlformats.org/drawingml/2006/main">
+            <a:r>
+              <a:t>This slide closes the mechanics-only slice. The next performance gate requires explicit operator authorization under the Gen5 research contract.</a:t>
+            </a:r>
+          </a:p>
+          <a:p xmlns:a="http://schemas.openxmlformats.org/drawingml/2006/main">
+            <a:r>
+              <a:t/>
+            </a:r>
+          </a:p>
+          <a:p xmlns:a="http://schemas.openxmlformats.org/drawingml/2006/main">
+            <a:r>
+              <a:t>[Sources]</a:t>
+            </a:r>
+          </a:p>
+          <a:p xmlns:a="http://schemas.openxmlformats.org/drawingml/2006/main">
+            <a:r>
+              <a:t>- C:/Users/Franc/OneDrive/Documents/Francis/Peltata Project/Time-Series-Modeling-Gen5/runs/research_workbench/literature_grounded/lit_mom_03_1_dual_momentum_mechanics_20260902/mom031_report.md</a:t>
+            </a:r>
+          </a:p>
+          <a:p xmlns:a="http://schemas.openxmlformats.org/drawingml/2006/main">
+            <a:r>
+              <a:t>- C:/Users/Franc/OneDrive/Documents/Francis/Peltata Project/Time-Series-Modeling-Gen5/literature_studies/R/gen5_lit_mom_03_1_dual_momentum_mechanics.R</a:t>
+            </a:r>
+          </a:p>
+          <a:p xmlns:a="http://schemas.openxmlformats.org/drawingml/2006/main">
+            <a:r>
+              <a:t>- C:/Users/Franc/OneDrive/Documents/Francis/Peltata Project/Time-Series-Modeling-Gen5/literature_studies/scripts/run_gen5_lit_mom_03_1_dual_momentum_mechanics.R</a:t>
+            </a:r>
+          </a:p>
+          <a:p xmlns:a="http://schemas.openxmlformats.org/drawingml/2006/main">
+            <a:r>
+              <a:t>- https://quantpedia.com/active-dual-momentum-gtaa-strategy/</a:t>
+            </a:r>
+          </a:p>
+          <a:p xmlns:a="http://schemas.openxmlformats.org/drawingml/2006/main">
+            <a:r>
+              <a:t>- Codex task conversation, 2026-09-02 (operator approval and mechanics readout)</a:t>
+            </a:r>
+          </a:p>
+        </p:txBody>
+      </p:sp>
+      <p:sp>
+        <p:nvSpPr>
+          <p:cNvPr id="4" name="Slide Number Placeholder 3"/>
+          <p:cNvSpPr>
+            <a:spLocks xmlns:a="http://schemas.openxmlformats.org/drawingml/2006/main" noGrp="1"/>
+          </p:cNvSpPr>
+          <p:nvPr>
+            <p:ph type="sldNum" idx="5"/>
+          </p:nvPr>
+        </p:nvSpPr>
+        <p:spPr/>
+        <p:txBody>
+          <a:bodyPr xmlns:a="http://schemas.openxmlformats.org/drawingml/2006/main"/>
+          <a:lstStyle xmlns:a="http://schemas.openxmlformats.org/drawingml/2006/main"/>
+          <a:p xmlns:a="http://schemas.openxmlformats.org/drawingml/2006/main"/>
+        </p:txBody>
+      </p:sp>
+    </p:spTree>
+  </p:cSld>
+  <p:clrMapOvr>
+    <a:masterClrMapping xmlns:a="http://schemas.openxmlformats.org/drawingml/2006/main"/>
+  </p:clrMapOvr>
+</p:notes>
+</file>
+
 <file path=ppt/notesSlides/notesSlide2.xml><?xml version="1.0" encoding="utf-8"?>
 <p:notes xmlns:p="http://schemas.openxmlformats.org/presentationml/2006/main">
   <p:cSld>
@@ -1823,7 +2237,7 @@
   </p:cSld>
   <p:clrMap bg1="lt1" tx1="dk1" bg2="lt2" tx2="dk2" accent1="accent1" accent2="accent2" accent3="accent3" accent4="accent4" accent5="accent5" accent6="accent6" hlink="hlink" folHlink="folHlink"/>
   <p:sldLayoutIdLst>
-    <p:sldLayoutId xmlns:r="http://schemas.openxmlformats.org/officeDocument/2006/relationships" id="2147483649" r:id="Rf63350cd78af4eb0"/>
+    <p:sldLayoutId xmlns:r="http://schemas.openxmlformats.org/officeDocument/2006/relationships" id="2147483649" r:id="R0b1eab2b973f459e"/>
   </p:sldLayoutIdLst>
   <p:txStyles>
     <p:titleStyle>
@@ -2402,6 +2816,7 @@
           <a:lstStyle xmlns:a="http://schemas.openxmlformats.org/drawingml/2006/main"/>
           <a:p xmlns:a="http://schemas.openxmlformats.org/drawingml/2006/main">
             <a:pPr algn="l">
+              <a:buNone/>
               <a:defRPr sz="1275" b="1">
                 <a:solidFill>
                   <a:srgbClr val="3D8DFF"/>
@@ -2458,6 +2873,7 @@
           <a:lstStyle xmlns:a="http://schemas.openxmlformats.org/drawingml/2006/main"/>
           <a:p xmlns:a="http://schemas.openxmlformats.org/drawingml/2006/main">
             <a:pPr algn="l">
+              <a:buNone/>
               <a:defRPr sz="5100" b="1">
                 <a:solidFill>
                   <a:srgbClr val="101820"/>
@@ -2514,6 +2930,7 @@
           <a:lstStyle xmlns:a="http://schemas.openxmlformats.org/drawingml/2006/main"/>
           <a:p xmlns:a="http://schemas.openxmlformats.org/drawingml/2006/main">
             <a:pPr algn="l">
+              <a:buNone/>
               <a:defRPr sz="2325" b="0">
                 <a:solidFill>
                   <a:srgbClr val="52616B"/>
@@ -2603,6 +3020,7 @@
           <a:lstStyle xmlns:a="http://schemas.openxmlformats.org/drawingml/2006/main"/>
           <a:p xmlns:a="http://schemas.openxmlformats.org/drawingml/2006/main">
             <a:pPr algn="l">
+              <a:buNone/>
               <a:defRPr sz="1875" b="1">
                 <a:solidFill>
                   <a:srgbClr val="3D8DFF"/>
@@ -2659,6 +3077,7 @@
           <a:lstStyle xmlns:a="http://schemas.openxmlformats.org/drawingml/2006/main"/>
           <a:p xmlns:a="http://schemas.openxmlformats.org/drawingml/2006/main">
             <a:pPr algn="l">
+              <a:buNone/>
               <a:defRPr sz="1275" b="1">
                 <a:solidFill>
                   <a:srgbClr val="52616B"/>
@@ -2715,6 +3134,7 @@
           <a:lstStyle xmlns:a="http://schemas.openxmlformats.org/drawingml/2006/main"/>
           <a:p xmlns:a="http://schemas.openxmlformats.org/drawingml/2006/main">
             <a:pPr algn="l">
+              <a:buNone/>
               <a:defRPr sz="1950" b="1">
                 <a:solidFill>
                   <a:srgbClr val="101820"/>
@@ -2771,6 +3191,7 @@
           <a:lstStyle xmlns:a="http://schemas.openxmlformats.org/drawingml/2006/main"/>
           <a:p xmlns:a="http://schemas.openxmlformats.org/drawingml/2006/main">
             <a:pPr algn="l">
+              <a:buNone/>
               <a:defRPr sz="1275" b="1">
                 <a:solidFill>
                   <a:srgbClr val="52616B"/>
@@ -2827,6 +3248,7 @@
           <a:lstStyle xmlns:a="http://schemas.openxmlformats.org/drawingml/2006/main"/>
           <a:p xmlns:a="http://schemas.openxmlformats.org/drawingml/2006/main">
             <a:pPr algn="l">
+              <a:buNone/>
               <a:defRPr sz="1950" b="1">
                 <a:solidFill>
                   <a:srgbClr val="C8553D"/>
@@ -2850,6 +3272,7 @@
           </a:p>
           <a:p xmlns:a="http://schemas.openxmlformats.org/drawingml/2006/main">
             <a:pPr algn="l">
+              <a:buNone/>
               <a:defRPr sz="1950" b="1">
                 <a:solidFill>
                   <a:srgbClr val="C8553D"/>
@@ -2906,6 +3329,7 @@
           <a:lstStyle xmlns:a="http://schemas.openxmlformats.org/drawingml/2006/main"/>
           <a:p xmlns:a="http://schemas.openxmlformats.org/drawingml/2006/main">
             <a:pPr algn="l">
+              <a:buNone/>
               <a:defRPr sz="1425" b="0">
                 <a:solidFill>
                   <a:srgbClr val="52616B"/>
@@ -2962,6 +3386,7 @@
           <a:lstStyle xmlns:a="http://schemas.openxmlformats.org/drawingml/2006/main"/>
           <a:p xmlns:a="http://schemas.openxmlformats.org/drawingml/2006/main">
             <a:pPr algn="r">
+              <a:buNone/>
               <a:defRPr sz="1200" b="0">
                 <a:solidFill>
                   <a:srgbClr val="52616B"/>
@@ -3047,6 +3472,7 @@
           <a:lstStyle xmlns:a="http://schemas.openxmlformats.org/drawingml/2006/main"/>
           <a:p xmlns:a="http://schemas.openxmlformats.org/drawingml/2006/main">
             <a:pPr algn="l">
+              <a:buNone/>
               <a:defRPr sz="1200" b="1">
                 <a:solidFill>
                   <a:srgbClr val="3D8DFF"/>
@@ -3103,6 +3529,7 @@
           <a:lstStyle xmlns:a="http://schemas.openxmlformats.org/drawingml/2006/main"/>
           <a:p xmlns:a="http://schemas.openxmlformats.org/drawingml/2006/main">
             <a:pPr algn="l">
+              <a:buNone/>
               <a:defRPr sz="2700" b="1">
                 <a:solidFill>
                   <a:srgbClr val="101820"/>
@@ -3190,6 +3617,7 @@
           <a:lstStyle xmlns:a="http://schemas.openxmlformats.org/drawingml/2006/main"/>
           <a:p xmlns:a="http://schemas.openxmlformats.org/drawingml/2006/main">
             <a:pPr algn="r">
+              <a:buNone/>
               <a:defRPr sz="1200" b="0">
                 <a:solidFill>
                   <a:srgbClr val="52616B"/>
@@ -3310,6 +3738,7 @@
           <a:lstStyle xmlns:a="http://schemas.openxmlformats.org/drawingml/2006/main"/>
           <a:p xmlns:a="http://schemas.openxmlformats.org/drawingml/2006/main">
             <a:pPr algn="l">
+              <a:buNone/>
               <a:defRPr sz="1350" b="1">
                 <a:solidFill>
                   <a:srgbClr val="C8553D"/>
@@ -3366,6 +3795,7 @@
           <a:lstStyle xmlns:a="http://schemas.openxmlformats.org/drawingml/2006/main"/>
           <a:p xmlns:a="http://schemas.openxmlformats.org/drawingml/2006/main">
             <a:pPr algn="l">
+              <a:buNone/>
               <a:defRPr sz="1500" b="1">
                 <a:solidFill>
                   <a:srgbClr val="101820"/>
@@ -3455,6 +3885,7 @@
           <a:lstStyle xmlns:a="http://schemas.openxmlformats.org/drawingml/2006/main"/>
           <a:p xmlns:a="http://schemas.openxmlformats.org/drawingml/2006/main">
             <a:pPr algn="l">
+              <a:buNone/>
               <a:defRPr sz="1350" b="1">
                 <a:solidFill>
                   <a:srgbClr val="C8553D"/>
@@ -3511,6 +3942,7 @@
           <a:lstStyle xmlns:a="http://schemas.openxmlformats.org/drawingml/2006/main"/>
           <a:p xmlns:a="http://schemas.openxmlformats.org/drawingml/2006/main">
             <a:pPr algn="l">
+              <a:buNone/>
               <a:defRPr sz="1500" b="1">
                 <a:solidFill>
                   <a:srgbClr val="101820"/>
@@ -3600,6 +4032,7 @@
           <a:lstStyle xmlns:a="http://schemas.openxmlformats.org/drawingml/2006/main"/>
           <a:p xmlns:a="http://schemas.openxmlformats.org/drawingml/2006/main">
             <a:pPr algn="l">
+              <a:buNone/>
               <a:defRPr sz="1350" b="1">
                 <a:solidFill>
                   <a:srgbClr val="3D8DFF"/>
@@ -3656,6 +4089,7 @@
           <a:lstStyle xmlns:a="http://schemas.openxmlformats.org/drawingml/2006/main"/>
           <a:p xmlns:a="http://schemas.openxmlformats.org/drawingml/2006/main">
             <a:pPr algn="l">
+              <a:buNone/>
               <a:defRPr sz="1500" b="1">
                 <a:solidFill>
                   <a:srgbClr val="101820"/>
@@ -3745,6 +4179,7 @@
           <a:lstStyle xmlns:a="http://schemas.openxmlformats.org/drawingml/2006/main"/>
           <a:p xmlns:a="http://schemas.openxmlformats.org/drawingml/2006/main">
             <a:pPr algn="l">
+              <a:buNone/>
               <a:defRPr sz="1350" b="1">
                 <a:solidFill>
                   <a:srgbClr val="3D8DFF"/>
@@ -3801,6 +4236,7 @@
           <a:lstStyle xmlns:a="http://schemas.openxmlformats.org/drawingml/2006/main"/>
           <a:p xmlns:a="http://schemas.openxmlformats.org/drawingml/2006/main">
             <a:pPr algn="l">
+              <a:buNone/>
               <a:defRPr sz="1500" b="1">
                 <a:solidFill>
                   <a:srgbClr val="101820"/>
@@ -3890,6 +4326,7 @@
           <a:lstStyle xmlns:a="http://schemas.openxmlformats.org/drawingml/2006/main"/>
           <a:p xmlns:a="http://schemas.openxmlformats.org/drawingml/2006/main">
             <a:pPr algn="l">
+              <a:buNone/>
               <a:defRPr sz="1350" b="1">
                 <a:solidFill>
                   <a:srgbClr val="3D8DFF"/>
@@ -3946,6 +4383,7 @@
           <a:lstStyle xmlns:a="http://schemas.openxmlformats.org/drawingml/2006/main"/>
           <a:p xmlns:a="http://schemas.openxmlformats.org/drawingml/2006/main">
             <a:pPr algn="l">
+              <a:buNone/>
               <a:defRPr sz="1500" b="1">
                 <a:solidFill>
                   <a:srgbClr val="101820"/>
@@ -4035,6 +4473,7 @@
           <a:lstStyle xmlns:a="http://schemas.openxmlformats.org/drawingml/2006/main"/>
           <a:p xmlns:a="http://schemas.openxmlformats.org/drawingml/2006/main">
             <a:pPr algn="ctr">
+              <a:buNone/>
               <a:defRPr sz="1875" b="1">
                 <a:solidFill>
                   <a:srgbClr val="C8553D"/>
@@ -4120,6 +4559,7 @@
           <a:lstStyle xmlns:a="http://schemas.openxmlformats.org/drawingml/2006/main"/>
           <a:p xmlns:a="http://schemas.openxmlformats.org/drawingml/2006/main">
             <a:pPr algn="l">
+              <a:buNone/>
               <a:defRPr sz="1200" b="1">
                 <a:solidFill>
                   <a:srgbClr val="3D8DFF"/>
@@ -4176,6 +4616,7 @@
           <a:lstStyle xmlns:a="http://schemas.openxmlformats.org/drawingml/2006/main"/>
           <a:p xmlns:a="http://schemas.openxmlformats.org/drawingml/2006/main">
             <a:pPr algn="l">
+              <a:buNone/>
               <a:defRPr sz="2700" b="1">
                 <a:solidFill>
                   <a:srgbClr val="101820"/>
@@ -4263,6 +4704,7 @@
           <a:lstStyle xmlns:a="http://schemas.openxmlformats.org/drawingml/2006/main"/>
           <a:p xmlns:a="http://schemas.openxmlformats.org/drawingml/2006/main">
             <a:pPr algn="r">
+              <a:buNone/>
               <a:defRPr sz="1200" b="0">
                 <a:solidFill>
                   <a:srgbClr val="52616B"/>
@@ -4319,6 +4761,7 @@
           <a:lstStyle xmlns:a="http://schemas.openxmlformats.org/drawingml/2006/main"/>
           <a:p xmlns:a="http://schemas.openxmlformats.org/drawingml/2006/main">
             <a:pPr algn="l">
+              <a:buNone/>
               <a:defRPr sz="1275" b="1">
                 <a:solidFill>
                   <a:srgbClr val="2E7D5B"/>
@@ -4441,6 +4884,7 @@
           <a:lstStyle xmlns:a="http://schemas.openxmlformats.org/drawingml/2006/main"/>
           <a:p xmlns:a="http://schemas.openxmlformats.org/drawingml/2006/main">
             <a:pPr algn="l">
+              <a:buNone/>
               <a:defRPr sz="1725" b="0">
                 <a:solidFill>
                   <a:srgbClr val="101820"/>
@@ -4530,6 +4974,7 @@
           <a:lstStyle xmlns:a="http://schemas.openxmlformats.org/drawingml/2006/main"/>
           <a:p xmlns:a="http://schemas.openxmlformats.org/drawingml/2006/main">
             <a:pPr algn="l">
+              <a:buNone/>
               <a:defRPr sz="1725" b="0">
                 <a:solidFill>
                   <a:srgbClr val="101820"/>
@@ -4619,6 +5064,7 @@
           <a:lstStyle xmlns:a="http://schemas.openxmlformats.org/drawingml/2006/main"/>
           <a:p xmlns:a="http://schemas.openxmlformats.org/drawingml/2006/main">
             <a:pPr algn="l">
+              <a:buNone/>
               <a:defRPr sz="1725" b="0">
                 <a:solidFill>
                   <a:srgbClr val="101820"/>
@@ -4708,6 +5154,7 @@
           <a:lstStyle xmlns:a="http://schemas.openxmlformats.org/drawingml/2006/main"/>
           <a:p xmlns:a="http://schemas.openxmlformats.org/drawingml/2006/main">
             <a:pPr algn="l">
+              <a:buNone/>
               <a:defRPr sz="1725" b="0">
                 <a:solidFill>
                   <a:srgbClr val="101820"/>
@@ -4797,6 +5244,7 @@
           <a:lstStyle xmlns:a="http://schemas.openxmlformats.org/drawingml/2006/main"/>
           <a:p xmlns:a="http://schemas.openxmlformats.org/drawingml/2006/main">
             <a:pPr algn="l">
+              <a:buNone/>
               <a:defRPr sz="1725" b="0">
                 <a:solidFill>
                   <a:srgbClr val="101820"/>
@@ -4853,6 +5301,7 @@
           <a:lstStyle xmlns:a="http://schemas.openxmlformats.org/drawingml/2006/main"/>
           <a:p xmlns:a="http://schemas.openxmlformats.org/drawingml/2006/main">
             <a:pPr algn="l">
+              <a:buNone/>
               <a:defRPr sz="1275" b="1">
                 <a:solidFill>
                   <a:srgbClr val="C8553D"/>
@@ -4975,6 +5424,7 @@
           <a:lstStyle xmlns:a="http://schemas.openxmlformats.org/drawingml/2006/main"/>
           <a:p xmlns:a="http://schemas.openxmlformats.org/drawingml/2006/main">
             <a:pPr algn="l">
+              <a:buNone/>
               <a:defRPr sz="1725" b="0">
                 <a:solidFill>
                   <a:srgbClr val="101820"/>
@@ -5064,6 +5514,7 @@
           <a:lstStyle xmlns:a="http://schemas.openxmlformats.org/drawingml/2006/main"/>
           <a:p xmlns:a="http://schemas.openxmlformats.org/drawingml/2006/main">
             <a:pPr algn="l">
+              <a:buNone/>
               <a:defRPr sz="1725" b="0">
                 <a:solidFill>
                   <a:srgbClr val="101820"/>
@@ -5153,6 +5604,7 @@
           <a:lstStyle xmlns:a="http://schemas.openxmlformats.org/drawingml/2006/main"/>
           <a:p xmlns:a="http://schemas.openxmlformats.org/drawingml/2006/main">
             <a:pPr algn="l">
+              <a:buNone/>
               <a:defRPr sz="1725" b="0">
                 <a:solidFill>
                   <a:srgbClr val="101820"/>
@@ -5242,6 +5694,7 @@
           <a:lstStyle xmlns:a="http://schemas.openxmlformats.org/drawingml/2006/main"/>
           <a:p xmlns:a="http://schemas.openxmlformats.org/drawingml/2006/main">
             <a:pPr algn="l">
+              <a:buNone/>
               <a:defRPr sz="1725" b="0">
                 <a:solidFill>
                   <a:srgbClr val="101820"/>
@@ -5331,6 +5784,7 @@
           <a:lstStyle xmlns:a="http://schemas.openxmlformats.org/drawingml/2006/main"/>
           <a:p xmlns:a="http://schemas.openxmlformats.org/drawingml/2006/main">
             <a:pPr algn="l">
+              <a:buNone/>
               <a:defRPr sz="1725" b="0">
                 <a:solidFill>
                   <a:srgbClr val="101820"/>
@@ -5416,6 +5870,7 @@
           <a:lstStyle xmlns:a="http://schemas.openxmlformats.org/drawingml/2006/main"/>
           <a:p xmlns:a="http://schemas.openxmlformats.org/drawingml/2006/main">
             <a:pPr algn="l">
+              <a:buNone/>
               <a:defRPr sz="1200" b="1">
                 <a:solidFill>
                   <a:srgbClr val="3D8DFF"/>
@@ -5472,6 +5927,7 @@
           <a:lstStyle xmlns:a="http://schemas.openxmlformats.org/drawingml/2006/main"/>
           <a:p xmlns:a="http://schemas.openxmlformats.org/drawingml/2006/main">
             <a:pPr algn="l">
+              <a:buNone/>
               <a:defRPr sz="2700" b="1">
                 <a:solidFill>
                   <a:srgbClr val="101820"/>
@@ -5559,6 +6015,7 @@
           <a:lstStyle xmlns:a="http://schemas.openxmlformats.org/drawingml/2006/main"/>
           <a:p xmlns:a="http://schemas.openxmlformats.org/drawingml/2006/main">
             <a:pPr algn="r">
+              <a:buNone/>
               <a:defRPr sz="1200" b="0">
                 <a:solidFill>
                   <a:srgbClr val="52616B"/>
@@ -5648,6 +6105,7 @@
           <a:lstStyle xmlns:a="http://schemas.openxmlformats.org/drawingml/2006/main"/>
           <a:p xmlns:a="http://schemas.openxmlformats.org/drawingml/2006/main">
             <a:pPr algn="l">
+              <a:buNone/>
               <a:defRPr sz="2550" b="1">
                 <a:solidFill>
                   <a:srgbClr val="3D8DFF"/>
@@ -5704,6 +6162,7 @@
           <a:lstStyle xmlns:a="http://schemas.openxmlformats.org/drawingml/2006/main"/>
           <a:p xmlns:a="http://schemas.openxmlformats.org/drawingml/2006/main">
             <a:pPr algn="l">
+              <a:buNone/>
               <a:defRPr sz="2175" b="1">
                 <a:solidFill>
                   <a:srgbClr val="101820"/>
@@ -5760,6 +6219,7 @@
           <a:lstStyle xmlns:a="http://schemas.openxmlformats.org/drawingml/2006/main"/>
           <a:p xmlns:a="http://schemas.openxmlformats.org/drawingml/2006/main">
             <a:pPr algn="l">
+              <a:buNone/>
               <a:defRPr sz="1575" b="0">
                 <a:solidFill>
                   <a:srgbClr val="52616B"/>
@@ -5849,6 +6309,7 @@
           <a:lstStyle xmlns:a="http://schemas.openxmlformats.org/drawingml/2006/main"/>
           <a:p xmlns:a="http://schemas.openxmlformats.org/drawingml/2006/main">
             <a:pPr algn="l">
+              <a:buNone/>
               <a:defRPr sz="2550" b="1">
                 <a:solidFill>
                   <a:srgbClr val="3D8DFF"/>
@@ -5905,6 +6366,7 @@
           <a:lstStyle xmlns:a="http://schemas.openxmlformats.org/drawingml/2006/main"/>
           <a:p xmlns:a="http://schemas.openxmlformats.org/drawingml/2006/main">
             <a:pPr algn="l">
+              <a:buNone/>
               <a:defRPr sz="2175" b="1">
                 <a:solidFill>
                   <a:srgbClr val="101820"/>
@@ -5961,6 +6423,7 @@
           <a:lstStyle xmlns:a="http://schemas.openxmlformats.org/drawingml/2006/main"/>
           <a:p xmlns:a="http://schemas.openxmlformats.org/drawingml/2006/main">
             <a:pPr algn="l">
+              <a:buNone/>
               <a:defRPr sz="1575" b="0">
                 <a:solidFill>
                   <a:srgbClr val="52616B"/>
@@ -6050,6 +6513,7 @@
           <a:lstStyle xmlns:a="http://schemas.openxmlformats.org/drawingml/2006/main"/>
           <a:p xmlns:a="http://schemas.openxmlformats.org/drawingml/2006/main">
             <a:pPr algn="l">
+              <a:buNone/>
               <a:defRPr sz="2550" b="1">
                 <a:solidFill>
                   <a:srgbClr val="3D8DFF"/>
@@ -6106,6 +6570,7 @@
           <a:lstStyle xmlns:a="http://schemas.openxmlformats.org/drawingml/2006/main"/>
           <a:p xmlns:a="http://schemas.openxmlformats.org/drawingml/2006/main">
             <a:pPr algn="l">
+              <a:buNone/>
               <a:defRPr sz="2175" b="1">
                 <a:solidFill>
                   <a:srgbClr val="101820"/>
@@ -6162,6 +6627,7 @@
           <a:lstStyle xmlns:a="http://schemas.openxmlformats.org/drawingml/2006/main"/>
           <a:p xmlns:a="http://schemas.openxmlformats.org/drawingml/2006/main">
             <a:pPr algn="l">
+              <a:buNone/>
               <a:defRPr sz="1575" b="0">
                 <a:solidFill>
                   <a:srgbClr val="52616B"/>
@@ -6251,6 +6717,7 @@
           <a:lstStyle xmlns:a="http://schemas.openxmlformats.org/drawingml/2006/main"/>
           <a:p xmlns:a="http://schemas.openxmlformats.org/drawingml/2006/main">
             <a:pPr algn="l">
+              <a:buNone/>
               <a:defRPr sz="2550" b="1">
                 <a:solidFill>
                   <a:srgbClr val="3D8DFF"/>
@@ -6307,6 +6774,7 @@
           <a:lstStyle xmlns:a="http://schemas.openxmlformats.org/drawingml/2006/main"/>
           <a:p xmlns:a="http://schemas.openxmlformats.org/drawingml/2006/main">
             <a:pPr algn="l">
+              <a:buNone/>
               <a:defRPr sz="2175" b="1">
                 <a:solidFill>
                   <a:srgbClr val="101820"/>
@@ -6363,6 +6831,7 @@
           <a:lstStyle xmlns:a="http://schemas.openxmlformats.org/drawingml/2006/main"/>
           <a:p xmlns:a="http://schemas.openxmlformats.org/drawingml/2006/main">
             <a:pPr algn="l">
+              <a:buNone/>
               <a:defRPr sz="1575" b="0">
                 <a:solidFill>
                   <a:srgbClr val="52616B"/>
@@ -6448,6 +6917,7 @@
           <a:lstStyle xmlns:a="http://schemas.openxmlformats.org/drawingml/2006/main"/>
           <a:p xmlns:a="http://schemas.openxmlformats.org/drawingml/2006/main">
             <a:pPr algn="l">
+              <a:buNone/>
               <a:defRPr sz="1200" b="1">
                 <a:solidFill>
                   <a:srgbClr val="3D8DFF"/>
@@ -6504,6 +6974,7 @@
           <a:lstStyle xmlns:a="http://schemas.openxmlformats.org/drawingml/2006/main"/>
           <a:p xmlns:a="http://schemas.openxmlformats.org/drawingml/2006/main">
             <a:pPr algn="l">
+              <a:buNone/>
               <a:defRPr sz="2700" b="1">
                 <a:solidFill>
                   <a:srgbClr val="101820"/>
@@ -6591,6 +7062,7 @@
           <a:lstStyle xmlns:a="http://schemas.openxmlformats.org/drawingml/2006/main"/>
           <a:p xmlns:a="http://schemas.openxmlformats.org/drawingml/2006/main">
             <a:pPr algn="r">
+              <a:buNone/>
               <a:defRPr sz="1200" b="0">
                 <a:solidFill>
                   <a:srgbClr val="52616B"/>
@@ -6680,6 +7152,7 @@
           <a:lstStyle xmlns:a="http://schemas.openxmlformats.org/drawingml/2006/main"/>
           <a:p xmlns:a="http://schemas.openxmlformats.org/drawingml/2006/main">
             <a:pPr algn="l">
+              <a:buNone/>
               <a:defRPr sz="1875" b="1">
                 <a:solidFill>
                   <a:srgbClr val="3D8DFF"/>
@@ -6736,6 +7209,7 @@
           <a:lstStyle xmlns:a="http://schemas.openxmlformats.org/drawingml/2006/main"/>
           <a:p xmlns:a="http://schemas.openxmlformats.org/drawingml/2006/main">
             <a:pPr algn="l">
+              <a:buNone/>
               <a:defRPr sz="1575" b="0">
                 <a:solidFill>
                   <a:srgbClr val="52616B"/>
@@ -6792,6 +7266,7 @@
           <a:lstStyle xmlns:a="http://schemas.openxmlformats.org/drawingml/2006/main"/>
           <a:p xmlns:a="http://schemas.openxmlformats.org/drawingml/2006/main">
             <a:pPr algn="ctr">
+              <a:buNone/>
               <a:defRPr sz="2550" b="1">
                 <a:solidFill>
                   <a:srgbClr val="3D8DFF"/>
@@ -6881,6 +7356,7 @@
           <a:lstStyle xmlns:a="http://schemas.openxmlformats.org/drawingml/2006/main"/>
           <a:p xmlns:a="http://schemas.openxmlformats.org/drawingml/2006/main">
             <a:pPr algn="l">
+              <a:buNone/>
               <a:defRPr sz="1875" b="1">
                 <a:solidFill>
                   <a:srgbClr val="101820"/>
@@ -6937,6 +7413,7 @@
           <a:lstStyle xmlns:a="http://schemas.openxmlformats.org/drawingml/2006/main"/>
           <a:p xmlns:a="http://schemas.openxmlformats.org/drawingml/2006/main">
             <a:pPr algn="l">
+              <a:buNone/>
               <a:defRPr sz="1575" b="0">
                 <a:solidFill>
                   <a:srgbClr val="52616B"/>
@@ -6993,6 +7470,7 @@
           <a:lstStyle xmlns:a="http://schemas.openxmlformats.org/drawingml/2006/main"/>
           <a:p xmlns:a="http://schemas.openxmlformats.org/drawingml/2006/main">
             <a:pPr algn="ctr">
+              <a:buNone/>
               <a:defRPr sz="2550" b="1">
                 <a:solidFill>
                   <a:srgbClr val="3D8DFF"/>
@@ -7082,6 +7560,7 @@
           <a:lstStyle xmlns:a="http://schemas.openxmlformats.org/drawingml/2006/main"/>
           <a:p xmlns:a="http://schemas.openxmlformats.org/drawingml/2006/main">
             <a:pPr algn="l">
+              <a:buNone/>
               <a:defRPr sz="1875" b="1">
                 <a:solidFill>
                   <a:srgbClr val="101820"/>
@@ -7138,6 +7617,7 @@
           <a:lstStyle xmlns:a="http://schemas.openxmlformats.org/drawingml/2006/main"/>
           <a:p xmlns:a="http://schemas.openxmlformats.org/drawingml/2006/main">
             <a:pPr algn="l">
+              <a:buNone/>
               <a:defRPr sz="1575" b="0">
                 <a:solidFill>
                   <a:srgbClr val="52616B"/>
@@ -7194,6 +7674,7 @@
           <a:lstStyle xmlns:a="http://schemas.openxmlformats.org/drawingml/2006/main"/>
           <a:p xmlns:a="http://schemas.openxmlformats.org/drawingml/2006/main">
             <a:pPr algn="ctr">
+              <a:buNone/>
               <a:defRPr sz="2550" b="1">
                 <a:solidFill>
                   <a:srgbClr val="3D8DFF"/>
@@ -7283,6 +7764,7 @@
           <a:lstStyle xmlns:a="http://schemas.openxmlformats.org/drawingml/2006/main"/>
           <a:p xmlns:a="http://schemas.openxmlformats.org/drawingml/2006/main">
             <a:pPr algn="l">
+              <a:buNone/>
               <a:defRPr sz="1875" b="1">
                 <a:solidFill>
                   <a:srgbClr val="101820"/>
@@ -7339,6 +7821,7 @@
           <a:lstStyle xmlns:a="http://schemas.openxmlformats.org/drawingml/2006/main"/>
           <a:p xmlns:a="http://schemas.openxmlformats.org/drawingml/2006/main">
             <a:pPr algn="l">
+              <a:buNone/>
               <a:defRPr sz="1575" b="0">
                 <a:solidFill>
                   <a:srgbClr val="52616B"/>
@@ -7395,6 +7878,7 @@
           <a:lstStyle xmlns:a="http://schemas.openxmlformats.org/drawingml/2006/main"/>
           <a:p xmlns:a="http://schemas.openxmlformats.org/drawingml/2006/main">
             <a:pPr algn="ctr">
+              <a:buNone/>
               <a:defRPr sz="2175" b="1">
                 <a:solidFill>
                   <a:srgbClr val="101820"/>
@@ -7480,6 +7964,7 @@
           <a:lstStyle xmlns:a="http://schemas.openxmlformats.org/drawingml/2006/main"/>
           <a:p xmlns:a="http://schemas.openxmlformats.org/drawingml/2006/main">
             <a:pPr algn="l">
+              <a:buNone/>
               <a:defRPr sz="1200" b="1">
                 <a:solidFill>
                   <a:srgbClr val="3D8DFF"/>
@@ -7536,6 +8021,7 @@
           <a:lstStyle xmlns:a="http://schemas.openxmlformats.org/drawingml/2006/main"/>
           <a:p xmlns:a="http://schemas.openxmlformats.org/drawingml/2006/main">
             <a:pPr algn="l">
+              <a:buNone/>
               <a:defRPr sz="2700" b="1">
                 <a:solidFill>
                   <a:srgbClr val="101820"/>
@@ -7623,6 +8109,7 @@
           <a:lstStyle xmlns:a="http://schemas.openxmlformats.org/drawingml/2006/main"/>
           <a:p xmlns:a="http://schemas.openxmlformats.org/drawingml/2006/main">
             <a:pPr algn="r">
+              <a:buNone/>
               <a:defRPr sz="1200" b="0">
                 <a:solidFill>
                   <a:srgbClr val="52616B"/>
@@ -7679,6 +8166,7 @@
           <a:lstStyle xmlns:a="http://schemas.openxmlformats.org/drawingml/2006/main"/>
           <a:p xmlns:a="http://schemas.openxmlformats.org/drawingml/2006/main">
             <a:pPr algn="l">
+              <a:buNone/>
               <a:defRPr sz="1950" b="1">
                 <a:solidFill>
                   <a:srgbClr val="3D8DFF"/>
@@ -7735,6 +8223,7 @@
           <a:lstStyle xmlns:a="http://schemas.openxmlformats.org/drawingml/2006/main"/>
           <a:p xmlns:a="http://schemas.openxmlformats.org/drawingml/2006/main">
             <a:pPr algn="l">
+              <a:buNone/>
               <a:defRPr sz="2925" b="1">
                 <a:solidFill>
                   <a:srgbClr val="101820"/>
@@ -7791,6 +8280,7 @@
           <a:lstStyle xmlns:a="http://schemas.openxmlformats.org/drawingml/2006/main"/>
           <a:p xmlns:a="http://schemas.openxmlformats.org/drawingml/2006/main">
             <a:pPr algn="l">
+              <a:buNone/>
               <a:defRPr sz="1950" b="0">
                 <a:solidFill>
                   <a:srgbClr val="52616B"/>
@@ -7880,6 +8370,7 @@
           <a:lstStyle xmlns:a="http://schemas.openxmlformats.org/drawingml/2006/main"/>
           <a:p xmlns:a="http://schemas.openxmlformats.org/drawingml/2006/main">
             <a:pPr algn="l">
+              <a:buNone/>
               <a:defRPr sz="1275" b="1">
                 <a:solidFill>
                   <a:srgbClr val="3D8DFF"/>
@@ -7936,6 +8427,7 @@
           <a:lstStyle xmlns:a="http://schemas.openxmlformats.org/drawingml/2006/main"/>
           <a:p xmlns:a="http://schemas.openxmlformats.org/drawingml/2006/main">
             <a:pPr algn="l">
+              <a:buNone/>
               <a:defRPr sz="2625" b="1">
                 <a:solidFill>
                   <a:srgbClr val="101820"/>
@@ -7992,6 +8484,7 @@
           <a:lstStyle xmlns:a="http://schemas.openxmlformats.org/drawingml/2006/main"/>
           <a:p xmlns:a="http://schemas.openxmlformats.org/drawingml/2006/main">
             <a:pPr algn="l">
+              <a:buNone/>
               <a:defRPr sz="1800" b="0">
                 <a:solidFill>
                   <a:srgbClr val="52616B"/>
@@ -8081,6 +8574,7 @@
           <a:lstStyle xmlns:a="http://schemas.openxmlformats.org/drawingml/2006/main"/>
           <a:p xmlns:a="http://schemas.openxmlformats.org/drawingml/2006/main">
             <a:pPr algn="ctr">
+              <a:buNone/>
               <a:defRPr sz="1800" b="1">
                 <a:solidFill>
                   <a:srgbClr val="C8553D"/>
@@ -8108,6 +8602,3018 @@
     <p:extLst>
       <p:ext uri="{BB962C8B-B14F-4D97-AF65-F5344CB8AC3E}">
         <p14:creationId xmlns:p14="http://schemas.microsoft.com/office/powerpoint/2010/main" val="65938535"/>
+      </p:ext>
+    </p:extLst>
+  </p:cSld>
+</p:sld>
+</file>
+
+<file path=ppt/slides/slide15.xml><?xml version="1.0" encoding="utf-8"?>
+<p:sld xmlns:p="http://schemas.openxmlformats.org/presentationml/2006/main">
+  <p:cSld>
+    <p:bg>
+      <p:bgPr>
+        <a:solidFill xmlns:a="http://schemas.openxmlformats.org/drawingml/2006/main">
+          <a:srgbClr val="FFFFFF"/>
+        </a:solidFill>
+      </p:bgPr>
+    </p:bg>
+    <p:spTree>
+      <p:nvGrpSpPr>
+        <p:cNvPr id="1" name=""/>
+        <p:cNvGrpSpPr/>
+        <p:nvPr/>
+      </p:nvGrpSpPr>
+      <p:grpSpPr>
+        <a:xfrm xmlns:a="http://schemas.openxmlformats.org/drawingml/2006/main"/>
+      </p:grpSpPr>
+      <p:sp>
+        <p:nvSpPr>
+          <p:cNvPr id="16" name="">
+            <a:extLst xmlns:a="http://schemas.openxmlformats.org/drawingml/2006/main">
+              <a:ext uri="{FF2B5EF4-FFF2-40B4-BE49-F238E27FC236}">
+                <a16:creationId xmlns:a16="http://schemas.microsoft.com/office/drawing/2014/main" id="{0643D917-60C1-49B6-A04E-D85D24522DCE}"/>
+              </a:ext>
+            </a:extLst>
+          </p:cNvPr>
+          <p:cNvSpPr>
+            <a:spLocks xmlns:a="http://schemas.openxmlformats.org/drawingml/2006/main" noGrp="1"/>
+          </p:cNvSpPr>
+          <p:nvPr/>
+        </p:nvSpPr>
+        <p:spPr>
+          <a:xfrm xmlns:a="http://schemas.openxmlformats.org/drawingml/2006/main">
+            <a:off x="400050" y="228600"/>
+            <a:ext cx="2857500" cy="228600"/>
+          </a:xfrm>
+          <a:prstGeom xmlns:a="http://schemas.openxmlformats.org/drawingml/2006/main" prst="rect">
+            <a:avLst/>
+          </a:prstGeom>
+          <a:noFill xmlns:a="http://schemas.openxmlformats.org/drawingml/2006/main"/>
+          <a:ln xmlns:a="http://schemas.openxmlformats.org/drawingml/2006/main" w="0">
+            <a:noFill/>
+            <a:prstDash val="solid"/>
+          </a:ln>
+        </p:spPr>
+        <p:txBody>
+          <a:bodyPr xmlns:a="http://schemas.openxmlformats.org/drawingml/2006/main" anchor="t"/>
+          <a:lstStyle xmlns:a="http://schemas.openxmlformats.org/drawingml/2006/main"/>
+          <a:p xmlns:a="http://schemas.openxmlformats.org/drawingml/2006/main">
+            <a:pPr algn="l">
+              <a:buNone/>
+              <a:defRPr sz="1200" b="1">
+                <a:solidFill>
+                  <a:srgbClr val="3D8DFF"/>
+                </a:solidFill>
+                <a:latin typeface="Arial"/>
+                <a:ea typeface="Arial"/>
+                <a:cs typeface="Arial"/>
+              </a:defRPr>
+            </a:pPr>
+            <a:r>
+              <a:rPr sz="1200" b="1">
+                <a:solidFill>
+                  <a:srgbClr val="3D8DFF"/>
+                </a:solidFill>
+                <a:latin typeface="Arial"/>
+                <a:ea typeface="Arial"/>
+                <a:cs typeface="Arial"/>
+              </a:rPr>
+              <a:t>LIT-MOM-03.1</a:t>
+            </a:r>
+          </a:p>
+        </p:txBody>
+      </p:sp>
+      <p:sp>
+        <p:nvSpPr>
+          <p:cNvPr id="2" name="">
+            <a:extLst xmlns:a="http://schemas.openxmlformats.org/drawingml/2006/main">
+              <a:ext uri="{FF2B5EF4-FFF2-40B4-BE49-F238E27FC236}">
+                <a16:creationId xmlns:a16="http://schemas.microsoft.com/office/drawing/2014/main" id="{3F51F0D8-19C8-434E-90A3-9CD80434373E}"/>
+              </a:ext>
+            </a:extLst>
+          </p:cNvPr>
+          <p:cNvSpPr>
+            <a:spLocks xmlns:a="http://schemas.openxmlformats.org/drawingml/2006/main" noGrp="1"/>
+          </p:cNvSpPr>
+          <p:nvPr/>
+        </p:nvSpPr>
+        <p:spPr>
+          <a:xfrm xmlns:a="http://schemas.openxmlformats.org/drawingml/2006/main">
+            <a:off x="400050" y="476250"/>
+            <a:ext cx="11049000" cy="819150"/>
+          </a:xfrm>
+          <a:prstGeom xmlns:a="http://schemas.openxmlformats.org/drawingml/2006/main" prst="rect">
+            <a:avLst/>
+          </a:prstGeom>
+          <a:noFill xmlns:a="http://schemas.openxmlformats.org/drawingml/2006/main"/>
+          <a:ln xmlns:a="http://schemas.openxmlformats.org/drawingml/2006/main" w="0">
+            <a:noFill/>
+            <a:prstDash val="solid"/>
+          </a:ln>
+        </p:spPr>
+        <p:txBody>
+          <a:bodyPr xmlns:a="http://schemas.openxmlformats.org/drawingml/2006/main" anchor="t"/>
+          <a:lstStyle xmlns:a="http://schemas.openxmlformats.org/drawingml/2006/main"/>
+          <a:p xmlns:a="http://schemas.openxmlformats.org/drawingml/2006/main">
+            <a:pPr algn="l">
+              <a:buNone/>
+              <a:defRPr sz="2700" b="1">
+                <a:solidFill>
+                  <a:srgbClr val="101820"/>
+                </a:solidFill>
+                <a:latin typeface="Arial"/>
+                <a:ea typeface="Arial"/>
+                <a:cs typeface="Arial"/>
+              </a:defRPr>
+            </a:pPr>
+            <a:r>
+              <a:rPr sz="2700" b="1">
+                <a:solidFill>
+                  <a:srgbClr val="101820"/>
+                </a:solidFill>
+                <a:latin typeface="Arial"/>
+                <a:ea typeface="Arial"/>
+                <a:cs typeface="Arial"/>
+              </a:rPr>
+              <a:t>The rule is reproducible—but the published history is not yet</a:t>
+            </a:r>
+          </a:p>
+        </p:txBody>
+      </p:sp>
+      <p:sp>
+        <p:nvSpPr>
+          <p:cNvPr id="3" name="">
+            <a:extLst xmlns:a="http://schemas.openxmlformats.org/drawingml/2006/main">
+              <a:ext uri="{FF2B5EF4-FFF2-40B4-BE49-F238E27FC236}">
+                <a16:creationId xmlns:a16="http://schemas.microsoft.com/office/drawing/2014/main" id="{9C82D8E5-4706-4E1C-8A9C-3CB6FFDCDE1D}"/>
+              </a:ext>
+            </a:extLst>
+          </p:cNvPr>
+          <p:cNvSpPr>
+            <a:spLocks xmlns:a="http://schemas.openxmlformats.org/drawingml/2006/main" noGrp="1"/>
+          </p:cNvSpPr>
+          <p:nvPr/>
+        </p:nvSpPr>
+        <p:spPr>
+          <a:xfrm xmlns:a="http://schemas.openxmlformats.org/drawingml/2006/main">
+            <a:off x="400050" y="1428750"/>
+            <a:ext cx="11391900" cy="0"/>
+          </a:xfrm>
+          <a:prstGeom xmlns:a="http://schemas.openxmlformats.org/drawingml/2006/main" prst="line">
+            <a:avLst/>
+          </a:prstGeom>
+          <a:noFill xmlns:a="http://schemas.openxmlformats.org/drawingml/2006/main"/>
+          <a:ln xmlns:a="http://schemas.openxmlformats.org/drawingml/2006/main" w="9525">
+            <a:solidFill>
+              <a:srgbClr val="B8BCC4"/>
+            </a:solidFill>
+            <a:prstDash val="solid"/>
+          </a:ln>
+        </p:spPr>
+      </p:sp>
+      <p:sp>
+        <p:nvSpPr>
+          <p:cNvPr id="4" name="">
+            <a:extLst xmlns:a="http://schemas.openxmlformats.org/drawingml/2006/main">
+              <a:ext uri="{FF2B5EF4-FFF2-40B4-BE49-F238E27FC236}">
+                <a16:creationId xmlns:a16="http://schemas.microsoft.com/office/drawing/2014/main" id="{8452295D-1E22-4BA1-B87C-35FC318DE242}"/>
+              </a:ext>
+            </a:extLst>
+          </p:cNvPr>
+          <p:cNvSpPr>
+            <a:spLocks xmlns:a="http://schemas.openxmlformats.org/drawingml/2006/main" noGrp="1"/>
+          </p:cNvSpPr>
+          <p:nvPr/>
+        </p:nvSpPr>
+        <p:spPr>
+          <a:xfrm xmlns:a="http://schemas.openxmlformats.org/drawingml/2006/main">
+            <a:off x="11010900" y="6324600"/>
+            <a:ext cx="762000" cy="266700"/>
+          </a:xfrm>
+          <a:prstGeom xmlns:a="http://schemas.openxmlformats.org/drawingml/2006/main" prst="rect">
+            <a:avLst/>
+          </a:prstGeom>
+          <a:noFill xmlns:a="http://schemas.openxmlformats.org/drawingml/2006/main"/>
+          <a:ln xmlns:a="http://schemas.openxmlformats.org/drawingml/2006/main" w="0">
+            <a:noFill/>
+            <a:prstDash val="solid"/>
+          </a:ln>
+        </p:spPr>
+        <p:txBody>
+          <a:bodyPr xmlns:a="http://schemas.openxmlformats.org/drawingml/2006/main" anchor="t"/>
+          <a:lstStyle xmlns:a="http://schemas.openxmlformats.org/drawingml/2006/main"/>
+          <a:p xmlns:a="http://schemas.openxmlformats.org/drawingml/2006/main">
+            <a:pPr algn="r">
+              <a:buNone/>
+              <a:defRPr sz="1200" b="0">
+                <a:solidFill>
+                  <a:srgbClr val="52616B"/>
+                </a:solidFill>
+                <a:latin typeface="Arial"/>
+                <a:ea typeface="Arial"/>
+                <a:cs typeface="Arial"/>
+              </a:defRPr>
+            </a:pPr>
+            <a:r>
+              <a:rPr sz="1200" b="0">
+                <a:solidFill>
+                  <a:srgbClr val="52616B"/>
+                </a:solidFill>
+                <a:latin typeface="Arial"/>
+                <a:ea typeface="Arial"/>
+                <a:cs typeface="Arial"/>
+              </a:rPr>
+              <a:t>15</a:t>
+            </a:r>
+          </a:p>
+        </p:txBody>
+      </p:sp>
+      <p:sp>
+        <p:nvSpPr>
+          <p:cNvPr id="5" name="">
+            <a:extLst xmlns:a="http://schemas.openxmlformats.org/drawingml/2006/main">
+              <a:ext uri="{FF2B5EF4-FFF2-40B4-BE49-F238E27FC236}">
+                <a16:creationId xmlns:a16="http://schemas.microsoft.com/office/drawing/2014/main" id="{EA84F263-DCB7-4ECF-AC3C-B71C047C289B}"/>
+              </a:ext>
+            </a:extLst>
+          </p:cNvPr>
+          <p:cNvSpPr>
+            <a:spLocks xmlns:a="http://schemas.openxmlformats.org/drawingml/2006/main" noGrp="1"/>
+          </p:cNvSpPr>
+          <p:nvPr/>
+        </p:nvSpPr>
+        <p:spPr>
+          <a:xfrm xmlns:a="http://schemas.openxmlformats.org/drawingml/2006/main">
+            <a:off x="628650" y="1790700"/>
+            <a:ext cx="4953000" cy="3257550"/>
+          </a:xfrm>
+          <a:prstGeom xmlns:a="http://schemas.openxmlformats.org/drawingml/2006/main" prst="rect">
+            <a:avLst/>
+          </a:prstGeom>
+          <a:solidFill xmlns:a="http://schemas.openxmlformats.org/drawingml/2006/main">
+            <a:srgbClr val="E6F2EC"/>
+          </a:solidFill>
+          <a:ln xmlns:a="http://schemas.openxmlformats.org/drawingml/2006/main" w="9525">
+            <a:solidFill>
+              <a:srgbClr val="2E7D5B"/>
+            </a:solidFill>
+            <a:prstDash val="solid"/>
+          </a:ln>
+        </p:spPr>
+      </p:sp>
+      <p:sp>
+        <p:nvSpPr>
+          <p:cNvPr id="6" name="">
+            <a:extLst xmlns:a="http://schemas.openxmlformats.org/drawingml/2006/main">
+              <a:ext uri="{FF2B5EF4-FFF2-40B4-BE49-F238E27FC236}">
+                <a16:creationId xmlns:a16="http://schemas.microsoft.com/office/drawing/2014/main" id="{2535A567-86A3-447F-ABF8-3D7CC1CFCEE3}"/>
+              </a:ext>
+            </a:extLst>
+          </p:cNvPr>
+          <p:cNvSpPr>
+            <a:spLocks xmlns:a="http://schemas.openxmlformats.org/drawingml/2006/main" noGrp="1"/>
+          </p:cNvSpPr>
+          <p:nvPr/>
+        </p:nvSpPr>
+        <p:spPr>
+          <a:xfrm xmlns:a="http://schemas.openxmlformats.org/drawingml/2006/main">
+            <a:off x="971550" y="2114550"/>
+            <a:ext cx="3238500" cy="247650"/>
+          </a:xfrm>
+          <a:prstGeom xmlns:a="http://schemas.openxmlformats.org/drawingml/2006/main" prst="rect">
+            <a:avLst/>
+          </a:prstGeom>
+          <a:noFill xmlns:a="http://schemas.openxmlformats.org/drawingml/2006/main"/>
+          <a:ln xmlns:a="http://schemas.openxmlformats.org/drawingml/2006/main" w="0">
+            <a:noFill/>
+            <a:prstDash val="solid"/>
+          </a:ln>
+        </p:spPr>
+        <p:txBody>
+          <a:bodyPr xmlns:a="http://schemas.openxmlformats.org/drawingml/2006/main" anchor="t"/>
+          <a:lstStyle xmlns:a="http://schemas.openxmlformats.org/drawingml/2006/main"/>
+          <a:p xmlns:a="http://schemas.openxmlformats.org/drawingml/2006/main">
+            <a:pPr algn="l">
+              <a:buNone/>
+              <a:defRPr sz="1275" b="1">
+                <a:solidFill>
+                  <a:srgbClr val="2E7D5B"/>
+                </a:solidFill>
+                <a:latin typeface="Arial"/>
+                <a:ea typeface="Arial"/>
+                <a:cs typeface="Arial"/>
+              </a:defRPr>
+            </a:pPr>
+            <a:r>
+              <a:rPr sz="1275" b="1">
+                <a:solidFill>
+                  <a:srgbClr val="2E7D5B"/>
+                </a:solidFill>
+                <a:latin typeface="Arial"/>
+                <a:ea typeface="Arial"/>
+                <a:cs typeface="Arial"/>
+              </a:rPr>
+              <a:t>PASS · LOCAL MECHANICS</a:t>
+            </a:r>
+          </a:p>
+        </p:txBody>
+      </p:sp>
+      <p:sp>
+        <p:nvSpPr>
+          <p:cNvPr id="7" name="">
+            <a:extLst xmlns:a="http://schemas.openxmlformats.org/drawingml/2006/main">
+              <a:ext uri="{FF2B5EF4-FFF2-40B4-BE49-F238E27FC236}">
+                <a16:creationId xmlns:a16="http://schemas.microsoft.com/office/drawing/2014/main" id="{B0EF5351-B0F9-4A7A-9512-D9DE9A581079}"/>
+              </a:ext>
+            </a:extLst>
+          </p:cNvPr>
+          <p:cNvSpPr>
+            <a:spLocks xmlns:a="http://schemas.openxmlformats.org/drawingml/2006/main" noGrp="1"/>
+          </p:cNvSpPr>
+          <p:nvPr/>
+        </p:nvSpPr>
+        <p:spPr>
+          <a:xfrm xmlns:a="http://schemas.openxmlformats.org/drawingml/2006/main">
+            <a:off x="971550" y="2667000"/>
+            <a:ext cx="1809750" cy="876300"/>
+          </a:xfrm>
+          <a:prstGeom xmlns:a="http://schemas.openxmlformats.org/drawingml/2006/main" prst="rect">
+            <a:avLst/>
+          </a:prstGeom>
+          <a:noFill xmlns:a="http://schemas.openxmlformats.org/drawingml/2006/main"/>
+          <a:ln xmlns:a="http://schemas.openxmlformats.org/drawingml/2006/main" w="0">
+            <a:noFill/>
+            <a:prstDash val="solid"/>
+          </a:ln>
+        </p:spPr>
+        <p:txBody>
+          <a:bodyPr xmlns:a="http://schemas.openxmlformats.org/drawingml/2006/main" anchor="t"/>
+          <a:lstStyle xmlns:a="http://schemas.openxmlformats.org/drawingml/2006/main"/>
+          <a:p xmlns:a="http://schemas.openxmlformats.org/drawingml/2006/main">
+            <a:pPr algn="l">
+              <a:buNone/>
+              <a:defRPr sz="5100" b="1">
+                <a:solidFill>
+                  <a:srgbClr val="2E7D5B"/>
+                </a:solidFill>
+                <a:latin typeface="Arial"/>
+                <a:ea typeface="Arial"/>
+                <a:cs typeface="Arial"/>
+              </a:defRPr>
+            </a:pPr>
+            <a:r>
+              <a:rPr sz="5100" b="1">
+                <a:solidFill>
+                  <a:srgbClr val="2E7D5B"/>
+                </a:solidFill>
+                <a:latin typeface="Arial"/>
+                <a:ea typeface="Arial"/>
+                <a:cs typeface="Arial"/>
+              </a:rPr>
+              <a:t>508</a:t>
+            </a:r>
+          </a:p>
+        </p:txBody>
+      </p:sp>
+      <p:sp>
+        <p:nvSpPr>
+          <p:cNvPr id="8" name="">
+            <a:extLst xmlns:a="http://schemas.openxmlformats.org/drawingml/2006/main">
+              <a:ext uri="{FF2B5EF4-FFF2-40B4-BE49-F238E27FC236}">
+                <a16:creationId xmlns:a16="http://schemas.microsoft.com/office/drawing/2014/main" id="{845D259F-CD58-4A41-8E58-6185E679F682}"/>
+              </a:ext>
+            </a:extLst>
+          </p:cNvPr>
+          <p:cNvSpPr>
+            <a:spLocks xmlns:a="http://schemas.openxmlformats.org/drawingml/2006/main" noGrp="1"/>
+          </p:cNvSpPr>
+          <p:nvPr/>
+        </p:nvSpPr>
+        <p:spPr>
+          <a:xfrm xmlns:a="http://schemas.openxmlformats.org/drawingml/2006/main">
+            <a:off x="2800350" y="2914650"/>
+            <a:ext cx="2324100" cy="457200"/>
+          </a:xfrm>
+          <a:prstGeom xmlns:a="http://schemas.openxmlformats.org/drawingml/2006/main" prst="rect">
+            <a:avLst/>
+          </a:prstGeom>
+          <a:noFill xmlns:a="http://schemas.openxmlformats.org/drawingml/2006/main"/>
+          <a:ln xmlns:a="http://schemas.openxmlformats.org/drawingml/2006/main" w="0">
+            <a:noFill/>
+            <a:prstDash val="solid"/>
+          </a:ln>
+        </p:spPr>
+        <p:txBody>
+          <a:bodyPr xmlns:a="http://schemas.openxmlformats.org/drawingml/2006/main" anchor="t"/>
+          <a:lstStyle xmlns:a="http://schemas.openxmlformats.org/drawingml/2006/main"/>
+          <a:p xmlns:a="http://schemas.openxmlformats.org/drawingml/2006/main">
+            <a:pPr algn="l">
+              <a:buNone/>
+              <a:defRPr sz="2100" b="1">
+                <a:solidFill>
+                  <a:srgbClr val="101820"/>
+                </a:solidFill>
+                <a:latin typeface="Arial"/>
+                <a:ea typeface="Arial"/>
+                <a:cs typeface="Arial"/>
+              </a:defRPr>
+            </a:pPr>
+            <a:r>
+              <a:rPr sz="2100" b="1">
+                <a:solidFill>
+                  <a:srgbClr val="101820"/>
+                </a:solidFill>
+                <a:latin typeface="Arial"/>
+                <a:ea typeface="Arial"/>
+                <a:cs typeface="Arial"/>
+              </a:rPr>
+              <a:t>weekly decisions</a:t>
+            </a:r>
+          </a:p>
+        </p:txBody>
+      </p:sp>
+      <p:sp>
+        <p:nvSpPr>
+          <p:cNvPr id="9" name="">
+            <a:extLst xmlns:a="http://schemas.openxmlformats.org/drawingml/2006/main">
+              <a:ext uri="{FF2B5EF4-FFF2-40B4-BE49-F238E27FC236}">
+                <a16:creationId xmlns:a16="http://schemas.microsoft.com/office/drawing/2014/main" id="{2B561A00-F2ED-46FB-9D93-63A3E1AD5803}"/>
+              </a:ext>
+            </a:extLst>
+          </p:cNvPr>
+          <p:cNvSpPr>
+            <a:spLocks xmlns:a="http://schemas.openxmlformats.org/drawingml/2006/main" noGrp="1"/>
+          </p:cNvSpPr>
+          <p:nvPr/>
+        </p:nvSpPr>
+        <p:spPr>
+          <a:xfrm xmlns:a="http://schemas.openxmlformats.org/drawingml/2006/main">
+            <a:off x="971550" y="3810000"/>
+            <a:ext cx="4000500" cy="933450"/>
+          </a:xfrm>
+          <a:prstGeom xmlns:a="http://schemas.openxmlformats.org/drawingml/2006/main" prst="rect">
+            <a:avLst/>
+          </a:prstGeom>
+          <a:noFill xmlns:a="http://schemas.openxmlformats.org/drawingml/2006/main"/>
+          <a:ln xmlns:a="http://schemas.openxmlformats.org/drawingml/2006/main" w="0">
+            <a:noFill/>
+            <a:prstDash val="solid"/>
+          </a:ln>
+        </p:spPr>
+        <p:txBody>
+          <a:bodyPr xmlns:a="http://schemas.openxmlformats.org/drawingml/2006/main" anchor="t"/>
+          <a:lstStyle xmlns:a="http://schemas.openxmlformats.org/drawingml/2006/main"/>
+          <a:p xmlns:a="http://schemas.openxmlformats.org/drawingml/2006/main">
+            <a:pPr algn="l">
+              <a:buNone/>
+              <a:defRPr sz="1800" b="0">
+                <a:solidFill>
+                  <a:srgbClr val="52616B"/>
+                </a:solidFill>
+                <a:latin typeface="Arial"/>
+                <a:ea typeface="Arial"/>
+                <a:cs typeface="Arial"/>
+              </a:defRPr>
+            </a:pPr>
+            <a:r>
+              <a:rPr sz="1800" b="0">
+                <a:solidFill>
+                  <a:srgbClr val="52616B"/>
+                </a:solidFill>
+                <a:latin typeface="Arial"/>
+                <a:ea typeface="Arial"/>
+                <a:cs typeface="Arial"/>
+              </a:rPr>
+              <a:t>2016-06-29 → 2026-03-18</a:t>
+            </a:r>
+          </a:p>
+          <a:p xmlns:a="http://schemas.openxmlformats.org/drawingml/2006/main">
+            <a:pPr algn="l">
+              <a:buNone/>
+              <a:defRPr sz="1800" b="0">
+                <a:solidFill>
+                  <a:srgbClr val="52616B"/>
+                </a:solidFill>
+                <a:latin typeface="Arial"/>
+                <a:ea typeface="Arial"/>
+                <a:cs typeface="Arial"/>
+              </a:defRPr>
+            </a:pPr>
+            <a:r>
+              <a:rPr sz="1800" b="0">
+                <a:solidFill>
+                  <a:srgbClr val="52616B"/>
+                </a:solidFill>
+                <a:latin typeface="Arial"/>
+                <a:ea typeface="Arial"/>
+                <a:cs typeface="Arial"/>
+              </a:rPr>
+              <a:t>All 11 mechanics checks pass</a:t>
+            </a:r>
+          </a:p>
+          <a:p xmlns:a="http://schemas.openxmlformats.org/drawingml/2006/main">
+            <a:pPr algn="l">
+              <a:buNone/>
+              <a:defRPr sz="1800" b="0">
+                <a:solidFill>
+                  <a:srgbClr val="52616B"/>
+                </a:solidFill>
+                <a:latin typeface="Arial"/>
+                <a:ea typeface="Arial"/>
+                <a:cs typeface="Arial"/>
+              </a:defRPr>
+            </a:pPr>
+            <a:r>
+              <a:rPr sz="1800" b="0">
+                <a:solidFill>
+                  <a:srgbClr val="52616B"/>
+                </a:solidFill>
+                <a:latin typeface="Arial"/>
+                <a:ea typeface="Arial"/>
+                <a:cs typeface="Arial"/>
+              </a:rPr>
+              <a:t>No outcome metrics computed</a:t>
+            </a:r>
+          </a:p>
+        </p:txBody>
+      </p:sp>
+      <p:sp>
+        <p:nvSpPr>
+          <p:cNvPr id="10" name="">
+            <a:extLst xmlns:a="http://schemas.openxmlformats.org/drawingml/2006/main">
+              <a:ext uri="{FF2B5EF4-FFF2-40B4-BE49-F238E27FC236}">
+                <a16:creationId xmlns:a16="http://schemas.microsoft.com/office/drawing/2014/main" id="{D80FDF2D-786A-4D34-8C53-03F5531FEFAA}"/>
+              </a:ext>
+            </a:extLst>
+          </p:cNvPr>
+          <p:cNvSpPr>
+            <a:spLocks xmlns:a="http://schemas.openxmlformats.org/drawingml/2006/main" noGrp="1"/>
+          </p:cNvSpPr>
+          <p:nvPr/>
+        </p:nvSpPr>
+        <p:spPr>
+          <a:xfrm xmlns:a="http://schemas.openxmlformats.org/drawingml/2006/main">
+            <a:off x="6191250" y="1790700"/>
+            <a:ext cx="4953000" cy="3257550"/>
+          </a:xfrm>
+          <a:prstGeom xmlns:a="http://schemas.openxmlformats.org/drawingml/2006/main" prst="rect">
+            <a:avLst/>
+          </a:prstGeom>
+          <a:solidFill xmlns:a="http://schemas.openxmlformats.org/drawingml/2006/main">
+            <a:srgbClr val="F7E7E2"/>
+          </a:solidFill>
+          <a:ln xmlns:a="http://schemas.openxmlformats.org/drawingml/2006/main" w="9525">
+            <a:solidFill>
+              <a:srgbClr val="C8553D"/>
+            </a:solidFill>
+            <a:prstDash val="solid"/>
+          </a:ln>
+        </p:spPr>
+      </p:sp>
+      <p:sp>
+        <p:nvSpPr>
+          <p:cNvPr id="11" name="">
+            <a:extLst xmlns:a="http://schemas.openxmlformats.org/drawingml/2006/main">
+              <a:ext uri="{FF2B5EF4-FFF2-40B4-BE49-F238E27FC236}">
+                <a16:creationId xmlns:a16="http://schemas.microsoft.com/office/drawing/2014/main" id="{E4150C52-9BF1-4205-AAE7-8463BBDA6FD9}"/>
+              </a:ext>
+            </a:extLst>
+          </p:cNvPr>
+          <p:cNvSpPr>
+            <a:spLocks xmlns:a="http://schemas.openxmlformats.org/drawingml/2006/main" noGrp="1"/>
+          </p:cNvSpPr>
+          <p:nvPr/>
+        </p:nvSpPr>
+        <p:spPr>
+          <a:xfrm xmlns:a="http://schemas.openxmlformats.org/drawingml/2006/main">
+            <a:off x="6534150" y="2114550"/>
+            <a:ext cx="3714750" cy="247650"/>
+          </a:xfrm>
+          <a:prstGeom xmlns:a="http://schemas.openxmlformats.org/drawingml/2006/main" prst="rect">
+            <a:avLst/>
+          </a:prstGeom>
+          <a:noFill xmlns:a="http://schemas.openxmlformats.org/drawingml/2006/main"/>
+          <a:ln xmlns:a="http://schemas.openxmlformats.org/drawingml/2006/main" w="0">
+            <a:noFill/>
+            <a:prstDash val="solid"/>
+          </a:ln>
+        </p:spPr>
+        <p:txBody>
+          <a:bodyPr xmlns:a="http://schemas.openxmlformats.org/drawingml/2006/main" anchor="t"/>
+          <a:lstStyle xmlns:a="http://schemas.openxmlformats.org/drawingml/2006/main"/>
+          <a:p xmlns:a="http://schemas.openxmlformats.org/drawingml/2006/main">
+            <a:pPr algn="l">
+              <a:buNone/>
+              <a:defRPr sz="1275" b="1">
+                <a:solidFill>
+                  <a:srgbClr val="C8553D"/>
+                </a:solidFill>
+                <a:latin typeface="Arial"/>
+                <a:ea typeface="Arial"/>
+                <a:cs typeface="Arial"/>
+              </a:defRPr>
+            </a:pPr>
+            <a:r>
+              <a:rPr sz="1275" b="1">
+                <a:solidFill>
+                  <a:srgbClr val="C8553D"/>
+                </a:solidFill>
+                <a:latin typeface="Arial"/>
+                <a:ea typeface="Arial"/>
+                <a:cs typeface="Arial"/>
+              </a:rPr>
+              <a:t>STOP · SOURCE-SPAN COVERAGE</a:t>
+            </a:r>
+          </a:p>
+        </p:txBody>
+      </p:sp>
+      <p:sp>
+        <p:nvSpPr>
+          <p:cNvPr id="12" name="">
+            <a:extLst xmlns:a="http://schemas.openxmlformats.org/drawingml/2006/main">
+              <a:ext uri="{FF2B5EF4-FFF2-40B4-BE49-F238E27FC236}">
+                <a16:creationId xmlns:a16="http://schemas.microsoft.com/office/drawing/2014/main" id="{0606DC9E-2BF6-4A3D-8AA4-5B9D11332D44}"/>
+              </a:ext>
+            </a:extLst>
+          </p:cNvPr>
+          <p:cNvSpPr>
+            <a:spLocks xmlns:a="http://schemas.openxmlformats.org/drawingml/2006/main" noGrp="1"/>
+          </p:cNvSpPr>
+          <p:nvPr/>
+        </p:nvSpPr>
+        <p:spPr>
+          <a:xfrm xmlns:a="http://schemas.openxmlformats.org/drawingml/2006/main">
+            <a:off x="6534150" y="2724150"/>
+            <a:ext cx="4000500" cy="704850"/>
+          </a:xfrm>
+          <a:prstGeom xmlns:a="http://schemas.openxmlformats.org/drawingml/2006/main" prst="rect">
+            <a:avLst/>
+          </a:prstGeom>
+          <a:noFill xmlns:a="http://schemas.openxmlformats.org/drawingml/2006/main"/>
+          <a:ln xmlns:a="http://schemas.openxmlformats.org/drawingml/2006/main" w="0">
+            <a:noFill/>
+            <a:prstDash val="solid"/>
+          </a:ln>
+        </p:spPr>
+        <p:txBody>
+          <a:bodyPr xmlns:a="http://schemas.openxmlformats.org/drawingml/2006/main" anchor="t"/>
+          <a:lstStyle xmlns:a="http://schemas.openxmlformats.org/drawingml/2006/main"/>
+          <a:p xmlns:a="http://schemas.openxmlformats.org/drawingml/2006/main">
+            <a:pPr algn="l">
+              <a:buNone/>
+              <a:defRPr sz="4050" b="1">
+                <a:solidFill>
+                  <a:srgbClr val="C8553D"/>
+                </a:solidFill>
+                <a:latin typeface="Arial"/>
+                <a:ea typeface="Arial"/>
+                <a:cs typeface="Arial"/>
+              </a:defRPr>
+            </a:pPr>
+            <a:r>
+              <a:rPr sz="4050" b="1">
+                <a:solidFill>
+                  <a:srgbClr val="C8553D"/>
+                </a:solidFill>
+                <a:latin typeface="Arial"/>
+                <a:ea typeface="Arial"/>
+                <a:cs typeface="Arial"/>
+              </a:rPr>
+              <a:t>2008–2015</a:t>
+            </a:r>
+          </a:p>
+        </p:txBody>
+      </p:sp>
+      <p:sp>
+        <p:nvSpPr>
+          <p:cNvPr id="13" name="">
+            <a:extLst xmlns:a="http://schemas.openxmlformats.org/drawingml/2006/main">
+              <a:ext uri="{FF2B5EF4-FFF2-40B4-BE49-F238E27FC236}">
+                <a16:creationId xmlns:a16="http://schemas.microsoft.com/office/drawing/2014/main" id="{03283D39-FBEA-479D-88E1-46F1F4C330B5}"/>
+              </a:ext>
+            </a:extLst>
+          </p:cNvPr>
+          <p:cNvSpPr>
+            <a:spLocks xmlns:a="http://schemas.openxmlformats.org/drawingml/2006/main" noGrp="1"/>
+          </p:cNvSpPr>
+          <p:nvPr/>
+        </p:nvSpPr>
+        <p:spPr>
+          <a:xfrm xmlns:a="http://schemas.openxmlformats.org/drawingml/2006/main">
+            <a:off x="6534150" y="3429000"/>
+            <a:ext cx="4000500" cy="457200"/>
+          </a:xfrm>
+          <a:prstGeom xmlns:a="http://schemas.openxmlformats.org/drawingml/2006/main" prst="rect">
+            <a:avLst/>
+          </a:prstGeom>
+          <a:noFill xmlns:a="http://schemas.openxmlformats.org/drawingml/2006/main"/>
+          <a:ln xmlns:a="http://schemas.openxmlformats.org/drawingml/2006/main" w="0">
+            <a:noFill/>
+            <a:prstDash val="solid"/>
+          </a:ln>
+        </p:spPr>
+        <p:txBody>
+          <a:bodyPr xmlns:a="http://schemas.openxmlformats.org/drawingml/2006/main" anchor="t"/>
+          <a:lstStyle xmlns:a="http://schemas.openxmlformats.org/drawingml/2006/main"/>
+          <a:p xmlns:a="http://schemas.openxmlformats.org/drawingml/2006/main">
+            <a:pPr algn="l">
+              <a:buNone/>
+              <a:defRPr sz="2175" b="1">
+                <a:solidFill>
+                  <a:srgbClr val="101820"/>
+                </a:solidFill>
+                <a:latin typeface="Arial"/>
+                <a:ea typeface="Arial"/>
+                <a:cs typeface="Arial"/>
+              </a:defRPr>
+            </a:pPr>
+            <a:r>
+              <a:rPr sz="2175" b="1">
+                <a:solidFill>
+                  <a:srgbClr val="101820"/>
+                </a:solidFill>
+                <a:latin typeface="Arial"/>
+                <a:ea typeface="Arial"/>
+                <a:cs typeface="Arial"/>
+              </a:rPr>
+              <a:t>remains unreproduced</a:t>
+            </a:r>
+          </a:p>
+        </p:txBody>
+      </p:sp>
+      <p:sp>
+        <p:nvSpPr>
+          <p:cNvPr id="14" name="">
+            <a:extLst xmlns:a="http://schemas.openxmlformats.org/drawingml/2006/main">
+              <a:ext uri="{FF2B5EF4-FFF2-40B4-BE49-F238E27FC236}">
+                <a16:creationId xmlns:a16="http://schemas.microsoft.com/office/drawing/2014/main" id="{DB7B3C09-EAFE-41D8-880B-D0BE56096F33}"/>
+              </a:ext>
+            </a:extLst>
+          </p:cNvPr>
+          <p:cNvSpPr>
+            <a:spLocks xmlns:a="http://schemas.openxmlformats.org/drawingml/2006/main" noGrp="1"/>
+          </p:cNvSpPr>
+          <p:nvPr/>
+        </p:nvSpPr>
+        <p:spPr>
+          <a:xfrm xmlns:a="http://schemas.openxmlformats.org/drawingml/2006/main">
+            <a:off x="6534150" y="4000500"/>
+            <a:ext cx="4000500" cy="876300"/>
+          </a:xfrm>
+          <a:prstGeom xmlns:a="http://schemas.openxmlformats.org/drawingml/2006/main" prst="rect">
+            <a:avLst/>
+          </a:prstGeom>
+          <a:noFill xmlns:a="http://schemas.openxmlformats.org/drawingml/2006/main"/>
+          <a:ln xmlns:a="http://schemas.openxmlformats.org/drawingml/2006/main" w="0">
+            <a:noFill/>
+            <a:prstDash val="solid"/>
+          </a:ln>
+        </p:spPr>
+        <p:txBody>
+          <a:bodyPr xmlns:a="http://schemas.openxmlformats.org/drawingml/2006/main" anchor="t"/>
+          <a:lstStyle xmlns:a="http://schemas.openxmlformats.org/drawingml/2006/main"/>
+          <a:p xmlns:a="http://schemas.openxmlformats.org/drawingml/2006/main">
+            <a:pPr algn="l">
+              <a:buNone/>
+              <a:defRPr sz="1500" b="0">
+                <a:solidFill>
+                  <a:srgbClr val="52616B"/>
+                </a:solidFill>
+                <a:latin typeface="Arial"/>
+                <a:ea typeface="Arial"/>
+                <a:cs typeface="Arial"/>
+              </a:defRPr>
+            </a:pPr>
+            <a:r>
+              <a:rPr sz="1500" b="0">
+                <a:solidFill>
+                  <a:srgbClr val="52616B"/>
+                </a:solidFill>
+                <a:latin typeface="Arial"/>
+                <a:ea typeface="Arial"/>
+                <a:cs typeface="Arial"/>
+              </a:rPr>
+              <a:t>The Alpaca account returned complete common history only from 2016. The window was narrowed explicitly—not silently.</a:t>
+            </a:r>
+          </a:p>
+        </p:txBody>
+      </p:sp>
+      <p:sp>
+        <p:nvSpPr>
+          <p:cNvPr id="15" name="">
+            <a:extLst xmlns:a="http://schemas.openxmlformats.org/drawingml/2006/main">
+              <a:ext uri="{FF2B5EF4-FFF2-40B4-BE49-F238E27FC236}">
+                <a16:creationId xmlns:a16="http://schemas.microsoft.com/office/drawing/2014/main" id="{0DF58B95-FF34-44E3-BD69-0887709C26B4}"/>
+              </a:ext>
+            </a:extLst>
+          </p:cNvPr>
+          <p:cNvSpPr>
+            <a:spLocks xmlns:a="http://schemas.openxmlformats.org/drawingml/2006/main" noGrp="1"/>
+          </p:cNvSpPr>
+          <p:nvPr/>
+        </p:nvSpPr>
+        <p:spPr>
+          <a:xfrm xmlns:a="http://schemas.openxmlformats.org/drawingml/2006/main">
+            <a:off x="2133600" y="5505450"/>
+            <a:ext cx="7924800" cy="381000"/>
+          </a:xfrm>
+          <a:prstGeom xmlns:a="http://schemas.openxmlformats.org/drawingml/2006/main" prst="rect">
+            <a:avLst/>
+          </a:prstGeom>
+          <a:noFill xmlns:a="http://schemas.openxmlformats.org/drawingml/2006/main"/>
+          <a:ln xmlns:a="http://schemas.openxmlformats.org/drawingml/2006/main" w="0">
+            <a:noFill/>
+            <a:prstDash val="solid"/>
+          </a:ln>
+        </p:spPr>
+        <p:txBody>
+          <a:bodyPr xmlns:a="http://schemas.openxmlformats.org/drawingml/2006/main" anchor="t"/>
+          <a:lstStyle xmlns:a="http://schemas.openxmlformats.org/drawingml/2006/main"/>
+          <a:p xmlns:a="http://schemas.openxmlformats.org/drawingml/2006/main">
+            <a:pPr algn="ctr">
+              <a:buNone/>
+              <a:defRPr sz="2175" b="1">
+                <a:solidFill>
+                  <a:srgbClr val="101820"/>
+                </a:solidFill>
+                <a:latin typeface="Arial"/>
+                <a:ea typeface="Arial"/>
+                <a:cs typeface="Arial"/>
+              </a:defRPr>
+            </a:pPr>
+            <a:r>
+              <a:rPr sz="2175" b="1">
+                <a:solidFill>
+                  <a:srgbClr val="101820"/>
+                </a:solidFill>
+                <a:latin typeface="Arial"/>
+                <a:ea typeface="Arial"/>
+                <a:cs typeface="Arial"/>
+              </a:rPr>
+              <a:t>This slide proves implementation, not profitability.</a:t>
+            </a:r>
+          </a:p>
+        </p:txBody>
+      </p:sp>
+    </p:spTree>
+    <p:extLst>
+      <p:ext uri="{BB962C8B-B14F-4D97-AF65-F5344CB8AC3E}">
+        <p14:creationId xmlns:p14="http://schemas.microsoft.com/office/powerpoint/2010/main" val="1503881080"/>
+      </p:ext>
+    </p:extLst>
+  </p:cSld>
+</p:sld>
+</file>
+
+<file path=ppt/slides/slide16.xml><?xml version="1.0" encoding="utf-8"?>
+<p:sld xmlns:p="http://schemas.openxmlformats.org/presentationml/2006/main">
+  <p:cSld>
+    <p:bg>
+      <p:bgPr>
+        <a:solidFill xmlns:a="http://schemas.openxmlformats.org/drawingml/2006/main">
+          <a:srgbClr val="FFFFFF"/>
+        </a:solidFill>
+      </p:bgPr>
+    </p:bg>
+    <p:spTree>
+      <p:nvGrpSpPr>
+        <p:cNvPr id="1" name=""/>
+        <p:cNvGrpSpPr/>
+        <p:nvPr/>
+      </p:nvGrpSpPr>
+      <p:grpSpPr>
+        <a:xfrm xmlns:a="http://schemas.openxmlformats.org/drawingml/2006/main"/>
+      </p:grpSpPr>
+      <p:sp>
+        <p:nvSpPr>
+          <p:cNvPr id="13" name="">
+            <a:extLst xmlns:a="http://schemas.openxmlformats.org/drawingml/2006/main">
+              <a:ext uri="{FF2B5EF4-FFF2-40B4-BE49-F238E27FC236}">
+                <a16:creationId xmlns:a16="http://schemas.microsoft.com/office/drawing/2014/main" id="{E7AA0F3C-FA14-482C-9911-54A24769116A}"/>
+              </a:ext>
+            </a:extLst>
+          </p:cNvPr>
+          <p:cNvSpPr>
+            <a:spLocks xmlns:a="http://schemas.openxmlformats.org/drawingml/2006/main" noGrp="1"/>
+          </p:cNvSpPr>
+          <p:nvPr/>
+        </p:nvSpPr>
+        <p:spPr>
+          <a:xfrm xmlns:a="http://schemas.openxmlformats.org/drawingml/2006/main">
+            <a:off x="400050" y="228600"/>
+            <a:ext cx="2857500" cy="228600"/>
+          </a:xfrm>
+          <a:prstGeom xmlns:a="http://schemas.openxmlformats.org/drawingml/2006/main" prst="rect">
+            <a:avLst/>
+          </a:prstGeom>
+          <a:noFill xmlns:a="http://schemas.openxmlformats.org/drawingml/2006/main"/>
+          <a:ln xmlns:a="http://schemas.openxmlformats.org/drawingml/2006/main" w="0">
+            <a:noFill/>
+            <a:prstDash val="solid"/>
+          </a:ln>
+        </p:spPr>
+        <p:txBody>
+          <a:bodyPr xmlns:a="http://schemas.openxmlformats.org/drawingml/2006/main" anchor="t"/>
+          <a:lstStyle xmlns:a="http://schemas.openxmlformats.org/drawingml/2006/main"/>
+          <a:p xmlns:a="http://schemas.openxmlformats.org/drawingml/2006/main">
+            <a:pPr algn="l">
+              <a:buNone/>
+              <a:defRPr sz="1200" b="1">
+                <a:solidFill>
+                  <a:srgbClr val="3D8DFF"/>
+                </a:solidFill>
+                <a:latin typeface="Arial"/>
+                <a:ea typeface="Arial"/>
+                <a:cs typeface="Arial"/>
+              </a:defRPr>
+            </a:pPr>
+            <a:r>
+              <a:rPr sz="1200" b="1">
+                <a:solidFill>
+                  <a:srgbClr val="3D8DFF"/>
+                </a:solidFill>
+                <a:latin typeface="Arial"/>
+                <a:ea typeface="Arial"/>
+                <a:cs typeface="Arial"/>
+              </a:rPr>
+              <a:t>LIT-MOM-03.1</a:t>
+            </a:r>
+          </a:p>
+        </p:txBody>
+      </p:sp>
+      <p:sp>
+        <p:nvSpPr>
+          <p:cNvPr id="2" name="">
+            <a:extLst xmlns:a="http://schemas.openxmlformats.org/drawingml/2006/main">
+              <a:ext uri="{FF2B5EF4-FFF2-40B4-BE49-F238E27FC236}">
+                <a16:creationId xmlns:a16="http://schemas.microsoft.com/office/drawing/2014/main" id="{522D8FEC-18D3-4EAC-98CE-20AF9D03A3AC}"/>
+              </a:ext>
+            </a:extLst>
+          </p:cNvPr>
+          <p:cNvSpPr>
+            <a:spLocks xmlns:a="http://schemas.openxmlformats.org/drawingml/2006/main" noGrp="1"/>
+          </p:cNvSpPr>
+          <p:nvPr/>
+        </p:nvSpPr>
+        <p:spPr>
+          <a:xfrm xmlns:a="http://schemas.openxmlformats.org/drawingml/2006/main">
+            <a:off x="400050" y="476250"/>
+            <a:ext cx="11049000" cy="819150"/>
+          </a:xfrm>
+          <a:prstGeom xmlns:a="http://schemas.openxmlformats.org/drawingml/2006/main" prst="rect">
+            <a:avLst/>
+          </a:prstGeom>
+          <a:noFill xmlns:a="http://schemas.openxmlformats.org/drawingml/2006/main"/>
+          <a:ln xmlns:a="http://schemas.openxmlformats.org/drawingml/2006/main" w="0">
+            <a:noFill/>
+            <a:prstDash val="solid"/>
+          </a:ln>
+        </p:spPr>
+        <p:txBody>
+          <a:bodyPr xmlns:a="http://schemas.openxmlformats.org/drawingml/2006/main" anchor="t"/>
+          <a:lstStyle xmlns:a="http://schemas.openxmlformats.org/drawingml/2006/main"/>
+          <a:p xmlns:a="http://schemas.openxmlformats.org/drawingml/2006/main">
+            <a:pPr algn="l">
+              <a:buNone/>
+              <a:defRPr sz="2700" b="1">
+                <a:solidFill>
+                  <a:srgbClr val="101820"/>
+                </a:solidFill>
+                <a:latin typeface="Arial"/>
+                <a:ea typeface="Arial"/>
+                <a:cs typeface="Arial"/>
+              </a:defRPr>
+            </a:pPr>
+            <a:r>
+              <a:rPr sz="2700" b="1">
+                <a:solidFill>
+                  <a:srgbClr val="101820"/>
+                </a:solidFill>
+                <a:latin typeface="Arial"/>
+                <a:ea typeface="Arial"/>
+                <a:cs typeface="Arial"/>
+              </a:rPr>
+              <a:t>The absolute-momentum veto is an occasional brake—not the normal state</a:t>
+            </a:r>
+          </a:p>
+        </p:txBody>
+      </p:sp>
+      <p:sp>
+        <p:nvSpPr>
+          <p:cNvPr id="3" name="">
+            <a:extLst xmlns:a="http://schemas.openxmlformats.org/drawingml/2006/main">
+              <a:ext uri="{FF2B5EF4-FFF2-40B4-BE49-F238E27FC236}">
+                <a16:creationId xmlns:a16="http://schemas.microsoft.com/office/drawing/2014/main" id="{21605544-2473-417D-B48F-9F8DF40D4FAF}"/>
+              </a:ext>
+            </a:extLst>
+          </p:cNvPr>
+          <p:cNvSpPr>
+            <a:spLocks xmlns:a="http://schemas.openxmlformats.org/drawingml/2006/main" noGrp="1"/>
+          </p:cNvSpPr>
+          <p:nvPr/>
+        </p:nvSpPr>
+        <p:spPr>
+          <a:xfrm xmlns:a="http://schemas.openxmlformats.org/drawingml/2006/main">
+            <a:off x="400050" y="1428750"/>
+            <a:ext cx="11391900" cy="0"/>
+          </a:xfrm>
+          <a:prstGeom xmlns:a="http://schemas.openxmlformats.org/drawingml/2006/main" prst="line">
+            <a:avLst/>
+          </a:prstGeom>
+          <a:noFill xmlns:a="http://schemas.openxmlformats.org/drawingml/2006/main"/>
+          <a:ln xmlns:a="http://schemas.openxmlformats.org/drawingml/2006/main" w="9525">
+            <a:solidFill>
+              <a:srgbClr val="B8BCC4"/>
+            </a:solidFill>
+            <a:prstDash val="solid"/>
+          </a:ln>
+        </p:spPr>
+      </p:sp>
+      <p:sp>
+        <p:nvSpPr>
+          <p:cNvPr id="4" name="">
+            <a:extLst xmlns:a="http://schemas.openxmlformats.org/drawingml/2006/main">
+              <a:ext uri="{FF2B5EF4-FFF2-40B4-BE49-F238E27FC236}">
+                <a16:creationId xmlns:a16="http://schemas.microsoft.com/office/drawing/2014/main" id="{7944BF93-B836-4831-89CE-852C703D91AD}"/>
+              </a:ext>
+            </a:extLst>
+          </p:cNvPr>
+          <p:cNvSpPr>
+            <a:spLocks xmlns:a="http://schemas.openxmlformats.org/drawingml/2006/main" noGrp="1"/>
+          </p:cNvSpPr>
+          <p:nvPr/>
+        </p:nvSpPr>
+        <p:spPr>
+          <a:xfrm xmlns:a="http://schemas.openxmlformats.org/drawingml/2006/main">
+            <a:off x="11010900" y="6324600"/>
+            <a:ext cx="762000" cy="266700"/>
+          </a:xfrm>
+          <a:prstGeom xmlns:a="http://schemas.openxmlformats.org/drawingml/2006/main" prst="rect">
+            <a:avLst/>
+          </a:prstGeom>
+          <a:noFill xmlns:a="http://schemas.openxmlformats.org/drawingml/2006/main"/>
+          <a:ln xmlns:a="http://schemas.openxmlformats.org/drawingml/2006/main" w="0">
+            <a:noFill/>
+            <a:prstDash val="solid"/>
+          </a:ln>
+        </p:spPr>
+        <p:txBody>
+          <a:bodyPr xmlns:a="http://schemas.openxmlformats.org/drawingml/2006/main" anchor="t"/>
+          <a:lstStyle xmlns:a="http://schemas.openxmlformats.org/drawingml/2006/main"/>
+          <a:p xmlns:a="http://schemas.openxmlformats.org/drawingml/2006/main">
+            <a:pPr algn="r">
+              <a:buNone/>
+              <a:defRPr sz="1200" b="0">
+                <a:solidFill>
+                  <a:srgbClr val="52616B"/>
+                </a:solidFill>
+                <a:latin typeface="Arial"/>
+                <a:ea typeface="Arial"/>
+                <a:cs typeface="Arial"/>
+              </a:defRPr>
+            </a:pPr>
+            <a:r>
+              <a:rPr sz="1200" b="0">
+                <a:solidFill>
+                  <a:srgbClr val="52616B"/>
+                </a:solidFill>
+                <a:latin typeface="Arial"/>
+                <a:ea typeface="Arial"/>
+                <a:cs typeface="Arial"/>
+              </a:rPr>
+              <a:t>16</a:t>
+            </a:r>
+          </a:p>
+        </p:txBody>
+      </p:sp>
+      <p:pic>
+        <p:nvPicPr>
+          <p:cNvPr id="19" name=""/>
+          <p:cNvPicPr>
+            <a:picLocks xmlns:a="http://schemas.openxmlformats.org/drawingml/2006/main" noChangeAspect="1"/>
+          </p:cNvPicPr>
+          <p:nvPr/>
+        </p:nvPicPr>
+        <p:blipFill>
+          <a:blip xmlns:r="http://schemas.openxmlformats.org/officeDocument/2006/relationships" xmlns:a="http://schemas.openxmlformats.org/drawingml/2006/main" r:embed="Re0b0c88161b3479f"/>
+          <a:stretch xmlns:a="http://schemas.openxmlformats.org/drawingml/2006/main"/>
+        </p:blipFill>
+        <p:spPr>
+          <a:xfrm xmlns:a="http://schemas.openxmlformats.org/drawingml/2006/main">
+            <a:off x="460699" y="1562100"/>
+            <a:ext cx="8222602" cy="4476750"/>
+          </a:xfrm>
+          <a:prstGeom xmlns:a="http://schemas.openxmlformats.org/drawingml/2006/main" prst="rect">
+            <a:avLst/>
+          </a:prstGeom>
+        </p:spPr>
+      </p:pic>
+      <p:sp>
+        <p:nvSpPr>
+          <p:cNvPr id="6" name="">
+            <a:extLst xmlns:a="http://schemas.openxmlformats.org/drawingml/2006/main">
+              <a:ext uri="{FF2B5EF4-FFF2-40B4-BE49-F238E27FC236}">
+                <a16:creationId xmlns:a16="http://schemas.microsoft.com/office/drawing/2014/main" id="{DBF73623-95B1-48A7-A168-959D4ACF9EF6}"/>
+              </a:ext>
+            </a:extLst>
+          </p:cNvPr>
+          <p:cNvSpPr>
+            <a:spLocks xmlns:a="http://schemas.openxmlformats.org/drawingml/2006/main" noGrp="1"/>
+          </p:cNvSpPr>
+          <p:nvPr/>
+        </p:nvSpPr>
+        <p:spPr>
+          <a:xfrm xmlns:a="http://schemas.openxmlformats.org/drawingml/2006/main">
+            <a:off x="8991600" y="1733550"/>
+            <a:ext cx="2724150" cy="3905250"/>
+          </a:xfrm>
+          <a:prstGeom xmlns:a="http://schemas.openxmlformats.org/drawingml/2006/main" prst="rect">
+            <a:avLst/>
+          </a:prstGeom>
+          <a:solidFill xmlns:a="http://schemas.openxmlformats.org/drawingml/2006/main">
+            <a:srgbClr val="EAF5FB"/>
+          </a:solidFill>
+          <a:ln xmlns:a="http://schemas.openxmlformats.org/drawingml/2006/main" w="9525">
+            <a:solidFill>
+              <a:srgbClr val="6DCBF4"/>
+            </a:solidFill>
+            <a:prstDash val="solid"/>
+          </a:ln>
+        </p:spPr>
+      </p:sp>
+      <p:sp>
+        <p:nvSpPr>
+          <p:cNvPr id="7" name="">
+            <a:extLst xmlns:a="http://schemas.openxmlformats.org/drawingml/2006/main">
+              <a:ext uri="{FF2B5EF4-FFF2-40B4-BE49-F238E27FC236}">
+                <a16:creationId xmlns:a16="http://schemas.microsoft.com/office/drawing/2014/main" id="{454D3BC9-AB19-4F57-985E-DDB05A7434C0}"/>
+              </a:ext>
+            </a:extLst>
+          </p:cNvPr>
+          <p:cNvSpPr>
+            <a:spLocks xmlns:a="http://schemas.openxmlformats.org/drawingml/2006/main" noGrp="1"/>
+          </p:cNvSpPr>
+          <p:nvPr/>
+        </p:nvSpPr>
+        <p:spPr>
+          <a:xfrm xmlns:a="http://schemas.openxmlformats.org/drawingml/2006/main">
+            <a:off x="9258300" y="2019300"/>
+            <a:ext cx="2095500" cy="247650"/>
+          </a:xfrm>
+          <a:prstGeom xmlns:a="http://schemas.openxmlformats.org/drawingml/2006/main" prst="rect">
+            <a:avLst/>
+          </a:prstGeom>
+          <a:noFill xmlns:a="http://schemas.openxmlformats.org/drawingml/2006/main"/>
+          <a:ln xmlns:a="http://schemas.openxmlformats.org/drawingml/2006/main" w="0">
+            <a:noFill/>
+            <a:prstDash val="solid"/>
+          </a:ln>
+        </p:spPr>
+        <p:txBody>
+          <a:bodyPr xmlns:a="http://schemas.openxmlformats.org/drawingml/2006/main" anchor="t"/>
+          <a:lstStyle xmlns:a="http://schemas.openxmlformats.org/drawingml/2006/main"/>
+          <a:p xmlns:a="http://schemas.openxmlformats.org/drawingml/2006/main">
+            <a:pPr algn="l">
+              <a:buNone/>
+              <a:defRPr sz="1275" b="1">
+                <a:solidFill>
+                  <a:srgbClr val="3D8DFF"/>
+                </a:solidFill>
+                <a:latin typeface="Arial"/>
+                <a:ea typeface="Arial"/>
+                <a:cs typeface="Arial"/>
+              </a:defRPr>
+            </a:pPr>
+            <a:r>
+              <a:rPr sz="1275" b="1">
+                <a:solidFill>
+                  <a:srgbClr val="3D8DFF"/>
+                </a:solidFill>
+                <a:latin typeface="Arial"/>
+                <a:ea typeface="Arial"/>
+                <a:cs typeface="Arial"/>
+              </a:rPr>
+              <a:t>MECHANICS READOUT</a:t>
+            </a:r>
+          </a:p>
+        </p:txBody>
+      </p:sp>
+      <p:sp>
+        <p:nvSpPr>
+          <p:cNvPr id="8" name="">
+            <a:extLst xmlns:a="http://schemas.openxmlformats.org/drawingml/2006/main">
+              <a:ext uri="{FF2B5EF4-FFF2-40B4-BE49-F238E27FC236}">
+                <a16:creationId xmlns:a16="http://schemas.microsoft.com/office/drawing/2014/main" id="{50CF5D67-77D5-4062-92DB-E9771F376463}"/>
+              </a:ext>
+            </a:extLst>
+          </p:cNvPr>
+          <p:cNvSpPr>
+            <a:spLocks xmlns:a="http://schemas.openxmlformats.org/drawingml/2006/main" noGrp="1"/>
+          </p:cNvSpPr>
+          <p:nvPr/>
+        </p:nvSpPr>
+        <p:spPr>
+          <a:xfrm xmlns:a="http://schemas.openxmlformats.org/drawingml/2006/main">
+            <a:off x="9258300" y="2571750"/>
+            <a:ext cx="2095500" cy="552450"/>
+          </a:xfrm>
+          <a:prstGeom xmlns:a="http://schemas.openxmlformats.org/drawingml/2006/main" prst="rect">
+            <a:avLst/>
+          </a:prstGeom>
+          <a:noFill xmlns:a="http://schemas.openxmlformats.org/drawingml/2006/main"/>
+          <a:ln xmlns:a="http://schemas.openxmlformats.org/drawingml/2006/main" w="0">
+            <a:noFill/>
+            <a:prstDash val="solid"/>
+          </a:ln>
+        </p:spPr>
+        <p:txBody>
+          <a:bodyPr xmlns:a="http://schemas.openxmlformats.org/drawingml/2006/main" anchor="t"/>
+          <a:lstStyle xmlns:a="http://schemas.openxmlformats.org/drawingml/2006/main"/>
+          <a:p xmlns:a="http://schemas.openxmlformats.org/drawingml/2006/main">
+            <a:pPr algn="l">
+              <a:buNone/>
+              <a:defRPr sz="3000" b="1">
+                <a:solidFill>
+                  <a:srgbClr val="101820"/>
+                </a:solidFill>
+                <a:latin typeface="Arial"/>
+                <a:ea typeface="Arial"/>
+                <a:cs typeface="Arial"/>
+              </a:defRPr>
+            </a:pPr>
+            <a:r>
+              <a:rPr sz="3000" b="1">
+                <a:solidFill>
+                  <a:srgbClr val="101820"/>
+                </a:solidFill>
+                <a:latin typeface="Arial"/>
+                <a:ea typeface="Arial"/>
+                <a:cs typeface="Arial"/>
+              </a:rPr>
+              <a:t>463 / 508</a:t>
+            </a:r>
+          </a:p>
+        </p:txBody>
+      </p:sp>
+      <p:sp>
+        <p:nvSpPr>
+          <p:cNvPr id="9" name="">
+            <a:extLst xmlns:a="http://schemas.openxmlformats.org/drawingml/2006/main">
+              <a:ext uri="{FF2B5EF4-FFF2-40B4-BE49-F238E27FC236}">
+                <a16:creationId xmlns:a16="http://schemas.microsoft.com/office/drawing/2014/main" id="{7C0B5D7F-B17A-4AC9-835E-6E44FD9128EC}"/>
+              </a:ext>
+            </a:extLst>
+          </p:cNvPr>
+          <p:cNvSpPr>
+            <a:spLocks xmlns:a="http://schemas.openxmlformats.org/drawingml/2006/main" noGrp="1"/>
+          </p:cNvSpPr>
+          <p:nvPr/>
+        </p:nvSpPr>
+        <p:spPr>
+          <a:xfrm xmlns:a="http://schemas.openxmlformats.org/drawingml/2006/main">
+            <a:off x="9258300" y="3105150"/>
+            <a:ext cx="2095500" cy="400050"/>
+          </a:xfrm>
+          <a:prstGeom xmlns:a="http://schemas.openxmlformats.org/drawingml/2006/main" prst="rect">
+            <a:avLst/>
+          </a:prstGeom>
+          <a:noFill xmlns:a="http://schemas.openxmlformats.org/drawingml/2006/main"/>
+          <a:ln xmlns:a="http://schemas.openxmlformats.org/drawingml/2006/main" w="0">
+            <a:noFill/>
+            <a:prstDash val="solid"/>
+          </a:ln>
+        </p:spPr>
+        <p:txBody>
+          <a:bodyPr xmlns:a="http://schemas.openxmlformats.org/drawingml/2006/main" anchor="t"/>
+          <a:lstStyle xmlns:a="http://schemas.openxmlformats.org/drawingml/2006/main"/>
+          <a:p xmlns:a="http://schemas.openxmlformats.org/drawingml/2006/main">
+            <a:pPr algn="l">
+              <a:buNone/>
+              <a:defRPr sz="1650" b="0">
+                <a:solidFill>
+                  <a:srgbClr val="52616B"/>
+                </a:solidFill>
+                <a:latin typeface="Arial"/>
+                <a:ea typeface="Arial"/>
+                <a:cs typeface="Arial"/>
+              </a:defRPr>
+            </a:pPr>
+            <a:r>
+              <a:rPr sz="1650" b="0">
+                <a:solidFill>
+                  <a:srgbClr val="52616B"/>
+                </a:solidFill>
+                <a:latin typeface="Arial"/>
+                <a:ea typeface="Arial"/>
+                <a:cs typeface="Arial"/>
+              </a:rPr>
+              <a:t>weeks fully invested</a:t>
+            </a:r>
+          </a:p>
+        </p:txBody>
+      </p:sp>
+      <p:sp>
+        <p:nvSpPr>
+          <p:cNvPr id="10" name="">
+            <a:extLst xmlns:a="http://schemas.openxmlformats.org/drawingml/2006/main">
+              <a:ext uri="{FF2B5EF4-FFF2-40B4-BE49-F238E27FC236}">
+                <a16:creationId xmlns:a16="http://schemas.microsoft.com/office/drawing/2014/main" id="{DE7E78EB-BFD1-417B-B781-C8666F0A80F8}"/>
+              </a:ext>
+            </a:extLst>
+          </p:cNvPr>
+          <p:cNvSpPr>
+            <a:spLocks xmlns:a="http://schemas.openxmlformats.org/drawingml/2006/main" noGrp="1"/>
+          </p:cNvSpPr>
+          <p:nvPr/>
+        </p:nvSpPr>
+        <p:spPr>
+          <a:xfrm xmlns:a="http://schemas.openxmlformats.org/drawingml/2006/main">
+            <a:off x="9258300" y="3790950"/>
+            <a:ext cx="2095500" cy="552450"/>
+          </a:xfrm>
+          <a:prstGeom xmlns:a="http://schemas.openxmlformats.org/drawingml/2006/main" prst="rect">
+            <a:avLst/>
+          </a:prstGeom>
+          <a:noFill xmlns:a="http://schemas.openxmlformats.org/drawingml/2006/main"/>
+          <a:ln xmlns:a="http://schemas.openxmlformats.org/drawingml/2006/main" w="0">
+            <a:noFill/>
+            <a:prstDash val="solid"/>
+          </a:ln>
+        </p:spPr>
+        <p:txBody>
+          <a:bodyPr xmlns:a="http://schemas.openxmlformats.org/drawingml/2006/main" anchor="t"/>
+          <a:lstStyle xmlns:a="http://schemas.openxmlformats.org/drawingml/2006/main"/>
+          <a:p xmlns:a="http://schemas.openxmlformats.org/drawingml/2006/main">
+            <a:pPr algn="l">
+              <a:buNone/>
+              <a:defRPr sz="3000" b="1">
+                <a:solidFill>
+                  <a:srgbClr val="3D8DFF"/>
+                </a:solidFill>
+                <a:latin typeface="Arial"/>
+                <a:ea typeface="Arial"/>
+                <a:cs typeface="Arial"/>
+              </a:defRPr>
+            </a:pPr>
+            <a:r>
+              <a:rPr sz="3000" b="1">
+                <a:solidFill>
+                  <a:srgbClr val="3D8DFF"/>
+                </a:solidFill>
+                <a:latin typeface="Arial"/>
+                <a:ea typeface="Arial"/>
+                <a:cs typeface="Arial"/>
+              </a:rPr>
+              <a:t>2.6%</a:t>
+            </a:r>
+          </a:p>
+        </p:txBody>
+      </p:sp>
+      <p:sp>
+        <p:nvSpPr>
+          <p:cNvPr id="11" name="">
+            <a:extLst xmlns:a="http://schemas.openxmlformats.org/drawingml/2006/main">
+              <a:ext uri="{FF2B5EF4-FFF2-40B4-BE49-F238E27FC236}">
+                <a16:creationId xmlns:a16="http://schemas.microsoft.com/office/drawing/2014/main" id="{5DFE562A-9915-489A-BC82-2F762B044604}"/>
+              </a:ext>
+            </a:extLst>
+          </p:cNvPr>
+          <p:cNvSpPr>
+            <a:spLocks xmlns:a="http://schemas.openxmlformats.org/drawingml/2006/main" noGrp="1"/>
+          </p:cNvSpPr>
+          <p:nvPr/>
+        </p:nvSpPr>
+        <p:spPr>
+          <a:xfrm xmlns:a="http://schemas.openxmlformats.org/drawingml/2006/main">
+            <a:off x="9258300" y="4324350"/>
+            <a:ext cx="2095500" cy="400050"/>
+          </a:xfrm>
+          <a:prstGeom xmlns:a="http://schemas.openxmlformats.org/drawingml/2006/main" prst="rect">
+            <a:avLst/>
+          </a:prstGeom>
+          <a:noFill xmlns:a="http://schemas.openxmlformats.org/drawingml/2006/main"/>
+          <a:ln xmlns:a="http://schemas.openxmlformats.org/drawingml/2006/main" w="0">
+            <a:noFill/>
+            <a:prstDash val="solid"/>
+          </a:ln>
+        </p:spPr>
+        <p:txBody>
+          <a:bodyPr xmlns:a="http://schemas.openxmlformats.org/drawingml/2006/main" anchor="t"/>
+          <a:lstStyle xmlns:a="http://schemas.openxmlformats.org/drawingml/2006/main"/>
+          <a:p xmlns:a="http://schemas.openxmlformats.org/drawingml/2006/main">
+            <a:pPr algn="l">
+              <a:buNone/>
+              <a:defRPr sz="1650" b="0">
+                <a:solidFill>
+                  <a:srgbClr val="52616B"/>
+                </a:solidFill>
+                <a:latin typeface="Arial"/>
+                <a:ea typeface="Arial"/>
+                <a:cs typeface="Arial"/>
+              </a:defRPr>
+            </a:pPr>
+            <a:r>
+              <a:rPr sz="1650" b="0">
+                <a:solidFill>
+                  <a:srgbClr val="52616B"/>
+                </a:solidFill>
+                <a:latin typeface="Arial"/>
+                <a:ea typeface="Arial"/>
+                <a:cs typeface="Arial"/>
+              </a:rPr>
+              <a:t>average cash weight</a:t>
+            </a:r>
+          </a:p>
+        </p:txBody>
+      </p:sp>
+      <p:sp>
+        <p:nvSpPr>
+          <p:cNvPr id="12" name="">
+            <a:extLst xmlns:a="http://schemas.openxmlformats.org/drawingml/2006/main">
+              <a:ext uri="{FF2B5EF4-FFF2-40B4-BE49-F238E27FC236}">
+                <a16:creationId xmlns:a16="http://schemas.microsoft.com/office/drawing/2014/main" id="{9A127473-A846-4BDC-AD98-EA1A2A6F11AD}"/>
+              </a:ext>
+            </a:extLst>
+          </p:cNvPr>
+          <p:cNvSpPr>
+            <a:spLocks xmlns:a="http://schemas.openxmlformats.org/drawingml/2006/main" noGrp="1"/>
+          </p:cNvSpPr>
+          <p:nvPr/>
+        </p:nvSpPr>
+        <p:spPr>
+          <a:xfrm xmlns:a="http://schemas.openxmlformats.org/drawingml/2006/main">
+            <a:off x="9258300" y="4972050"/>
+            <a:ext cx="2095500" cy="381000"/>
+          </a:xfrm>
+          <a:prstGeom xmlns:a="http://schemas.openxmlformats.org/drawingml/2006/main" prst="rect">
+            <a:avLst/>
+          </a:prstGeom>
+          <a:noFill xmlns:a="http://schemas.openxmlformats.org/drawingml/2006/main"/>
+          <a:ln xmlns:a="http://schemas.openxmlformats.org/drawingml/2006/main" w="0">
+            <a:noFill/>
+            <a:prstDash val="solid"/>
+          </a:ln>
+        </p:spPr>
+        <p:txBody>
+          <a:bodyPr xmlns:a="http://schemas.openxmlformats.org/drawingml/2006/main" anchor="t"/>
+          <a:lstStyle xmlns:a="http://schemas.openxmlformats.org/drawingml/2006/main"/>
+          <a:p xmlns:a="http://schemas.openxmlformats.org/drawingml/2006/main">
+            <a:pPr algn="l">
+              <a:buNone/>
+              <a:defRPr sz="1950" b="1">
+                <a:solidFill>
+                  <a:srgbClr val="101820"/>
+                </a:solidFill>
+                <a:latin typeface="Arial"/>
+                <a:ea typeface="Arial"/>
+                <a:cs typeface="Arial"/>
+              </a:defRPr>
+            </a:pPr>
+            <a:r>
+              <a:rPr sz="1950" b="1">
+                <a:solidFill>
+                  <a:srgbClr val="101820"/>
+                </a:solidFill>
+                <a:latin typeface="Arial"/>
+                <a:ea typeface="Arial"/>
+                <a:cs typeface="Arial"/>
+              </a:rPr>
+              <a:t>0% → 66.7%</a:t>
+            </a:r>
+          </a:p>
+        </p:txBody>
+      </p:sp>
+    </p:spTree>
+    <p:extLst>
+      <p:ext uri="{BB962C8B-B14F-4D97-AF65-F5344CB8AC3E}">
+        <p14:creationId xmlns:p14="http://schemas.microsoft.com/office/powerpoint/2010/main" val="1063912481"/>
+      </p:ext>
+    </p:extLst>
+  </p:cSld>
+</p:sld>
+</file>
+
+<file path=ppt/slides/slide17.xml><?xml version="1.0" encoding="utf-8"?>
+<p:sld xmlns:p="http://schemas.openxmlformats.org/presentationml/2006/main">
+  <p:cSld>
+    <p:bg>
+      <p:bgPr>
+        <a:solidFill xmlns:a="http://schemas.openxmlformats.org/drawingml/2006/main">
+          <a:srgbClr val="FFFFFF"/>
+        </a:solidFill>
+      </p:bgPr>
+    </p:bg>
+    <p:spTree>
+      <p:nvGrpSpPr>
+        <p:cNvPr id="1" name=""/>
+        <p:cNvGrpSpPr/>
+        <p:nvPr/>
+      </p:nvGrpSpPr>
+      <p:grpSpPr>
+        <a:xfrm xmlns:a="http://schemas.openxmlformats.org/drawingml/2006/main"/>
+      </p:grpSpPr>
+      <p:sp>
+        <p:nvSpPr>
+          <p:cNvPr id="14" name="">
+            <a:extLst xmlns:a="http://schemas.openxmlformats.org/drawingml/2006/main">
+              <a:ext uri="{FF2B5EF4-FFF2-40B4-BE49-F238E27FC236}">
+                <a16:creationId xmlns:a16="http://schemas.microsoft.com/office/drawing/2014/main" id="{39B7BB28-C5CF-47BA-A918-FA17029EB44A}"/>
+              </a:ext>
+            </a:extLst>
+          </p:cNvPr>
+          <p:cNvSpPr>
+            <a:spLocks xmlns:a="http://schemas.openxmlformats.org/drawingml/2006/main" noGrp="1"/>
+          </p:cNvSpPr>
+          <p:nvPr/>
+        </p:nvSpPr>
+        <p:spPr>
+          <a:xfrm xmlns:a="http://schemas.openxmlformats.org/drawingml/2006/main">
+            <a:off x="400050" y="228600"/>
+            <a:ext cx="2857500" cy="228600"/>
+          </a:xfrm>
+          <a:prstGeom xmlns:a="http://schemas.openxmlformats.org/drawingml/2006/main" prst="rect">
+            <a:avLst/>
+          </a:prstGeom>
+          <a:noFill xmlns:a="http://schemas.openxmlformats.org/drawingml/2006/main"/>
+          <a:ln xmlns:a="http://schemas.openxmlformats.org/drawingml/2006/main" w="0">
+            <a:noFill/>
+            <a:prstDash val="solid"/>
+          </a:ln>
+        </p:spPr>
+        <p:txBody>
+          <a:bodyPr xmlns:a="http://schemas.openxmlformats.org/drawingml/2006/main" anchor="t"/>
+          <a:lstStyle xmlns:a="http://schemas.openxmlformats.org/drawingml/2006/main"/>
+          <a:p xmlns:a="http://schemas.openxmlformats.org/drawingml/2006/main">
+            <a:pPr algn="l">
+              <a:buNone/>
+              <a:defRPr sz="1200" b="1">
+                <a:solidFill>
+                  <a:srgbClr val="3D8DFF"/>
+                </a:solidFill>
+                <a:latin typeface="Arial"/>
+                <a:ea typeface="Arial"/>
+                <a:cs typeface="Arial"/>
+              </a:defRPr>
+            </a:pPr>
+            <a:r>
+              <a:rPr sz="1200" b="1">
+                <a:solidFill>
+                  <a:srgbClr val="3D8DFF"/>
+                </a:solidFill>
+                <a:latin typeface="Arial"/>
+                <a:ea typeface="Arial"/>
+                <a:cs typeface="Arial"/>
+              </a:rPr>
+              <a:t>LIT-MOM-03.1</a:t>
+            </a:r>
+          </a:p>
+        </p:txBody>
+      </p:sp>
+      <p:sp>
+        <p:nvSpPr>
+          <p:cNvPr id="2" name="">
+            <a:extLst xmlns:a="http://schemas.openxmlformats.org/drawingml/2006/main">
+              <a:ext uri="{FF2B5EF4-FFF2-40B4-BE49-F238E27FC236}">
+                <a16:creationId xmlns:a16="http://schemas.microsoft.com/office/drawing/2014/main" id="{8C401559-67C5-4215-B579-93FC871FC00D}"/>
+              </a:ext>
+            </a:extLst>
+          </p:cNvPr>
+          <p:cNvSpPr>
+            <a:spLocks xmlns:a="http://schemas.openxmlformats.org/drawingml/2006/main" noGrp="1"/>
+          </p:cNvSpPr>
+          <p:nvPr/>
+        </p:nvSpPr>
+        <p:spPr>
+          <a:xfrm xmlns:a="http://schemas.openxmlformats.org/drawingml/2006/main">
+            <a:off x="400050" y="476250"/>
+            <a:ext cx="11049000" cy="819150"/>
+          </a:xfrm>
+          <a:prstGeom xmlns:a="http://schemas.openxmlformats.org/drawingml/2006/main" prst="rect">
+            <a:avLst/>
+          </a:prstGeom>
+          <a:noFill xmlns:a="http://schemas.openxmlformats.org/drawingml/2006/main"/>
+          <a:ln xmlns:a="http://schemas.openxmlformats.org/drawingml/2006/main" w="0">
+            <a:noFill/>
+            <a:prstDash val="solid"/>
+          </a:ln>
+        </p:spPr>
+        <p:txBody>
+          <a:bodyPr xmlns:a="http://schemas.openxmlformats.org/drawingml/2006/main" anchor="t"/>
+          <a:lstStyle xmlns:a="http://schemas.openxmlformats.org/drawingml/2006/main"/>
+          <a:p xmlns:a="http://schemas.openxmlformats.org/drawingml/2006/main">
+            <a:pPr algn="l">
+              <a:buNone/>
+              <a:defRPr sz="2700" b="1">
+                <a:solidFill>
+                  <a:srgbClr val="101820"/>
+                </a:solidFill>
+                <a:latin typeface="Arial"/>
+                <a:ea typeface="Arial"/>
+                <a:cs typeface="Arial"/>
+              </a:defRPr>
+            </a:pPr>
+            <a:r>
+              <a:rPr sz="2700" b="1">
+                <a:solidFill>
+                  <a:srgbClr val="101820"/>
+                </a:solidFill>
+                <a:latin typeface="Arial"/>
+                <a:ea typeface="Arial"/>
+                <a:cs typeface="Arial"/>
+              </a:rPr>
+              <a:t>The two horizons usually concentrate on the same winners</a:t>
+            </a:r>
+          </a:p>
+        </p:txBody>
+      </p:sp>
+      <p:sp>
+        <p:nvSpPr>
+          <p:cNvPr id="3" name="">
+            <a:extLst xmlns:a="http://schemas.openxmlformats.org/drawingml/2006/main">
+              <a:ext uri="{FF2B5EF4-FFF2-40B4-BE49-F238E27FC236}">
+                <a16:creationId xmlns:a16="http://schemas.microsoft.com/office/drawing/2014/main" id="{FE913BAC-F3B9-4338-8958-15CBEBB596BB}"/>
+              </a:ext>
+            </a:extLst>
+          </p:cNvPr>
+          <p:cNvSpPr>
+            <a:spLocks xmlns:a="http://schemas.openxmlformats.org/drawingml/2006/main" noGrp="1"/>
+          </p:cNvSpPr>
+          <p:nvPr/>
+        </p:nvSpPr>
+        <p:spPr>
+          <a:xfrm xmlns:a="http://schemas.openxmlformats.org/drawingml/2006/main">
+            <a:off x="400050" y="1428750"/>
+            <a:ext cx="11391900" cy="0"/>
+          </a:xfrm>
+          <a:prstGeom xmlns:a="http://schemas.openxmlformats.org/drawingml/2006/main" prst="line">
+            <a:avLst/>
+          </a:prstGeom>
+          <a:noFill xmlns:a="http://schemas.openxmlformats.org/drawingml/2006/main"/>
+          <a:ln xmlns:a="http://schemas.openxmlformats.org/drawingml/2006/main" w="9525">
+            <a:solidFill>
+              <a:srgbClr val="B8BCC4"/>
+            </a:solidFill>
+            <a:prstDash val="solid"/>
+          </a:ln>
+        </p:spPr>
+      </p:sp>
+      <p:sp>
+        <p:nvSpPr>
+          <p:cNvPr id="4" name="">
+            <a:extLst xmlns:a="http://schemas.openxmlformats.org/drawingml/2006/main">
+              <a:ext uri="{FF2B5EF4-FFF2-40B4-BE49-F238E27FC236}">
+                <a16:creationId xmlns:a16="http://schemas.microsoft.com/office/drawing/2014/main" id="{80D32FF2-05B5-4DF6-BBF4-B1464DC9B66A}"/>
+              </a:ext>
+            </a:extLst>
+          </p:cNvPr>
+          <p:cNvSpPr>
+            <a:spLocks xmlns:a="http://schemas.openxmlformats.org/drawingml/2006/main" noGrp="1"/>
+          </p:cNvSpPr>
+          <p:nvPr/>
+        </p:nvSpPr>
+        <p:spPr>
+          <a:xfrm xmlns:a="http://schemas.openxmlformats.org/drawingml/2006/main">
+            <a:off x="11372850" y="6324600"/>
+            <a:ext cx="400050" cy="266700"/>
+          </a:xfrm>
+          <a:prstGeom xmlns:a="http://schemas.openxmlformats.org/drawingml/2006/main" prst="rect">
+            <a:avLst/>
+          </a:prstGeom>
+          <a:noFill xmlns:a="http://schemas.openxmlformats.org/drawingml/2006/main"/>
+          <a:ln xmlns:a="http://schemas.openxmlformats.org/drawingml/2006/main" w="0">
+            <a:noFill/>
+            <a:prstDash val="solid"/>
+          </a:ln>
+        </p:spPr>
+        <p:txBody>
+          <a:bodyPr xmlns:a="http://schemas.openxmlformats.org/drawingml/2006/main" anchor="t"/>
+          <a:lstStyle xmlns:a="http://schemas.openxmlformats.org/drawingml/2006/main"/>
+          <a:p xmlns:a="http://schemas.openxmlformats.org/drawingml/2006/main">
+            <a:pPr algn="l">
+              <a:buNone/>
+              <a:defRPr sz="1200" b="0">
+                <a:solidFill>
+                  <a:srgbClr val="52616B"/>
+                </a:solidFill>
+                <a:latin typeface="Arial"/>
+                <a:ea typeface="Arial"/>
+                <a:cs typeface="Arial"/>
+              </a:defRPr>
+            </a:pPr>
+            <a:r>
+              <a:rPr sz="1200" b="0">
+                <a:solidFill>
+                  <a:srgbClr val="52616B"/>
+                </a:solidFill>
+                <a:latin typeface="Arial"/>
+                <a:ea typeface="Arial"/>
+                <a:cs typeface="Arial"/>
+              </a:rPr>
+              <a:t>17</a:t>
+            </a:r>
+          </a:p>
+        </p:txBody>
+      </p:sp>
+      <p:pic>
+        <p:nvPicPr>
+          <p:cNvPr id="22" name=""/>
+          <p:cNvPicPr>
+            <a:picLocks xmlns:a="http://schemas.openxmlformats.org/drawingml/2006/main" noChangeAspect="1"/>
+          </p:cNvPicPr>
+          <p:nvPr/>
+        </p:nvPicPr>
+        <p:blipFill>
+          <a:blip xmlns:r="http://schemas.openxmlformats.org/officeDocument/2006/relationships" xmlns:a="http://schemas.openxmlformats.org/drawingml/2006/main" r:embed="Rb35fa0dd1d5040a2"/>
+          <a:stretch xmlns:a="http://schemas.openxmlformats.org/drawingml/2006/main"/>
+        </p:blipFill>
+        <p:spPr>
+          <a:xfrm xmlns:a="http://schemas.openxmlformats.org/drawingml/2006/main">
+            <a:off x="401022" y="1657350"/>
+            <a:ext cx="7522806" cy="4095750"/>
+          </a:xfrm>
+          <a:prstGeom xmlns:a="http://schemas.openxmlformats.org/drawingml/2006/main" prst="rect">
+            <a:avLst/>
+          </a:prstGeom>
+        </p:spPr>
+      </p:pic>
+      <p:sp>
+        <p:nvSpPr>
+          <p:cNvPr id="6" name="">
+            <a:extLst xmlns:a="http://schemas.openxmlformats.org/drawingml/2006/main">
+              <a:ext uri="{FF2B5EF4-FFF2-40B4-BE49-F238E27FC236}">
+                <a16:creationId xmlns:a16="http://schemas.microsoft.com/office/drawing/2014/main" id="{8B7E846F-BE01-42E8-9EBB-9EA3FC7567F0}"/>
+              </a:ext>
+            </a:extLst>
+          </p:cNvPr>
+          <p:cNvSpPr>
+            <a:spLocks xmlns:a="http://schemas.openxmlformats.org/drawingml/2006/main" noGrp="1"/>
+          </p:cNvSpPr>
+          <p:nvPr/>
+        </p:nvSpPr>
+        <p:spPr>
+          <a:xfrm xmlns:a="http://schemas.openxmlformats.org/drawingml/2006/main">
+            <a:off x="8153400" y="1695450"/>
+            <a:ext cx="3429000" cy="4057650"/>
+          </a:xfrm>
+          <a:prstGeom xmlns:a="http://schemas.openxmlformats.org/drawingml/2006/main" prst="rect">
+            <a:avLst/>
+          </a:prstGeom>
+          <a:solidFill xmlns:a="http://schemas.openxmlformats.org/drawingml/2006/main">
+            <a:srgbClr val="EAF5FB"/>
+          </a:solidFill>
+          <a:ln xmlns:a="http://schemas.openxmlformats.org/drawingml/2006/main" w="9525">
+            <a:solidFill>
+              <a:srgbClr val="6DCBF4"/>
+            </a:solidFill>
+            <a:prstDash val="solid"/>
+          </a:ln>
+        </p:spPr>
+      </p:sp>
+      <p:sp>
+        <p:nvSpPr>
+          <p:cNvPr id="7" name="">
+            <a:extLst xmlns:a="http://schemas.openxmlformats.org/drawingml/2006/main">
+              <a:ext uri="{FF2B5EF4-FFF2-40B4-BE49-F238E27FC236}">
+                <a16:creationId xmlns:a16="http://schemas.microsoft.com/office/drawing/2014/main" id="{7A48CFB1-8F2F-43AD-84B5-5B62F4FCE8D1}"/>
+              </a:ext>
+            </a:extLst>
+          </p:cNvPr>
+          <p:cNvSpPr>
+            <a:spLocks xmlns:a="http://schemas.openxmlformats.org/drawingml/2006/main" noGrp="1"/>
+          </p:cNvSpPr>
+          <p:nvPr/>
+        </p:nvSpPr>
+        <p:spPr>
+          <a:xfrm xmlns:a="http://schemas.openxmlformats.org/drawingml/2006/main">
+            <a:off x="8496300" y="2000250"/>
+            <a:ext cx="2476500" cy="247650"/>
+          </a:xfrm>
+          <a:prstGeom xmlns:a="http://schemas.openxmlformats.org/drawingml/2006/main" prst="rect">
+            <a:avLst/>
+          </a:prstGeom>
+          <a:noFill xmlns:a="http://schemas.openxmlformats.org/drawingml/2006/main"/>
+          <a:ln xmlns:a="http://schemas.openxmlformats.org/drawingml/2006/main" w="0">
+            <a:noFill/>
+            <a:prstDash val="solid"/>
+          </a:ln>
+        </p:spPr>
+        <p:txBody>
+          <a:bodyPr xmlns:a="http://schemas.openxmlformats.org/drawingml/2006/main" anchor="t"/>
+          <a:lstStyle xmlns:a="http://schemas.openxmlformats.org/drawingml/2006/main"/>
+          <a:p xmlns:a="http://schemas.openxmlformats.org/drawingml/2006/main">
+            <a:pPr algn="l">
+              <a:buNone/>
+              <a:defRPr sz="1275" b="1">
+                <a:solidFill>
+                  <a:srgbClr val="3D8DFF"/>
+                </a:solidFill>
+                <a:latin typeface="Arial"/>
+                <a:ea typeface="Arial"/>
+                <a:cs typeface="Arial"/>
+              </a:defRPr>
+            </a:pPr>
+            <a:r>
+              <a:rPr sz="1275" b="1">
+                <a:solidFill>
+                  <a:srgbClr val="3D8DFF"/>
+                </a:solidFill>
+                <a:latin typeface="Arial"/>
+                <a:ea typeface="Arial"/>
+                <a:cs typeface="Arial"/>
+              </a:rPr>
+              <a:t>SLEEVE OVERLAP</a:t>
+            </a:r>
+          </a:p>
+        </p:txBody>
+      </p:sp>
+      <p:sp>
+        <p:nvSpPr>
+          <p:cNvPr id="8" name="">
+            <a:extLst xmlns:a="http://schemas.openxmlformats.org/drawingml/2006/main">
+              <a:ext uri="{FF2B5EF4-FFF2-40B4-BE49-F238E27FC236}">
+                <a16:creationId xmlns:a16="http://schemas.microsoft.com/office/drawing/2014/main" id="{DC731ED7-5F85-42CB-A69F-0889CEA3331A}"/>
+              </a:ext>
+            </a:extLst>
+          </p:cNvPr>
+          <p:cNvSpPr>
+            <a:spLocks xmlns:a="http://schemas.openxmlformats.org/drawingml/2006/main" noGrp="1"/>
+          </p:cNvSpPr>
+          <p:nvPr/>
+        </p:nvSpPr>
+        <p:spPr>
+          <a:xfrm xmlns:a="http://schemas.openxmlformats.org/drawingml/2006/main">
+            <a:off x="8496300" y="2533650"/>
+            <a:ext cx="2686050" cy="609600"/>
+          </a:xfrm>
+          <a:prstGeom xmlns:a="http://schemas.openxmlformats.org/drawingml/2006/main" prst="rect">
+            <a:avLst/>
+          </a:prstGeom>
+          <a:noFill xmlns:a="http://schemas.openxmlformats.org/drawingml/2006/main"/>
+          <a:ln xmlns:a="http://schemas.openxmlformats.org/drawingml/2006/main" w="0">
+            <a:noFill/>
+            <a:prstDash val="solid"/>
+          </a:ln>
+        </p:spPr>
+        <p:txBody>
+          <a:bodyPr xmlns:a="http://schemas.openxmlformats.org/drawingml/2006/main" anchor="t"/>
+          <a:lstStyle xmlns:a="http://schemas.openxmlformats.org/drawingml/2006/main"/>
+          <a:p xmlns:a="http://schemas.openxmlformats.org/drawingml/2006/main">
+            <a:pPr algn="l">
+              <a:buNone/>
+              <a:defRPr sz="3375" b="1">
+                <a:solidFill>
+                  <a:srgbClr val="3D8DFF"/>
+                </a:solidFill>
+                <a:latin typeface="Arial"/>
+                <a:ea typeface="Arial"/>
+                <a:cs typeface="Arial"/>
+              </a:defRPr>
+            </a:pPr>
+            <a:r>
+              <a:rPr sz="3375" b="1">
+                <a:solidFill>
+                  <a:srgbClr val="3D8DFF"/>
+                </a:solidFill>
+                <a:latin typeface="Arial"/>
+                <a:ea typeface="Arial"/>
+                <a:cs typeface="Arial"/>
+              </a:rPr>
+              <a:t>488 / 508</a:t>
+            </a:r>
+          </a:p>
+        </p:txBody>
+      </p:sp>
+      <p:sp>
+        <p:nvSpPr>
+          <p:cNvPr id="9" name="">
+            <a:extLst xmlns:a="http://schemas.openxmlformats.org/drawingml/2006/main">
+              <a:ext uri="{FF2B5EF4-FFF2-40B4-BE49-F238E27FC236}">
+                <a16:creationId xmlns:a16="http://schemas.microsoft.com/office/drawing/2014/main" id="{406DC0E8-33AD-4797-87D6-8B560493E789}"/>
+              </a:ext>
+            </a:extLst>
+          </p:cNvPr>
+          <p:cNvSpPr>
+            <a:spLocks xmlns:a="http://schemas.openxmlformats.org/drawingml/2006/main" noGrp="1"/>
+          </p:cNvSpPr>
+          <p:nvPr/>
+        </p:nvSpPr>
+        <p:spPr>
+          <a:xfrm xmlns:a="http://schemas.openxmlformats.org/drawingml/2006/main">
+            <a:off x="8496300" y="3105150"/>
+            <a:ext cx="2686050" cy="400050"/>
+          </a:xfrm>
+          <a:prstGeom xmlns:a="http://schemas.openxmlformats.org/drawingml/2006/main" prst="rect">
+            <a:avLst/>
+          </a:prstGeom>
+          <a:noFill xmlns:a="http://schemas.openxmlformats.org/drawingml/2006/main"/>
+          <a:ln xmlns:a="http://schemas.openxmlformats.org/drawingml/2006/main" w="0">
+            <a:noFill/>
+            <a:prstDash val="solid"/>
+          </a:ln>
+        </p:spPr>
+        <p:txBody>
+          <a:bodyPr xmlns:a="http://schemas.openxmlformats.org/drawingml/2006/main" anchor="t"/>
+          <a:lstStyle xmlns:a="http://schemas.openxmlformats.org/drawingml/2006/main"/>
+          <a:p xmlns:a="http://schemas.openxmlformats.org/drawingml/2006/main">
+            <a:pPr algn="l">
+              <a:buNone/>
+              <a:defRPr sz="1725" b="0">
+                <a:solidFill>
+                  <a:srgbClr val="52616B"/>
+                </a:solidFill>
+                <a:latin typeface="Arial"/>
+                <a:ea typeface="Arial"/>
+                <a:cs typeface="Arial"/>
+              </a:defRPr>
+            </a:pPr>
+            <a:r>
+              <a:rPr sz="1725" b="0">
+                <a:solidFill>
+                  <a:srgbClr val="52616B"/>
+                </a:solidFill>
+                <a:latin typeface="Arial"/>
+                <a:ea typeface="Arial"/>
+                <a:cs typeface="Arial"/>
+              </a:rPr>
+              <a:t>weeks shared ≥1 ETF</a:t>
+            </a:r>
+          </a:p>
+        </p:txBody>
+      </p:sp>
+      <p:sp>
+        <p:nvSpPr>
+          <p:cNvPr id="10" name="">
+            <a:extLst xmlns:a="http://schemas.openxmlformats.org/drawingml/2006/main">
+              <a:ext uri="{FF2B5EF4-FFF2-40B4-BE49-F238E27FC236}">
+                <a16:creationId xmlns:a16="http://schemas.microsoft.com/office/drawing/2014/main" id="{A0EB914A-A236-47F4-91E9-BA72FF10432A}"/>
+              </a:ext>
+            </a:extLst>
+          </p:cNvPr>
+          <p:cNvSpPr>
+            <a:spLocks xmlns:a="http://schemas.openxmlformats.org/drawingml/2006/main" noGrp="1"/>
+          </p:cNvSpPr>
+          <p:nvPr/>
+        </p:nvSpPr>
+        <p:spPr>
+          <a:xfrm xmlns:a="http://schemas.openxmlformats.org/drawingml/2006/main">
+            <a:off x="8496300" y="3714750"/>
+            <a:ext cx="2686050" cy="0"/>
+          </a:xfrm>
+          <a:prstGeom xmlns:a="http://schemas.openxmlformats.org/drawingml/2006/main" prst="line">
+            <a:avLst/>
+          </a:prstGeom>
+          <a:noFill xmlns:a="http://schemas.openxmlformats.org/drawingml/2006/main"/>
+          <a:ln xmlns:a="http://schemas.openxmlformats.org/drawingml/2006/main" w="19050">
+            <a:solidFill>
+              <a:srgbClr val="6DCBF4"/>
+            </a:solidFill>
+            <a:prstDash val="solid"/>
+          </a:ln>
+        </p:spPr>
+      </p:sp>
+      <p:sp>
+        <p:nvSpPr>
+          <p:cNvPr id="11" name="">
+            <a:extLst xmlns:a="http://schemas.openxmlformats.org/drawingml/2006/main">
+              <a:ext uri="{FF2B5EF4-FFF2-40B4-BE49-F238E27FC236}">
+                <a16:creationId xmlns:a16="http://schemas.microsoft.com/office/drawing/2014/main" id="{63C90848-627F-4872-9F08-0BCEBC58FC88}"/>
+              </a:ext>
+            </a:extLst>
+          </p:cNvPr>
+          <p:cNvSpPr>
+            <a:spLocks xmlns:a="http://schemas.openxmlformats.org/drawingml/2006/main" noGrp="1"/>
+          </p:cNvSpPr>
+          <p:nvPr/>
+        </p:nvSpPr>
+        <p:spPr>
+          <a:xfrm xmlns:a="http://schemas.openxmlformats.org/drawingml/2006/main">
+            <a:off x="8496300" y="3962400"/>
+            <a:ext cx="2686050" cy="323850"/>
+          </a:xfrm>
+          <a:prstGeom xmlns:a="http://schemas.openxmlformats.org/drawingml/2006/main" prst="rect">
+            <a:avLst/>
+          </a:prstGeom>
+          <a:noFill xmlns:a="http://schemas.openxmlformats.org/drawingml/2006/main"/>
+          <a:ln xmlns:a="http://schemas.openxmlformats.org/drawingml/2006/main" w="0">
+            <a:noFill/>
+            <a:prstDash val="solid"/>
+          </a:ln>
+        </p:spPr>
+        <p:txBody>
+          <a:bodyPr xmlns:a="http://schemas.openxmlformats.org/drawingml/2006/main" anchor="t"/>
+          <a:lstStyle xmlns:a="http://schemas.openxmlformats.org/drawingml/2006/main"/>
+          <a:p xmlns:a="http://schemas.openxmlformats.org/drawingml/2006/main">
+            <a:pPr algn="l">
+              <a:buNone/>
+              <a:defRPr sz="1575" b="1">
+                <a:solidFill>
+                  <a:srgbClr val="101820"/>
+                </a:solidFill>
+                <a:latin typeface="Arial"/>
+                <a:ea typeface="Arial"/>
+                <a:cs typeface="Arial"/>
+              </a:defRPr>
+            </a:pPr>
+            <a:r>
+              <a:rPr sz="1575" b="1">
+                <a:solidFill>
+                  <a:srgbClr val="101820"/>
+                </a:solidFill>
+                <a:latin typeface="Arial"/>
+                <a:ea typeface="Arial"/>
+                <a:cs typeface="Arial"/>
+              </a:rPr>
+              <a:t>Latest decision · 2026-03-18</a:t>
+            </a:r>
+          </a:p>
+        </p:txBody>
+      </p:sp>
+      <p:sp>
+        <p:nvSpPr>
+          <p:cNvPr id="12" name="">
+            <a:extLst xmlns:a="http://schemas.openxmlformats.org/drawingml/2006/main">
+              <a:ext uri="{FF2B5EF4-FFF2-40B4-BE49-F238E27FC236}">
+                <a16:creationId xmlns:a16="http://schemas.microsoft.com/office/drawing/2014/main" id="{70090FDC-931D-4B56-AD5D-C71AA6FC29F9}"/>
+              </a:ext>
+            </a:extLst>
+          </p:cNvPr>
+          <p:cNvSpPr>
+            <a:spLocks xmlns:a="http://schemas.openxmlformats.org/drawingml/2006/main" noGrp="1"/>
+          </p:cNvSpPr>
+          <p:nvPr/>
+        </p:nvSpPr>
+        <p:spPr>
+          <a:xfrm xmlns:a="http://schemas.openxmlformats.org/drawingml/2006/main">
+            <a:off x="8496300" y="4419600"/>
+            <a:ext cx="2686050" cy="1009650"/>
+          </a:xfrm>
+          <a:prstGeom xmlns:a="http://schemas.openxmlformats.org/drawingml/2006/main" prst="rect">
+            <a:avLst/>
+          </a:prstGeom>
+          <a:noFill xmlns:a="http://schemas.openxmlformats.org/drawingml/2006/main"/>
+          <a:ln xmlns:a="http://schemas.openxmlformats.org/drawingml/2006/main" w="0">
+            <a:noFill/>
+            <a:prstDash val="solid"/>
+          </a:ln>
+        </p:spPr>
+        <p:txBody>
+          <a:bodyPr xmlns:a="http://schemas.openxmlformats.org/drawingml/2006/main" anchor="t"/>
+          <a:lstStyle xmlns:a="http://schemas.openxmlformats.org/drawingml/2006/main"/>
+          <a:p xmlns:a="http://schemas.openxmlformats.org/drawingml/2006/main">
+            <a:pPr algn="l">
+              <a:buNone/>
+              <a:defRPr sz="1725" b="0">
+                <a:solidFill>
+                  <a:srgbClr val="52616B"/>
+                </a:solidFill>
+                <a:latin typeface="Arial"/>
+                <a:ea typeface="Arial"/>
+                <a:cs typeface="Arial"/>
+              </a:defRPr>
+            </a:pPr>
+            <a:r>
+              <a:rPr sz="1725" b="0">
+                <a:solidFill>
+                  <a:srgbClr val="52616B"/>
+                </a:solidFill>
+                <a:latin typeface="Arial"/>
+                <a:ea typeface="Arial"/>
+                <a:cs typeface="Arial"/>
+              </a:rPr>
+              <a:t>10w  UUP · GLD · USO</a:t>
+            </a:r>
+          </a:p>
+          <a:p xmlns:a="http://schemas.openxmlformats.org/drawingml/2006/main">
+            <a:pPr algn="l">
+              <a:buNone/>
+              <a:defRPr sz="1725" b="0">
+                <a:solidFill>
+                  <a:srgbClr val="52616B"/>
+                </a:solidFill>
+                <a:latin typeface="Arial"/>
+                <a:ea typeface="Arial"/>
+                <a:cs typeface="Arial"/>
+              </a:defRPr>
+            </a:pPr>
+            <a:r>
+              <a:rPr sz="1725" b="0">
+                <a:solidFill>
+                  <a:srgbClr val="52616B"/>
+                </a:solidFill>
+                <a:latin typeface="Arial"/>
+                <a:ea typeface="Arial"/>
+                <a:cs typeface="Arial"/>
+              </a:rPr>
+              <a:t>25w  GLD · USO · EEM</a:t>
+            </a:r>
+          </a:p>
+          <a:p xmlns:a="http://schemas.openxmlformats.org/drawingml/2006/main">
+            <a:pPr algn="l">
+              <a:buNone/>
+              <a:defRPr sz="1725" b="0">
+                <a:solidFill>
+                  <a:srgbClr val="52616B"/>
+                </a:solidFill>
+                <a:latin typeface="Arial"/>
+                <a:ea typeface="Arial"/>
+                <a:cs typeface="Arial"/>
+              </a:defRPr>
+            </a:pPr>
+            <a:r>
+              <a:rPr sz="1725" b="0">
+                <a:solidFill>
+                  <a:srgbClr val="52616B"/>
+                </a:solidFill>
+                <a:latin typeface="Arial"/>
+                <a:ea typeface="Arial"/>
+                <a:cs typeface="Arial"/>
+              </a:rPr>
+              <a:t>Cash  0%</a:t>
+            </a:r>
+          </a:p>
+        </p:txBody>
+      </p:sp>
+      <p:sp>
+        <p:nvSpPr>
+          <p:cNvPr id="13" name="">
+            <a:extLst xmlns:a="http://schemas.openxmlformats.org/drawingml/2006/main">
+              <a:ext uri="{FF2B5EF4-FFF2-40B4-BE49-F238E27FC236}">
+                <a16:creationId xmlns:a16="http://schemas.microsoft.com/office/drawing/2014/main" id="{F166845D-8E26-4804-AAA3-D76C79B2D4FB}"/>
+              </a:ext>
+            </a:extLst>
+          </p:cNvPr>
+          <p:cNvSpPr>
+            <a:spLocks xmlns:a="http://schemas.openxmlformats.org/drawingml/2006/main" noGrp="1"/>
+          </p:cNvSpPr>
+          <p:nvPr/>
+        </p:nvSpPr>
+        <p:spPr>
+          <a:xfrm xmlns:a="http://schemas.openxmlformats.org/drawingml/2006/main">
+            <a:off x="1066800" y="5886450"/>
+            <a:ext cx="9620250" cy="323850"/>
+          </a:xfrm>
+          <a:prstGeom xmlns:a="http://schemas.openxmlformats.org/drawingml/2006/main" prst="rect">
+            <a:avLst/>
+          </a:prstGeom>
+          <a:noFill xmlns:a="http://schemas.openxmlformats.org/drawingml/2006/main"/>
+          <a:ln xmlns:a="http://schemas.openxmlformats.org/drawingml/2006/main" w="0">
+            <a:noFill/>
+            <a:prstDash val="solid"/>
+          </a:ln>
+        </p:spPr>
+        <p:txBody>
+          <a:bodyPr xmlns:a="http://schemas.openxmlformats.org/drawingml/2006/main" anchor="t"/>
+          <a:lstStyle xmlns:a="http://schemas.openxmlformats.org/drawingml/2006/main"/>
+          <a:p xmlns:a="http://schemas.openxmlformats.org/drawingml/2006/main">
+            <a:pPr algn="ctr">
+              <a:buNone/>
+              <a:defRPr sz="1800" b="1">
+                <a:solidFill>
+                  <a:srgbClr val="101820"/>
+                </a:solidFill>
+                <a:latin typeface="Arial"/>
+                <a:ea typeface="Arial"/>
+                <a:cs typeface="Arial"/>
+              </a:defRPr>
+            </a:pPr>
+            <a:r>
+              <a:rPr sz="1800" b="1">
+                <a:solidFill>
+                  <a:srgbClr val="101820"/>
+                </a:solidFill>
+                <a:latin typeface="Arial"/>
+                <a:ea typeface="Arial"/>
+                <a:cs typeface="Arial"/>
+              </a:rPr>
+              <a:t>Shared selections stack: one ETF can receive two one-sixth slots = one-third.</a:t>
+            </a:r>
+          </a:p>
+        </p:txBody>
+      </p:sp>
+      <p:sp>
+        <p:nvSpPr>
+          <p:cNvPr id="16" name="">
+            <a:extLst xmlns:a="http://schemas.openxmlformats.org/drawingml/2006/main">
+              <a:ext uri="{FF2B5EF4-FFF2-40B4-BE49-F238E27FC236}">
+                <a16:creationId xmlns:a16="http://schemas.microsoft.com/office/drawing/2014/main" id="{CBB05286-4B59-4C91-A588-5CD09F062F89}"/>
+              </a:ext>
+            </a:extLst>
+          </p:cNvPr>
+          <p:cNvSpPr>
+            <a:spLocks xmlns:a="http://schemas.openxmlformats.org/drawingml/2006/main" noGrp="1"/>
+          </p:cNvSpPr>
+          <p:nvPr/>
+        </p:nvSpPr>
+        <p:spPr>
+          <a:xfrm xmlns:a="http://schemas.openxmlformats.org/drawingml/2006/main">
+            <a:off x="11144250" y="6324600"/>
+            <a:ext cx="628650" cy="266700"/>
+          </a:xfrm>
+          <a:prstGeom xmlns:a="http://schemas.openxmlformats.org/drawingml/2006/main" prst="rect">
+            <a:avLst/>
+          </a:prstGeom>
+          <a:noFill xmlns:a="http://schemas.openxmlformats.org/drawingml/2006/main"/>
+          <a:ln xmlns:a="http://schemas.openxmlformats.org/drawingml/2006/main" w="0">
+            <a:noFill/>
+            <a:prstDash val="solid"/>
+          </a:ln>
+        </p:spPr>
+        <p:txBody>
+          <a:bodyPr xmlns:a="http://schemas.openxmlformats.org/drawingml/2006/main" anchor="t"/>
+          <a:lstStyle xmlns:a="http://schemas.openxmlformats.org/drawingml/2006/main"/>
+          <a:p xmlns:a="http://schemas.openxmlformats.org/drawingml/2006/main">
+            <a:pPr algn="r">
+              <a:buNone/>
+              <a:defRPr sz="1200" b="0">
+                <a:solidFill>
+                  <a:srgbClr val="52616B"/>
+                </a:solidFill>
+                <a:latin typeface="Arial"/>
+                <a:ea typeface="Arial"/>
+                <a:cs typeface="Arial"/>
+              </a:defRPr>
+            </a:pPr>
+            <a:r>
+              <a:rPr sz="1200" b="0">
+                <a:solidFill>
+                  <a:srgbClr val="52616B"/>
+                </a:solidFill>
+                <a:latin typeface="Arial"/>
+                <a:ea typeface="Arial"/>
+                <a:cs typeface="Arial"/>
+              </a:rPr>
+              <a:t/>
+            </a:r>
+          </a:p>
+        </p:txBody>
+      </p:sp>
+    </p:spTree>
+    <p:extLst>
+      <p:ext uri="{BB962C8B-B14F-4D97-AF65-F5344CB8AC3E}">
+        <p14:creationId xmlns:p14="http://schemas.microsoft.com/office/powerpoint/2010/main" val="1019663795"/>
+      </p:ext>
+    </p:extLst>
+  </p:cSld>
+</p:sld>
+</file>
+
+<file path=ppt/slides/slide18.xml><?xml version="1.0" encoding="utf-8"?>
+<p:sld xmlns:p="http://schemas.openxmlformats.org/presentationml/2006/main">
+  <p:cSld>
+    <p:bg>
+      <p:bgPr>
+        <a:solidFill xmlns:a="http://schemas.openxmlformats.org/drawingml/2006/main">
+          <a:srgbClr val="FFFFFF"/>
+        </a:solidFill>
+      </p:bgPr>
+    </p:bg>
+    <p:spTree>
+      <p:nvGrpSpPr>
+        <p:cNvPr id="1" name=""/>
+        <p:cNvGrpSpPr/>
+        <p:nvPr/>
+      </p:nvGrpSpPr>
+      <p:grpSpPr>
+        <a:xfrm xmlns:a="http://schemas.openxmlformats.org/drawingml/2006/main"/>
+      </p:grpSpPr>
+      <p:sp>
+        <p:nvSpPr>
+          <p:cNvPr id="16" name="">
+            <a:extLst xmlns:a="http://schemas.openxmlformats.org/drawingml/2006/main">
+              <a:ext uri="{FF2B5EF4-FFF2-40B4-BE49-F238E27FC236}">
+                <a16:creationId xmlns:a16="http://schemas.microsoft.com/office/drawing/2014/main" id="{D2DB7632-9321-4B0D-B49B-BAF52F1D5F3F}"/>
+              </a:ext>
+            </a:extLst>
+          </p:cNvPr>
+          <p:cNvSpPr>
+            <a:spLocks xmlns:a="http://schemas.openxmlformats.org/drawingml/2006/main" noGrp="1"/>
+          </p:cNvSpPr>
+          <p:nvPr/>
+        </p:nvSpPr>
+        <p:spPr>
+          <a:xfrm xmlns:a="http://schemas.openxmlformats.org/drawingml/2006/main">
+            <a:off x="400050" y="228600"/>
+            <a:ext cx="2857500" cy="228600"/>
+          </a:xfrm>
+          <a:prstGeom xmlns:a="http://schemas.openxmlformats.org/drawingml/2006/main" prst="rect">
+            <a:avLst/>
+          </a:prstGeom>
+          <a:noFill xmlns:a="http://schemas.openxmlformats.org/drawingml/2006/main"/>
+          <a:ln xmlns:a="http://schemas.openxmlformats.org/drawingml/2006/main" w="0">
+            <a:noFill/>
+            <a:prstDash val="solid"/>
+          </a:ln>
+        </p:spPr>
+        <p:txBody>
+          <a:bodyPr xmlns:a="http://schemas.openxmlformats.org/drawingml/2006/main" anchor="t"/>
+          <a:lstStyle xmlns:a="http://schemas.openxmlformats.org/drawingml/2006/main"/>
+          <a:p xmlns:a="http://schemas.openxmlformats.org/drawingml/2006/main">
+            <a:pPr algn="l">
+              <a:buNone/>
+              <a:defRPr sz="1200" b="1">
+                <a:solidFill>
+                  <a:srgbClr val="3D8DFF"/>
+                </a:solidFill>
+                <a:latin typeface="Arial"/>
+                <a:ea typeface="Arial"/>
+                <a:cs typeface="Arial"/>
+              </a:defRPr>
+            </a:pPr>
+            <a:r>
+              <a:rPr sz="1200" b="1">
+                <a:solidFill>
+                  <a:srgbClr val="3D8DFF"/>
+                </a:solidFill>
+                <a:latin typeface="Arial"/>
+                <a:ea typeface="Arial"/>
+                <a:cs typeface="Arial"/>
+              </a:rPr>
+              <a:t>LIT-MOM-03.1</a:t>
+            </a:r>
+          </a:p>
+        </p:txBody>
+      </p:sp>
+      <p:sp>
+        <p:nvSpPr>
+          <p:cNvPr id="2" name="">
+            <a:extLst xmlns:a="http://schemas.openxmlformats.org/drawingml/2006/main">
+              <a:ext uri="{FF2B5EF4-FFF2-40B4-BE49-F238E27FC236}">
+                <a16:creationId xmlns:a16="http://schemas.microsoft.com/office/drawing/2014/main" id="{4F6E0FE8-6C1B-4A13-9D2D-6E11399D4DD1}"/>
+              </a:ext>
+            </a:extLst>
+          </p:cNvPr>
+          <p:cNvSpPr>
+            <a:spLocks xmlns:a="http://schemas.openxmlformats.org/drawingml/2006/main" noGrp="1"/>
+          </p:cNvSpPr>
+          <p:nvPr/>
+        </p:nvSpPr>
+        <p:spPr>
+          <a:xfrm xmlns:a="http://schemas.openxmlformats.org/drawingml/2006/main">
+            <a:off x="400050" y="476250"/>
+            <a:ext cx="11049000" cy="819150"/>
+          </a:xfrm>
+          <a:prstGeom xmlns:a="http://schemas.openxmlformats.org/drawingml/2006/main" prst="rect">
+            <a:avLst/>
+          </a:prstGeom>
+          <a:noFill xmlns:a="http://schemas.openxmlformats.org/drawingml/2006/main"/>
+          <a:ln xmlns:a="http://schemas.openxmlformats.org/drawingml/2006/main" w="0">
+            <a:noFill/>
+            <a:prstDash val="solid"/>
+          </a:ln>
+        </p:spPr>
+        <p:txBody>
+          <a:bodyPr xmlns:a="http://schemas.openxmlformats.org/drawingml/2006/main" anchor="t"/>
+          <a:lstStyle xmlns:a="http://schemas.openxmlformats.org/drawingml/2006/main"/>
+          <a:p xmlns:a="http://schemas.openxmlformats.org/drawingml/2006/main">
+            <a:pPr algn="l">
+              <a:buNone/>
+              <a:defRPr sz="2700" b="1">
+                <a:solidFill>
+                  <a:srgbClr val="101820"/>
+                </a:solidFill>
+                <a:latin typeface="Arial"/>
+                <a:ea typeface="Arial"/>
+                <a:cs typeface="Arial"/>
+              </a:defRPr>
+            </a:pPr>
+            <a:r>
+              <a:rPr sz="2700" b="1">
+                <a:solidFill>
+                  <a:srgbClr val="101820"/>
+                </a:solidFill>
+                <a:latin typeface="Arial"/>
+                <a:ea typeface="Arial"/>
+                <a:cs typeface="Arial"/>
+              </a:rPr>
+              <a:t>Mechanics are now inspectable; value-add remains the next question</a:t>
+            </a:r>
+          </a:p>
+        </p:txBody>
+      </p:sp>
+      <p:sp>
+        <p:nvSpPr>
+          <p:cNvPr id="3" name="">
+            <a:extLst xmlns:a="http://schemas.openxmlformats.org/drawingml/2006/main">
+              <a:ext uri="{FF2B5EF4-FFF2-40B4-BE49-F238E27FC236}">
+                <a16:creationId xmlns:a16="http://schemas.microsoft.com/office/drawing/2014/main" id="{0E0B56DB-4E40-4B87-BA34-B14274318353}"/>
+              </a:ext>
+            </a:extLst>
+          </p:cNvPr>
+          <p:cNvSpPr>
+            <a:spLocks xmlns:a="http://schemas.openxmlformats.org/drawingml/2006/main" noGrp="1"/>
+          </p:cNvSpPr>
+          <p:nvPr/>
+        </p:nvSpPr>
+        <p:spPr>
+          <a:xfrm xmlns:a="http://schemas.openxmlformats.org/drawingml/2006/main">
+            <a:off x="400050" y="1428750"/>
+            <a:ext cx="11391900" cy="0"/>
+          </a:xfrm>
+          <a:prstGeom xmlns:a="http://schemas.openxmlformats.org/drawingml/2006/main" prst="line">
+            <a:avLst/>
+          </a:prstGeom>
+          <a:noFill xmlns:a="http://schemas.openxmlformats.org/drawingml/2006/main"/>
+          <a:ln xmlns:a="http://schemas.openxmlformats.org/drawingml/2006/main" w="9525">
+            <a:solidFill>
+              <a:srgbClr val="B8BCC4"/>
+            </a:solidFill>
+            <a:prstDash val="solid"/>
+          </a:ln>
+        </p:spPr>
+      </p:sp>
+      <p:sp>
+        <p:nvSpPr>
+          <p:cNvPr id="4" name="">
+            <a:extLst xmlns:a="http://schemas.openxmlformats.org/drawingml/2006/main">
+              <a:ext uri="{FF2B5EF4-FFF2-40B4-BE49-F238E27FC236}">
+                <a16:creationId xmlns:a16="http://schemas.microsoft.com/office/drawing/2014/main" id="{609465AD-88DC-48BC-BDAC-EBEFA9C8F7B5}"/>
+              </a:ext>
+            </a:extLst>
+          </p:cNvPr>
+          <p:cNvSpPr>
+            <a:spLocks xmlns:a="http://schemas.openxmlformats.org/drawingml/2006/main" noGrp="1"/>
+          </p:cNvSpPr>
+          <p:nvPr/>
+        </p:nvSpPr>
+        <p:spPr>
+          <a:xfrm xmlns:a="http://schemas.openxmlformats.org/drawingml/2006/main">
+            <a:off x="11010900" y="6324600"/>
+            <a:ext cx="762000" cy="266700"/>
+          </a:xfrm>
+          <a:prstGeom xmlns:a="http://schemas.openxmlformats.org/drawingml/2006/main" prst="rect">
+            <a:avLst/>
+          </a:prstGeom>
+          <a:noFill xmlns:a="http://schemas.openxmlformats.org/drawingml/2006/main"/>
+          <a:ln xmlns:a="http://schemas.openxmlformats.org/drawingml/2006/main" w="0">
+            <a:noFill/>
+            <a:prstDash val="solid"/>
+          </a:ln>
+        </p:spPr>
+        <p:txBody>
+          <a:bodyPr xmlns:a="http://schemas.openxmlformats.org/drawingml/2006/main" anchor="t"/>
+          <a:lstStyle xmlns:a="http://schemas.openxmlformats.org/drawingml/2006/main"/>
+          <a:p xmlns:a="http://schemas.openxmlformats.org/drawingml/2006/main">
+            <a:pPr algn="r">
+              <a:buNone/>
+              <a:defRPr sz="1200" b="0">
+                <a:solidFill>
+                  <a:srgbClr val="52616B"/>
+                </a:solidFill>
+                <a:latin typeface="Arial"/>
+                <a:ea typeface="Arial"/>
+                <a:cs typeface="Arial"/>
+              </a:defRPr>
+            </a:pPr>
+            <a:r>
+              <a:rPr sz="1200" b="0">
+                <a:solidFill>
+                  <a:srgbClr val="52616B"/>
+                </a:solidFill>
+                <a:latin typeface="Arial"/>
+                <a:ea typeface="Arial"/>
+                <a:cs typeface="Arial"/>
+              </a:rPr>
+              <a:t>18</a:t>
+            </a:r>
+          </a:p>
+        </p:txBody>
+      </p:sp>
+      <p:sp>
+        <p:nvSpPr>
+          <p:cNvPr id="5" name="">
+            <a:extLst xmlns:a="http://schemas.openxmlformats.org/drawingml/2006/main">
+              <a:ext uri="{FF2B5EF4-FFF2-40B4-BE49-F238E27FC236}">
+                <a16:creationId xmlns:a16="http://schemas.microsoft.com/office/drawing/2014/main" id="{CD393174-0A3C-4E18-A0E5-CFFEAB42B506}"/>
+              </a:ext>
+            </a:extLst>
+          </p:cNvPr>
+          <p:cNvSpPr>
+            <a:spLocks xmlns:a="http://schemas.openxmlformats.org/drawingml/2006/main" noGrp="1"/>
+          </p:cNvSpPr>
+          <p:nvPr/>
+        </p:nvSpPr>
+        <p:spPr>
+          <a:xfrm xmlns:a="http://schemas.openxmlformats.org/drawingml/2006/main">
+            <a:off x="666750" y="1752600"/>
+            <a:ext cx="10858500" cy="1028700"/>
+          </a:xfrm>
+          <a:prstGeom xmlns:a="http://schemas.openxmlformats.org/drawingml/2006/main" prst="rect">
+            <a:avLst/>
+          </a:prstGeom>
+          <a:solidFill xmlns:a="http://schemas.openxmlformats.org/drawingml/2006/main">
+            <a:srgbClr val="E6F2EC"/>
+          </a:solidFill>
+          <a:ln xmlns:a="http://schemas.openxmlformats.org/drawingml/2006/main" w="9525">
+            <a:solidFill>
+              <a:srgbClr val="2E7D5B"/>
+            </a:solidFill>
+            <a:prstDash val="solid"/>
+          </a:ln>
+        </p:spPr>
+      </p:sp>
+      <p:sp>
+        <p:nvSpPr>
+          <p:cNvPr id="6" name="">
+            <a:extLst xmlns:a="http://schemas.openxmlformats.org/drawingml/2006/main">
+              <a:ext uri="{FF2B5EF4-FFF2-40B4-BE49-F238E27FC236}">
+                <a16:creationId xmlns:a16="http://schemas.microsoft.com/office/drawing/2014/main" id="{802C9A30-9CD1-4907-B5B7-2F6BE57885E8}"/>
+              </a:ext>
+            </a:extLst>
+          </p:cNvPr>
+          <p:cNvSpPr>
+            <a:spLocks xmlns:a="http://schemas.openxmlformats.org/drawingml/2006/main" noGrp="1"/>
+          </p:cNvSpPr>
+          <p:nvPr/>
+        </p:nvSpPr>
+        <p:spPr>
+          <a:xfrm xmlns:a="http://schemas.openxmlformats.org/drawingml/2006/main">
+            <a:off x="952500" y="2000250"/>
+            <a:ext cx="2190750" cy="400050"/>
+          </a:xfrm>
+          <a:prstGeom xmlns:a="http://schemas.openxmlformats.org/drawingml/2006/main" prst="rect">
+            <a:avLst/>
+          </a:prstGeom>
+          <a:noFill xmlns:a="http://schemas.openxmlformats.org/drawingml/2006/main"/>
+          <a:ln xmlns:a="http://schemas.openxmlformats.org/drawingml/2006/main" w="0">
+            <a:noFill/>
+            <a:prstDash val="solid"/>
+          </a:ln>
+        </p:spPr>
+        <p:txBody>
+          <a:bodyPr xmlns:a="http://schemas.openxmlformats.org/drawingml/2006/main" anchor="t"/>
+          <a:lstStyle xmlns:a="http://schemas.openxmlformats.org/drawingml/2006/main"/>
+          <a:p xmlns:a="http://schemas.openxmlformats.org/drawingml/2006/main">
+            <a:pPr algn="l">
+              <a:buNone/>
+              <a:defRPr sz="2025" b="1">
+                <a:solidFill>
+                  <a:srgbClr val="2E7D5B"/>
+                </a:solidFill>
+                <a:latin typeface="Arial"/>
+                <a:ea typeface="Arial"/>
+                <a:cs typeface="Arial"/>
+              </a:defRPr>
+            </a:pPr>
+            <a:r>
+              <a:rPr sz="2025" b="1">
+                <a:solidFill>
+                  <a:srgbClr val="2E7D5B"/>
+                </a:solidFill>
+                <a:latin typeface="Arial"/>
+                <a:ea typeface="Arial"/>
+                <a:cs typeface="Arial"/>
+              </a:rPr>
+              <a:t>Established</a:t>
+            </a:r>
+          </a:p>
+        </p:txBody>
+      </p:sp>
+      <p:sp>
+        <p:nvSpPr>
+          <p:cNvPr id="7" name="">
+            <a:extLst xmlns:a="http://schemas.openxmlformats.org/drawingml/2006/main">
+              <a:ext uri="{FF2B5EF4-FFF2-40B4-BE49-F238E27FC236}">
+                <a16:creationId xmlns:a16="http://schemas.microsoft.com/office/drawing/2014/main" id="{4C0B6826-C1CD-407B-B1BD-7E0FDA1C4296}"/>
+              </a:ext>
+            </a:extLst>
+          </p:cNvPr>
+          <p:cNvSpPr>
+            <a:spLocks xmlns:a="http://schemas.openxmlformats.org/drawingml/2006/main" noGrp="1"/>
+          </p:cNvSpPr>
+          <p:nvPr/>
+        </p:nvSpPr>
+        <p:spPr>
+          <a:xfrm xmlns:a="http://schemas.openxmlformats.org/drawingml/2006/main">
+            <a:off x="3276600" y="1943100"/>
+            <a:ext cx="7772400" cy="647700"/>
+          </a:xfrm>
+          <a:prstGeom xmlns:a="http://schemas.openxmlformats.org/drawingml/2006/main" prst="rect">
+            <a:avLst/>
+          </a:prstGeom>
+          <a:noFill xmlns:a="http://schemas.openxmlformats.org/drawingml/2006/main"/>
+          <a:ln xmlns:a="http://schemas.openxmlformats.org/drawingml/2006/main" w="0">
+            <a:noFill/>
+            <a:prstDash val="solid"/>
+          </a:ln>
+        </p:spPr>
+        <p:txBody>
+          <a:bodyPr xmlns:a="http://schemas.openxmlformats.org/drawingml/2006/main" anchor="t"/>
+          <a:lstStyle xmlns:a="http://schemas.openxmlformats.org/drawingml/2006/main"/>
+          <a:p xmlns:a="http://schemas.openxmlformats.org/drawingml/2006/main">
+            <a:pPr algn="l">
+              <a:buNone/>
+              <a:defRPr sz="1725" b="0">
+                <a:solidFill>
+                  <a:srgbClr val="101820"/>
+                </a:solidFill>
+                <a:latin typeface="Arial"/>
+                <a:ea typeface="Arial"/>
+                <a:cs typeface="Arial"/>
+              </a:defRPr>
+            </a:pPr>
+            <a:r>
+              <a:rPr sz="1725" b="0">
+                <a:solidFill>
+                  <a:srgbClr val="101820"/>
+                </a:solidFill>
+                <a:latin typeface="Arial"/>
+                <a:ea typeface="Arial"/>
+                <a:cs typeface="Arial"/>
+              </a:rPr>
+              <a:t>Exact ranks, vetoes, one-sixth slots, duplicate-sleeve stacking, holiday fallback, and next-open designation.</a:t>
+            </a:r>
+          </a:p>
+        </p:txBody>
+      </p:sp>
+      <p:sp>
+        <p:nvSpPr>
+          <p:cNvPr id="8" name="">
+            <a:extLst xmlns:a="http://schemas.openxmlformats.org/drawingml/2006/main">
+              <a:ext uri="{FF2B5EF4-FFF2-40B4-BE49-F238E27FC236}">
+                <a16:creationId xmlns:a16="http://schemas.microsoft.com/office/drawing/2014/main" id="{3AFAF26A-2C8D-481A-8C17-B8A9A3967177}"/>
+              </a:ext>
+            </a:extLst>
+          </p:cNvPr>
+          <p:cNvSpPr>
+            <a:spLocks xmlns:a="http://schemas.openxmlformats.org/drawingml/2006/main" noGrp="1"/>
+          </p:cNvSpPr>
+          <p:nvPr/>
+        </p:nvSpPr>
+        <p:spPr>
+          <a:xfrm xmlns:a="http://schemas.openxmlformats.org/drawingml/2006/main">
+            <a:off x="666750" y="3048000"/>
+            <a:ext cx="10858500" cy="1028700"/>
+          </a:xfrm>
+          <a:prstGeom xmlns:a="http://schemas.openxmlformats.org/drawingml/2006/main" prst="rect">
+            <a:avLst/>
+          </a:prstGeom>
+          <a:solidFill xmlns:a="http://schemas.openxmlformats.org/drawingml/2006/main">
+            <a:srgbClr val="F7E7E2"/>
+          </a:solidFill>
+          <a:ln xmlns:a="http://schemas.openxmlformats.org/drawingml/2006/main" w="9525">
+            <a:solidFill>
+              <a:srgbClr val="C8553D"/>
+            </a:solidFill>
+            <a:prstDash val="solid"/>
+          </a:ln>
+        </p:spPr>
+      </p:sp>
+      <p:sp>
+        <p:nvSpPr>
+          <p:cNvPr id="9" name="">
+            <a:extLst xmlns:a="http://schemas.openxmlformats.org/drawingml/2006/main">
+              <a:ext uri="{FF2B5EF4-FFF2-40B4-BE49-F238E27FC236}">
+                <a16:creationId xmlns:a16="http://schemas.microsoft.com/office/drawing/2014/main" id="{DDE8FBE1-8020-4B7A-932E-FC73716C919B}"/>
+              </a:ext>
+            </a:extLst>
+          </p:cNvPr>
+          <p:cNvSpPr>
+            <a:spLocks xmlns:a="http://schemas.openxmlformats.org/drawingml/2006/main" noGrp="1"/>
+          </p:cNvSpPr>
+          <p:nvPr/>
+        </p:nvSpPr>
+        <p:spPr>
+          <a:xfrm xmlns:a="http://schemas.openxmlformats.org/drawingml/2006/main">
+            <a:off x="952500" y="3295650"/>
+            <a:ext cx="2190750" cy="400050"/>
+          </a:xfrm>
+          <a:prstGeom xmlns:a="http://schemas.openxmlformats.org/drawingml/2006/main" prst="rect">
+            <a:avLst/>
+          </a:prstGeom>
+          <a:noFill xmlns:a="http://schemas.openxmlformats.org/drawingml/2006/main"/>
+          <a:ln xmlns:a="http://schemas.openxmlformats.org/drawingml/2006/main" w="0">
+            <a:noFill/>
+            <a:prstDash val="solid"/>
+          </a:ln>
+        </p:spPr>
+        <p:txBody>
+          <a:bodyPr xmlns:a="http://schemas.openxmlformats.org/drawingml/2006/main" anchor="t"/>
+          <a:lstStyle xmlns:a="http://schemas.openxmlformats.org/drawingml/2006/main"/>
+          <a:p xmlns:a="http://schemas.openxmlformats.org/drawingml/2006/main">
+            <a:pPr algn="l">
+              <a:buNone/>
+              <a:defRPr sz="2025" b="1">
+                <a:solidFill>
+                  <a:srgbClr val="C8553D"/>
+                </a:solidFill>
+                <a:latin typeface="Arial"/>
+                <a:ea typeface="Arial"/>
+                <a:cs typeface="Arial"/>
+              </a:defRPr>
+            </a:pPr>
+            <a:r>
+              <a:rPr sz="2025" b="1">
+                <a:solidFill>
+                  <a:srgbClr val="C8553D"/>
+                </a:solidFill>
+                <a:latin typeface="Arial"/>
+                <a:ea typeface="Arial"/>
+                <a:cs typeface="Arial"/>
+              </a:rPr>
+              <a:t>Not established</a:t>
+            </a:r>
+          </a:p>
+        </p:txBody>
+      </p:sp>
+      <p:sp>
+        <p:nvSpPr>
+          <p:cNvPr id="10" name="">
+            <a:extLst xmlns:a="http://schemas.openxmlformats.org/drawingml/2006/main">
+              <a:ext uri="{FF2B5EF4-FFF2-40B4-BE49-F238E27FC236}">
+                <a16:creationId xmlns:a16="http://schemas.microsoft.com/office/drawing/2014/main" id="{E6DA919C-47F4-4345-87E2-1F6DF9D0EC90}"/>
+              </a:ext>
+            </a:extLst>
+          </p:cNvPr>
+          <p:cNvSpPr>
+            <a:spLocks xmlns:a="http://schemas.openxmlformats.org/drawingml/2006/main" noGrp="1"/>
+          </p:cNvSpPr>
+          <p:nvPr/>
+        </p:nvSpPr>
+        <p:spPr>
+          <a:xfrm xmlns:a="http://schemas.openxmlformats.org/drawingml/2006/main">
+            <a:off x="3276600" y="3238500"/>
+            <a:ext cx="7772400" cy="647700"/>
+          </a:xfrm>
+          <a:prstGeom xmlns:a="http://schemas.openxmlformats.org/drawingml/2006/main" prst="rect">
+            <a:avLst/>
+          </a:prstGeom>
+          <a:noFill xmlns:a="http://schemas.openxmlformats.org/drawingml/2006/main"/>
+          <a:ln xmlns:a="http://schemas.openxmlformats.org/drawingml/2006/main" w="0">
+            <a:noFill/>
+            <a:prstDash val="solid"/>
+          </a:ln>
+        </p:spPr>
+        <p:txBody>
+          <a:bodyPr xmlns:a="http://schemas.openxmlformats.org/drawingml/2006/main" anchor="t"/>
+          <a:lstStyle xmlns:a="http://schemas.openxmlformats.org/drawingml/2006/main"/>
+          <a:p xmlns:a="http://schemas.openxmlformats.org/drawingml/2006/main">
+            <a:pPr algn="l">
+              <a:buNone/>
+              <a:defRPr sz="1725" b="0">
+                <a:solidFill>
+                  <a:srgbClr val="101820"/>
+                </a:solidFill>
+                <a:latin typeface="Arial"/>
+                <a:ea typeface="Arial"/>
+                <a:cs typeface="Arial"/>
+              </a:defRPr>
+            </a:pPr>
+            <a:r>
+              <a:rPr sz="1725" b="0">
+                <a:solidFill>
+                  <a:srgbClr val="101820"/>
+                </a:solidFill>
+                <a:latin typeface="Arial"/>
+                <a:ea typeface="Arial"/>
+                <a:cs typeface="Arial"/>
+              </a:rPr>
+              <a:t>No returns, costs, turnover drag, drawdown, baseline comparison, parameter robustness, or edge claim.</a:t>
+            </a:r>
+          </a:p>
+        </p:txBody>
+      </p:sp>
+      <p:sp>
+        <p:nvSpPr>
+          <p:cNvPr id="11" name="">
+            <a:extLst xmlns:a="http://schemas.openxmlformats.org/drawingml/2006/main">
+              <a:ext uri="{FF2B5EF4-FFF2-40B4-BE49-F238E27FC236}">
+                <a16:creationId xmlns:a16="http://schemas.microsoft.com/office/drawing/2014/main" id="{0879E259-AD91-4B41-8E67-E5334F74BAB8}"/>
+              </a:ext>
+            </a:extLst>
+          </p:cNvPr>
+          <p:cNvSpPr>
+            <a:spLocks xmlns:a="http://schemas.openxmlformats.org/drawingml/2006/main" noGrp="1"/>
+          </p:cNvSpPr>
+          <p:nvPr/>
+        </p:nvSpPr>
+        <p:spPr>
+          <a:xfrm xmlns:a="http://schemas.openxmlformats.org/drawingml/2006/main">
+            <a:off x="666750" y="4343400"/>
+            <a:ext cx="10858500" cy="1028700"/>
+          </a:xfrm>
+          <a:prstGeom xmlns:a="http://schemas.openxmlformats.org/drawingml/2006/main" prst="rect">
+            <a:avLst/>
+          </a:prstGeom>
+          <a:solidFill xmlns:a="http://schemas.openxmlformats.org/drawingml/2006/main">
+            <a:srgbClr val="EDEDED"/>
+          </a:solidFill>
+          <a:ln xmlns:a="http://schemas.openxmlformats.org/drawingml/2006/main" w="9525">
+            <a:solidFill>
+              <a:srgbClr val="52616B"/>
+            </a:solidFill>
+            <a:prstDash val="solid"/>
+          </a:ln>
+        </p:spPr>
+      </p:sp>
+      <p:sp>
+        <p:nvSpPr>
+          <p:cNvPr id="12" name="">
+            <a:extLst xmlns:a="http://schemas.openxmlformats.org/drawingml/2006/main">
+              <a:ext uri="{FF2B5EF4-FFF2-40B4-BE49-F238E27FC236}">
+                <a16:creationId xmlns:a16="http://schemas.microsoft.com/office/drawing/2014/main" id="{FE0E70E3-6874-4441-9FD1-1060221212D9}"/>
+              </a:ext>
+            </a:extLst>
+          </p:cNvPr>
+          <p:cNvSpPr>
+            <a:spLocks xmlns:a="http://schemas.openxmlformats.org/drawingml/2006/main" noGrp="1"/>
+          </p:cNvSpPr>
+          <p:nvPr/>
+        </p:nvSpPr>
+        <p:spPr>
+          <a:xfrm xmlns:a="http://schemas.openxmlformats.org/drawingml/2006/main">
+            <a:off x="952500" y="4591050"/>
+            <a:ext cx="2190750" cy="400050"/>
+          </a:xfrm>
+          <a:prstGeom xmlns:a="http://schemas.openxmlformats.org/drawingml/2006/main" prst="rect">
+            <a:avLst/>
+          </a:prstGeom>
+          <a:noFill xmlns:a="http://schemas.openxmlformats.org/drawingml/2006/main"/>
+          <a:ln xmlns:a="http://schemas.openxmlformats.org/drawingml/2006/main" w="0">
+            <a:noFill/>
+            <a:prstDash val="solid"/>
+          </a:ln>
+        </p:spPr>
+        <p:txBody>
+          <a:bodyPr xmlns:a="http://schemas.openxmlformats.org/drawingml/2006/main" anchor="t"/>
+          <a:lstStyle xmlns:a="http://schemas.openxmlformats.org/drawingml/2006/main"/>
+          <a:p xmlns:a="http://schemas.openxmlformats.org/drawingml/2006/main">
+            <a:pPr algn="l">
+              <a:buNone/>
+              <a:defRPr sz="2025" b="1">
+                <a:solidFill>
+                  <a:srgbClr val="52616B"/>
+                </a:solidFill>
+                <a:latin typeface="Arial"/>
+                <a:ea typeface="Arial"/>
+                <a:cs typeface="Arial"/>
+              </a:defRPr>
+            </a:pPr>
+            <a:r>
+              <a:rPr sz="2025" b="1">
+                <a:solidFill>
+                  <a:srgbClr val="52616B"/>
+                </a:solidFill>
+                <a:latin typeface="Arial"/>
+                <a:ea typeface="Arial"/>
+                <a:cs typeface="Arial"/>
+              </a:rPr>
+              <a:t>Coverage STOP</a:t>
+            </a:r>
+          </a:p>
+        </p:txBody>
+      </p:sp>
+      <p:sp>
+        <p:nvSpPr>
+          <p:cNvPr id="13" name="">
+            <a:extLst xmlns:a="http://schemas.openxmlformats.org/drawingml/2006/main">
+              <a:ext uri="{FF2B5EF4-FFF2-40B4-BE49-F238E27FC236}">
+                <a16:creationId xmlns:a16="http://schemas.microsoft.com/office/drawing/2014/main" id="{7D88D2F7-BBA9-4B06-83BF-EF6C40360B55}"/>
+              </a:ext>
+            </a:extLst>
+          </p:cNvPr>
+          <p:cNvSpPr>
+            <a:spLocks xmlns:a="http://schemas.openxmlformats.org/drawingml/2006/main" noGrp="1"/>
+          </p:cNvSpPr>
+          <p:nvPr/>
+        </p:nvSpPr>
+        <p:spPr>
+          <a:xfrm xmlns:a="http://schemas.openxmlformats.org/drawingml/2006/main">
+            <a:off x="3276600" y="4533900"/>
+            <a:ext cx="7772400" cy="647700"/>
+          </a:xfrm>
+          <a:prstGeom xmlns:a="http://schemas.openxmlformats.org/drawingml/2006/main" prst="rect">
+            <a:avLst/>
+          </a:prstGeom>
+          <a:noFill xmlns:a="http://schemas.openxmlformats.org/drawingml/2006/main"/>
+          <a:ln xmlns:a="http://schemas.openxmlformats.org/drawingml/2006/main" w="0">
+            <a:noFill/>
+            <a:prstDash val="solid"/>
+          </a:ln>
+        </p:spPr>
+        <p:txBody>
+          <a:bodyPr xmlns:a="http://schemas.openxmlformats.org/drawingml/2006/main" anchor="t"/>
+          <a:lstStyle xmlns:a="http://schemas.openxmlformats.org/drawingml/2006/main"/>
+          <a:p xmlns:a="http://schemas.openxmlformats.org/drawingml/2006/main">
+            <a:pPr algn="l">
+              <a:buNone/>
+              <a:defRPr sz="1725" b="0">
+                <a:solidFill>
+                  <a:srgbClr val="101820"/>
+                </a:solidFill>
+                <a:latin typeface="Arial"/>
+                <a:ea typeface="Arial"/>
+                <a:cs typeface="Arial"/>
+              </a:defRPr>
+            </a:pPr>
+            <a:r>
+              <a:rPr sz="1725" b="0">
+                <a:solidFill>
+                  <a:srgbClr val="101820"/>
+                </a:solidFill>
+                <a:latin typeface="Arial"/>
+                <a:ea typeface="Arial"/>
+                <a:cs typeface="Arial"/>
+              </a:rPr>
+              <a:t>The publisher's 2008–2015 segment is unavailable under the current Alpaca account and provider contract.</a:t>
+            </a:r>
+          </a:p>
+        </p:txBody>
+      </p:sp>
+      <p:sp>
+        <p:nvSpPr>
+          <p:cNvPr id="14" name="">
+            <a:extLst xmlns:a="http://schemas.openxmlformats.org/drawingml/2006/main">
+              <a:ext uri="{FF2B5EF4-FFF2-40B4-BE49-F238E27FC236}">
+                <a16:creationId xmlns:a16="http://schemas.microsoft.com/office/drawing/2014/main" id="{F7E3D076-54D1-4B3D-8F4A-D11630B25FFC}"/>
+              </a:ext>
+            </a:extLst>
+          </p:cNvPr>
+          <p:cNvSpPr>
+            <a:spLocks xmlns:a="http://schemas.openxmlformats.org/drawingml/2006/main" noGrp="1"/>
+          </p:cNvSpPr>
+          <p:nvPr/>
+        </p:nvSpPr>
+        <p:spPr>
+          <a:xfrm xmlns:a="http://schemas.openxmlformats.org/drawingml/2006/main">
+            <a:off x="2114550" y="5753100"/>
+            <a:ext cx="7962900" cy="495300"/>
+          </a:xfrm>
+          <a:prstGeom xmlns:a="http://schemas.openxmlformats.org/drawingml/2006/main" prst="rect">
+            <a:avLst/>
+          </a:prstGeom>
+          <a:solidFill xmlns:a="http://schemas.openxmlformats.org/drawingml/2006/main">
+            <a:srgbClr val="EAF5FB"/>
+          </a:solidFill>
+          <a:ln xmlns:a="http://schemas.openxmlformats.org/drawingml/2006/main" w="9525">
+            <a:solidFill>
+              <a:srgbClr val="6DCBF4"/>
+            </a:solidFill>
+            <a:prstDash val="solid"/>
+          </a:ln>
+        </p:spPr>
+      </p:sp>
+      <p:sp>
+        <p:nvSpPr>
+          <p:cNvPr id="15" name="">
+            <a:extLst xmlns:a="http://schemas.openxmlformats.org/drawingml/2006/main">
+              <a:ext uri="{FF2B5EF4-FFF2-40B4-BE49-F238E27FC236}">
+                <a16:creationId xmlns:a16="http://schemas.microsoft.com/office/drawing/2014/main" id="{FF7807EE-5E9A-4AC4-A3F2-FA1CED7A80A8}"/>
+              </a:ext>
+            </a:extLst>
+          </p:cNvPr>
+          <p:cNvSpPr>
+            <a:spLocks xmlns:a="http://schemas.openxmlformats.org/drawingml/2006/main" noGrp="1"/>
+          </p:cNvSpPr>
+          <p:nvPr/>
+        </p:nvSpPr>
+        <p:spPr>
+          <a:xfrm xmlns:a="http://schemas.openxmlformats.org/drawingml/2006/main">
+            <a:off x="2343150" y="5753100"/>
+            <a:ext cx="7505700" cy="457200"/>
+          </a:xfrm>
+          <a:prstGeom xmlns:a="http://schemas.openxmlformats.org/drawingml/2006/main" prst="rect">
+            <a:avLst/>
+          </a:prstGeom>
+          <a:noFill xmlns:a="http://schemas.openxmlformats.org/drawingml/2006/main"/>
+          <a:ln xmlns:a="http://schemas.openxmlformats.org/drawingml/2006/main" w="0">
+            <a:noFill/>
+            <a:prstDash val="solid"/>
+          </a:ln>
+        </p:spPr>
+        <p:txBody>
+          <a:bodyPr xmlns:a="http://schemas.openxmlformats.org/drawingml/2006/main" anchor="t"/>
+          <a:lstStyle xmlns:a="http://schemas.openxmlformats.org/drawingml/2006/main"/>
+          <a:p xmlns:a="http://schemas.openxmlformats.org/drawingml/2006/main">
+            <a:pPr algn="ctr">
+              <a:buNone/>
+              <a:defRPr sz="1350" b="1">
+                <a:solidFill>
+                  <a:srgbClr val="3D8DFF"/>
+                </a:solidFill>
+                <a:latin typeface="Arial"/>
+                <a:ea typeface="Arial"/>
+                <a:cs typeface="Arial"/>
+              </a:defRPr>
+            </a:pPr>
+            <a:r>
+              <a:rPr sz="1350" b="1">
+                <a:solidFill>
+                  <a:srgbClr val="3D8DFF"/>
+                </a:solidFill>
+                <a:latin typeface="Arial"/>
+                <a:ea typeface="Arial"/>
+                <a:cs typeface="Arial"/>
+              </a:rPr>
+              <a:t>Next proposed gate: causal 2016–2026 replay against cash, equal-weight, relative-only, absolute-only, and attainable long-only ownership.</a:t>
+            </a:r>
+          </a:p>
+        </p:txBody>
+      </p:sp>
+    </p:spTree>
+    <p:extLst>
+      <p:ext uri="{BB962C8B-B14F-4D97-AF65-F5344CB8AC3E}">
+        <p14:creationId xmlns:p14="http://schemas.microsoft.com/office/powerpoint/2010/main" val="733918031"/>
       </p:ext>
     </p:extLst>
   </p:cSld>
@@ -8166,6 +11672,7 @@
           <a:lstStyle xmlns:a="http://schemas.openxmlformats.org/drawingml/2006/main"/>
           <a:p xmlns:a="http://schemas.openxmlformats.org/drawingml/2006/main">
             <a:pPr algn="l">
+              <a:buNone/>
               <a:defRPr sz="1200" b="1">
                 <a:solidFill>
                   <a:srgbClr val="3D8DFF"/>
@@ -8222,6 +11729,7 @@
           <a:lstStyle xmlns:a="http://schemas.openxmlformats.org/drawingml/2006/main"/>
           <a:p xmlns:a="http://schemas.openxmlformats.org/drawingml/2006/main">
             <a:pPr algn="l">
+              <a:buNone/>
               <a:defRPr sz="2700" b="1">
                 <a:solidFill>
                   <a:srgbClr val="101820"/>
@@ -8309,6 +11817,7 @@
           <a:lstStyle xmlns:a="http://schemas.openxmlformats.org/drawingml/2006/main"/>
           <a:p xmlns:a="http://schemas.openxmlformats.org/drawingml/2006/main">
             <a:pPr algn="r">
+              <a:buNone/>
               <a:defRPr sz="1200" b="0">
                 <a:solidFill>
                   <a:srgbClr val="52616B"/>
@@ -8365,6 +11874,7 @@
           <a:lstStyle xmlns:a="http://schemas.openxmlformats.org/drawingml/2006/main"/>
           <a:p xmlns:a="http://schemas.openxmlformats.org/drawingml/2006/main">
             <a:pPr algn="l">
+              <a:buNone/>
               <a:defRPr sz="1275" b="1">
                 <a:solidFill>
                   <a:srgbClr val="2E7D5B"/>
@@ -8421,6 +11931,7 @@
           <a:lstStyle xmlns:a="http://schemas.openxmlformats.org/drawingml/2006/main"/>
           <a:p xmlns:a="http://schemas.openxmlformats.org/drawingml/2006/main">
             <a:pPr algn="l">
+              <a:buNone/>
               <a:defRPr sz="2250" b="1">
                 <a:solidFill>
                   <a:srgbClr val="101820"/>
@@ -8510,6 +12021,7 @@
           <a:lstStyle xmlns:a="http://schemas.openxmlformats.org/drawingml/2006/main"/>
           <a:p xmlns:a="http://schemas.openxmlformats.org/drawingml/2006/main">
             <a:pPr algn="ctr">
+              <a:buNone/>
               <a:defRPr sz="2025" b="1">
                 <a:solidFill>
                   <a:srgbClr val="2E7D5B"/>
@@ -8566,6 +12078,7 @@
           <a:lstStyle xmlns:a="http://schemas.openxmlformats.org/drawingml/2006/main"/>
           <a:p xmlns:a="http://schemas.openxmlformats.org/drawingml/2006/main">
             <a:pPr algn="l">
+              <a:buNone/>
               <a:defRPr sz="1275" b="1">
                 <a:solidFill>
                   <a:srgbClr val="C8553D"/>
@@ -8622,6 +12135,7 @@
           <a:lstStyle xmlns:a="http://schemas.openxmlformats.org/drawingml/2006/main"/>
           <a:p xmlns:a="http://schemas.openxmlformats.org/drawingml/2006/main">
             <a:pPr algn="l">
+              <a:buNone/>
               <a:defRPr sz="2250" b="1">
                 <a:solidFill>
                   <a:srgbClr val="101820"/>
@@ -8711,6 +12225,7 @@
           <a:lstStyle xmlns:a="http://schemas.openxmlformats.org/drawingml/2006/main"/>
           <a:p xmlns:a="http://schemas.openxmlformats.org/drawingml/2006/main">
             <a:pPr algn="ctr">
+              <a:buNone/>
               <a:defRPr sz="2025" b="1">
                 <a:solidFill>
                   <a:srgbClr val="C8553D"/>
@@ -8767,6 +12282,7 @@
           <a:lstStyle xmlns:a="http://schemas.openxmlformats.org/drawingml/2006/main"/>
           <a:p xmlns:a="http://schemas.openxmlformats.org/drawingml/2006/main">
             <a:pPr algn="ctr">
+              <a:buNone/>
               <a:defRPr sz="2025" b="1">
                 <a:solidFill>
                   <a:srgbClr val="101820"/>
@@ -8852,6 +12368,7 @@
           <a:lstStyle xmlns:a="http://schemas.openxmlformats.org/drawingml/2006/main"/>
           <a:p xmlns:a="http://schemas.openxmlformats.org/drawingml/2006/main">
             <a:pPr algn="l">
+              <a:buNone/>
               <a:defRPr sz="1200" b="1">
                 <a:solidFill>
                   <a:srgbClr val="3D8DFF"/>
@@ -8908,6 +12425,7 @@
           <a:lstStyle xmlns:a="http://schemas.openxmlformats.org/drawingml/2006/main"/>
           <a:p xmlns:a="http://schemas.openxmlformats.org/drawingml/2006/main">
             <a:pPr algn="l">
+              <a:buNone/>
               <a:defRPr sz="2700" b="1">
                 <a:solidFill>
                   <a:srgbClr val="101820"/>
@@ -8995,6 +12513,7 @@
           <a:lstStyle xmlns:a="http://schemas.openxmlformats.org/drawingml/2006/main"/>
           <a:p xmlns:a="http://schemas.openxmlformats.org/drawingml/2006/main">
             <a:pPr algn="r">
+              <a:buNone/>
               <a:defRPr sz="1200" b="0">
                 <a:solidFill>
                   <a:srgbClr val="52616B"/>
@@ -9051,6 +12570,7 @@
           <a:lstStyle xmlns:a="http://schemas.openxmlformats.org/drawingml/2006/main"/>
           <a:p xmlns:a="http://schemas.openxmlformats.org/drawingml/2006/main">
             <a:pPr algn="l">
+              <a:buNone/>
               <a:defRPr sz="1275" b="1">
                 <a:solidFill>
                   <a:srgbClr val="C8553D"/>
@@ -9140,6 +12660,7 @@
           <a:lstStyle xmlns:a="http://schemas.openxmlformats.org/drawingml/2006/main"/>
           <a:p xmlns:a="http://schemas.openxmlformats.org/drawingml/2006/main">
             <a:pPr algn="ctr">
+              <a:buNone/>
               <a:defRPr sz="2550" b="1">
                 <a:solidFill>
                   <a:srgbClr val="101820"/>
@@ -9163,6 +12684,7 @@
           </a:p>
           <a:p xmlns:a="http://schemas.openxmlformats.org/drawingml/2006/main">
             <a:pPr algn="ctr">
+              <a:buNone/>
               <a:defRPr sz="2550" b="1">
                 <a:solidFill>
                   <a:srgbClr val="101820"/>
@@ -9219,6 +12741,7 @@
           <a:lstStyle xmlns:a="http://schemas.openxmlformats.org/drawingml/2006/main"/>
           <a:p xmlns:a="http://schemas.openxmlformats.org/drawingml/2006/main">
             <a:pPr algn="ctr">
+              <a:buNone/>
               <a:defRPr sz="1650" b="0">
                 <a:solidFill>
                   <a:srgbClr val="C8553D"/>
@@ -9399,6 +12922,7 @@
           <a:lstStyle xmlns:a="http://schemas.openxmlformats.org/drawingml/2006/main"/>
           <a:p xmlns:a="http://schemas.openxmlformats.org/drawingml/2006/main">
             <a:pPr algn="l">
+              <a:buNone/>
               <a:defRPr sz="1275" b="1">
                 <a:solidFill>
                   <a:srgbClr val="3D8DFF"/>
@@ -10448,6 +13972,7 @@
           <a:lstStyle xmlns:a="http://schemas.openxmlformats.org/drawingml/2006/main"/>
           <a:p xmlns:a="http://schemas.openxmlformats.org/drawingml/2006/main">
             <a:pPr algn="ctr">
+              <a:buNone/>
               <a:defRPr sz="1725" b="1">
                 <a:solidFill>
                   <a:srgbClr val="101820"/>
@@ -10504,6 +14029,7 @@
           <a:lstStyle xmlns:a="http://schemas.openxmlformats.org/drawingml/2006/main"/>
           <a:p xmlns:a="http://schemas.openxmlformats.org/drawingml/2006/main">
             <a:pPr algn="ctr">
+              <a:buNone/>
               <a:defRPr sz="2100" b="1">
                 <a:solidFill>
                   <a:srgbClr val="101820"/>
@@ -10589,6 +14115,7 @@
           <a:lstStyle xmlns:a="http://schemas.openxmlformats.org/drawingml/2006/main"/>
           <a:p xmlns:a="http://schemas.openxmlformats.org/drawingml/2006/main">
             <a:pPr algn="l">
+              <a:buNone/>
               <a:defRPr sz="1200" b="1">
                 <a:solidFill>
                   <a:srgbClr val="3D8DFF"/>
@@ -10645,6 +14172,7 @@
           <a:lstStyle xmlns:a="http://schemas.openxmlformats.org/drawingml/2006/main"/>
           <a:p xmlns:a="http://schemas.openxmlformats.org/drawingml/2006/main">
             <a:pPr algn="l">
+              <a:buNone/>
               <a:defRPr sz="2700" b="1">
                 <a:solidFill>
                   <a:srgbClr val="101820"/>
@@ -10732,6 +14260,7 @@
           <a:lstStyle xmlns:a="http://schemas.openxmlformats.org/drawingml/2006/main"/>
           <a:p xmlns:a="http://schemas.openxmlformats.org/drawingml/2006/main">
             <a:pPr algn="r">
+              <a:buNone/>
               <a:defRPr sz="1200" b="0">
                 <a:solidFill>
                   <a:srgbClr val="52616B"/>
@@ -10821,6 +14350,7 @@
           <a:lstStyle xmlns:a="http://schemas.openxmlformats.org/drawingml/2006/main"/>
           <a:p xmlns:a="http://schemas.openxmlformats.org/drawingml/2006/main">
             <a:pPr algn="l">
+              <a:buNone/>
               <a:defRPr sz="1350" b="1">
                 <a:solidFill>
                   <a:srgbClr val="3D8DFF"/>
@@ -10877,6 +14407,7 @@
           <a:lstStyle xmlns:a="http://schemas.openxmlformats.org/drawingml/2006/main"/>
           <a:p xmlns:a="http://schemas.openxmlformats.org/drawingml/2006/main">
             <a:pPr algn="l">
+              <a:buNone/>
               <a:defRPr sz="1725" b="1">
                 <a:solidFill>
                   <a:srgbClr val="101820"/>
@@ -10933,6 +14464,7 @@
           <a:lstStyle xmlns:a="http://schemas.openxmlformats.org/drawingml/2006/main"/>
           <a:p xmlns:a="http://schemas.openxmlformats.org/drawingml/2006/main">
             <a:pPr algn="l">
+              <a:buNone/>
               <a:defRPr sz="1575" b="0">
                 <a:solidFill>
                   <a:srgbClr val="52616B"/>
@@ -11022,6 +14554,7 @@
           <a:lstStyle xmlns:a="http://schemas.openxmlformats.org/drawingml/2006/main"/>
           <a:p xmlns:a="http://schemas.openxmlformats.org/drawingml/2006/main">
             <a:pPr algn="l">
+              <a:buNone/>
               <a:defRPr sz="1350" b="1">
                 <a:solidFill>
                   <a:srgbClr val="3D8DFF"/>
@@ -11078,6 +14611,7 @@
           <a:lstStyle xmlns:a="http://schemas.openxmlformats.org/drawingml/2006/main"/>
           <a:p xmlns:a="http://schemas.openxmlformats.org/drawingml/2006/main">
             <a:pPr algn="l">
+              <a:buNone/>
               <a:defRPr sz="1725" b="1">
                 <a:solidFill>
                   <a:srgbClr val="101820"/>
@@ -11134,6 +14668,7 @@
           <a:lstStyle xmlns:a="http://schemas.openxmlformats.org/drawingml/2006/main"/>
           <a:p xmlns:a="http://schemas.openxmlformats.org/drawingml/2006/main">
             <a:pPr algn="l">
+              <a:buNone/>
               <a:defRPr sz="1575" b="0">
                 <a:solidFill>
                   <a:srgbClr val="52616B"/>
@@ -11223,6 +14758,7 @@
           <a:lstStyle xmlns:a="http://schemas.openxmlformats.org/drawingml/2006/main"/>
           <a:p xmlns:a="http://schemas.openxmlformats.org/drawingml/2006/main">
             <a:pPr algn="l">
+              <a:buNone/>
               <a:defRPr sz="1350" b="1">
                 <a:solidFill>
                   <a:srgbClr val="C8553D"/>
@@ -11279,6 +14815,7 @@
           <a:lstStyle xmlns:a="http://schemas.openxmlformats.org/drawingml/2006/main"/>
           <a:p xmlns:a="http://schemas.openxmlformats.org/drawingml/2006/main">
             <a:pPr algn="l">
+              <a:buNone/>
               <a:defRPr sz="1725" b="1">
                 <a:solidFill>
                   <a:srgbClr val="101820"/>
@@ -11335,6 +14872,7 @@
           <a:lstStyle xmlns:a="http://schemas.openxmlformats.org/drawingml/2006/main"/>
           <a:p xmlns:a="http://schemas.openxmlformats.org/drawingml/2006/main">
             <a:pPr algn="l">
+              <a:buNone/>
               <a:defRPr sz="1575" b="0">
                 <a:solidFill>
                   <a:srgbClr val="52616B"/>
@@ -11420,6 +14958,7 @@
           <a:lstStyle xmlns:a="http://schemas.openxmlformats.org/drawingml/2006/main"/>
           <a:p xmlns:a="http://schemas.openxmlformats.org/drawingml/2006/main">
             <a:pPr algn="l">
+              <a:buNone/>
               <a:defRPr sz="1200" b="1">
                 <a:solidFill>
                   <a:srgbClr val="3D8DFF"/>
@@ -11476,6 +15015,7 @@
           <a:lstStyle xmlns:a="http://schemas.openxmlformats.org/drawingml/2006/main"/>
           <a:p xmlns:a="http://schemas.openxmlformats.org/drawingml/2006/main">
             <a:pPr algn="l">
+              <a:buNone/>
               <a:defRPr sz="2700" b="1">
                 <a:solidFill>
                   <a:srgbClr val="101820"/>
@@ -11563,6 +15103,7 @@
           <a:lstStyle xmlns:a="http://schemas.openxmlformats.org/drawingml/2006/main"/>
           <a:p xmlns:a="http://schemas.openxmlformats.org/drawingml/2006/main">
             <a:pPr algn="r">
+              <a:buNone/>
               <a:defRPr sz="1200" b="0">
                 <a:solidFill>
                   <a:srgbClr val="52616B"/>
@@ -11652,6 +15193,7 @@
           <a:lstStyle xmlns:a="http://schemas.openxmlformats.org/drawingml/2006/main"/>
           <a:p xmlns:a="http://schemas.openxmlformats.org/drawingml/2006/main">
             <a:pPr algn="l">
+              <a:buNone/>
               <a:defRPr sz="1650" b="1">
                 <a:solidFill>
                   <a:srgbClr val="3D8DFF"/>
@@ -11708,6 +15250,7 @@
           <a:lstStyle xmlns:a="http://schemas.openxmlformats.org/drawingml/2006/main"/>
           <a:p xmlns:a="http://schemas.openxmlformats.org/drawingml/2006/main">
             <a:pPr algn="l">
+              <a:buNone/>
               <a:defRPr sz="2100" b="1">
                 <a:solidFill>
                   <a:srgbClr val="101820"/>
@@ -11764,6 +15307,7 @@
           <a:lstStyle xmlns:a="http://schemas.openxmlformats.org/drawingml/2006/main"/>
           <a:p xmlns:a="http://schemas.openxmlformats.org/drawingml/2006/main">
             <a:pPr algn="l">
+              <a:buNone/>
               <a:defRPr sz="1575" b="0">
                 <a:solidFill>
                   <a:srgbClr val="52616B"/>
@@ -11853,6 +15397,7 @@
           <a:lstStyle xmlns:a="http://schemas.openxmlformats.org/drawingml/2006/main"/>
           <a:p xmlns:a="http://schemas.openxmlformats.org/drawingml/2006/main">
             <a:pPr algn="l">
+              <a:buNone/>
               <a:defRPr sz="1650" b="1">
                 <a:solidFill>
                   <a:srgbClr val="3D8DFF"/>
@@ -11909,6 +15454,7 @@
           <a:lstStyle xmlns:a="http://schemas.openxmlformats.org/drawingml/2006/main"/>
           <a:p xmlns:a="http://schemas.openxmlformats.org/drawingml/2006/main">
             <a:pPr algn="l">
+              <a:buNone/>
               <a:defRPr sz="2100" b="1">
                 <a:solidFill>
                   <a:srgbClr val="101820"/>
@@ -11965,6 +15511,7 @@
           <a:lstStyle xmlns:a="http://schemas.openxmlformats.org/drawingml/2006/main"/>
           <a:p xmlns:a="http://schemas.openxmlformats.org/drawingml/2006/main">
             <a:pPr algn="l">
+              <a:buNone/>
               <a:defRPr sz="1575" b="0">
                 <a:solidFill>
                   <a:srgbClr val="52616B"/>
@@ -12054,6 +15601,7 @@
           <a:lstStyle xmlns:a="http://schemas.openxmlformats.org/drawingml/2006/main"/>
           <a:p xmlns:a="http://schemas.openxmlformats.org/drawingml/2006/main">
             <a:pPr algn="l">
+              <a:buNone/>
               <a:defRPr sz="1650" b="1">
                 <a:solidFill>
                   <a:srgbClr val="C8553D"/>
@@ -12110,6 +15658,7 @@
           <a:lstStyle xmlns:a="http://schemas.openxmlformats.org/drawingml/2006/main"/>
           <a:p xmlns:a="http://schemas.openxmlformats.org/drawingml/2006/main">
             <a:pPr algn="l">
+              <a:buNone/>
               <a:defRPr sz="2100" b="1">
                 <a:solidFill>
                   <a:srgbClr val="101820"/>
@@ -12166,6 +15715,7 @@
           <a:lstStyle xmlns:a="http://schemas.openxmlformats.org/drawingml/2006/main"/>
           <a:p xmlns:a="http://schemas.openxmlformats.org/drawingml/2006/main">
             <a:pPr algn="l">
+              <a:buNone/>
               <a:defRPr sz="1575" b="0">
                 <a:solidFill>
                   <a:srgbClr val="52616B"/>
@@ -12255,6 +15805,7 @@
           <a:lstStyle xmlns:a="http://schemas.openxmlformats.org/drawingml/2006/main"/>
           <a:p xmlns:a="http://schemas.openxmlformats.org/drawingml/2006/main">
             <a:pPr algn="l">
+              <a:buNone/>
               <a:defRPr sz="1650" b="1">
                 <a:solidFill>
                   <a:srgbClr val="3D8DFF"/>
@@ -12311,6 +15862,7 @@
           <a:lstStyle xmlns:a="http://schemas.openxmlformats.org/drawingml/2006/main"/>
           <a:p xmlns:a="http://schemas.openxmlformats.org/drawingml/2006/main">
             <a:pPr algn="l">
+              <a:buNone/>
               <a:defRPr sz="2100" b="1">
                 <a:solidFill>
                   <a:srgbClr val="101820"/>
@@ -12367,6 +15919,7 @@
           <a:lstStyle xmlns:a="http://schemas.openxmlformats.org/drawingml/2006/main"/>
           <a:p xmlns:a="http://schemas.openxmlformats.org/drawingml/2006/main">
             <a:pPr algn="l">
+              <a:buNone/>
               <a:defRPr sz="1575" b="0">
                 <a:solidFill>
                   <a:srgbClr val="52616B"/>
@@ -12452,6 +16005,7 @@
           <a:lstStyle xmlns:a="http://schemas.openxmlformats.org/drawingml/2006/main"/>
           <a:p xmlns:a="http://schemas.openxmlformats.org/drawingml/2006/main">
             <a:pPr algn="l">
+              <a:buNone/>
               <a:defRPr sz="1200" b="1">
                 <a:solidFill>
                   <a:srgbClr val="3D8DFF"/>
@@ -12508,6 +16062,7 @@
           <a:lstStyle xmlns:a="http://schemas.openxmlformats.org/drawingml/2006/main"/>
           <a:p xmlns:a="http://schemas.openxmlformats.org/drawingml/2006/main">
             <a:pPr algn="l">
+              <a:buNone/>
               <a:defRPr sz="2700" b="1">
                 <a:solidFill>
                   <a:srgbClr val="101820"/>
@@ -12595,6 +16150,7 @@
           <a:lstStyle xmlns:a="http://schemas.openxmlformats.org/drawingml/2006/main"/>
           <a:p xmlns:a="http://schemas.openxmlformats.org/drawingml/2006/main">
             <a:pPr algn="r">
+              <a:buNone/>
               <a:defRPr sz="1200" b="0">
                 <a:solidFill>
                   <a:srgbClr val="52616B"/>
@@ -12651,6 +16207,7 @@
           <a:lstStyle xmlns:a="http://schemas.openxmlformats.org/drawingml/2006/main"/>
           <a:p xmlns:a="http://schemas.openxmlformats.org/drawingml/2006/main">
             <a:pPr algn="l">
+              <a:buNone/>
               <a:defRPr sz="2325" b="1">
                 <a:solidFill>
                   <a:srgbClr val="101820"/>
@@ -12707,6 +16264,7 @@
           <a:lstStyle xmlns:a="http://schemas.openxmlformats.org/drawingml/2006/main"/>
           <a:p xmlns:a="http://schemas.openxmlformats.org/drawingml/2006/main">
             <a:pPr algn="l">
+              <a:buNone/>
               <a:defRPr sz="1875" b="0">
                 <a:solidFill>
                   <a:srgbClr val="52616B"/>
@@ -12796,6 +16354,7 @@
           <a:lstStyle xmlns:a="http://schemas.openxmlformats.org/drawingml/2006/main"/>
           <a:p xmlns:a="http://schemas.openxmlformats.org/drawingml/2006/main">
             <a:pPr algn="l">
+              <a:buNone/>
               <a:defRPr sz="1575" b="1">
                 <a:solidFill>
                   <a:srgbClr val="101820"/>
@@ -12852,6 +16411,7 @@
           <a:lstStyle xmlns:a="http://schemas.openxmlformats.org/drawingml/2006/main"/>
           <a:p xmlns:a="http://schemas.openxmlformats.org/drawingml/2006/main">
             <a:pPr algn="l">
+              <a:buNone/>
               <a:defRPr sz="1500" b="0">
                 <a:solidFill>
                   <a:srgbClr val="52616B"/>
@@ -12941,6 +16501,7 @@
           <a:lstStyle xmlns:a="http://schemas.openxmlformats.org/drawingml/2006/main"/>
           <a:p xmlns:a="http://schemas.openxmlformats.org/drawingml/2006/main">
             <a:pPr algn="l">
+              <a:buNone/>
               <a:defRPr sz="1575" b="1">
                 <a:solidFill>
                   <a:srgbClr val="101820"/>
@@ -12997,6 +16558,7 @@
           <a:lstStyle xmlns:a="http://schemas.openxmlformats.org/drawingml/2006/main"/>
           <a:p xmlns:a="http://schemas.openxmlformats.org/drawingml/2006/main">
             <a:pPr algn="l">
+              <a:buNone/>
               <a:defRPr sz="1500" b="0">
                 <a:solidFill>
                   <a:srgbClr val="52616B"/>
@@ -13086,6 +16648,7 @@
           <a:lstStyle xmlns:a="http://schemas.openxmlformats.org/drawingml/2006/main"/>
           <a:p xmlns:a="http://schemas.openxmlformats.org/drawingml/2006/main">
             <a:pPr algn="l">
+              <a:buNone/>
               <a:defRPr sz="1575" b="1">
                 <a:solidFill>
                   <a:srgbClr val="101820"/>
@@ -13142,6 +16705,7 @@
           <a:lstStyle xmlns:a="http://schemas.openxmlformats.org/drawingml/2006/main"/>
           <a:p xmlns:a="http://schemas.openxmlformats.org/drawingml/2006/main">
             <a:pPr algn="l">
+              <a:buNone/>
               <a:defRPr sz="1500" b="0">
                 <a:solidFill>
                   <a:srgbClr val="52616B"/>
@@ -13231,6 +16795,7 @@
           <a:lstStyle xmlns:a="http://schemas.openxmlformats.org/drawingml/2006/main"/>
           <a:p xmlns:a="http://schemas.openxmlformats.org/drawingml/2006/main">
             <a:pPr algn="l">
+              <a:buNone/>
               <a:defRPr sz="1575" b="1">
                 <a:solidFill>
                   <a:srgbClr val="C8553D"/>
@@ -13287,6 +16852,7 @@
           <a:lstStyle xmlns:a="http://schemas.openxmlformats.org/drawingml/2006/main"/>
           <a:p xmlns:a="http://schemas.openxmlformats.org/drawingml/2006/main">
             <a:pPr algn="l">
+              <a:buNone/>
               <a:defRPr sz="1500" b="0">
                 <a:solidFill>
                   <a:srgbClr val="52616B"/>
@@ -13372,6 +16938,7 @@
           <a:lstStyle xmlns:a="http://schemas.openxmlformats.org/drawingml/2006/main"/>
           <a:p xmlns:a="http://schemas.openxmlformats.org/drawingml/2006/main">
             <a:pPr algn="l">
+              <a:buNone/>
               <a:defRPr sz="1200" b="1">
                 <a:solidFill>
                   <a:srgbClr val="3D8DFF"/>
@@ -13428,6 +16995,7 @@
           <a:lstStyle xmlns:a="http://schemas.openxmlformats.org/drawingml/2006/main"/>
           <a:p xmlns:a="http://schemas.openxmlformats.org/drawingml/2006/main">
             <a:pPr algn="l">
+              <a:buNone/>
               <a:defRPr sz="2700" b="1">
                 <a:solidFill>
                   <a:srgbClr val="101820"/>
@@ -13515,6 +17083,7 @@
           <a:lstStyle xmlns:a="http://schemas.openxmlformats.org/drawingml/2006/main"/>
           <a:p xmlns:a="http://schemas.openxmlformats.org/drawingml/2006/main">
             <a:pPr algn="r">
+              <a:buNone/>
               <a:defRPr sz="1200" b="0">
                 <a:solidFill>
                   <a:srgbClr val="52616B"/>
@@ -13637,6 +17206,7 @@
           <a:lstStyle xmlns:a="http://schemas.openxmlformats.org/drawingml/2006/main"/>
           <a:p xmlns:a="http://schemas.openxmlformats.org/drawingml/2006/main">
             <a:pPr algn="l">
+              <a:buNone/>
               <a:defRPr sz="2175" b="1">
                 <a:solidFill>
                   <a:srgbClr val="101820"/>
@@ -13693,6 +17263,7 @@
           <a:lstStyle xmlns:a="http://schemas.openxmlformats.org/drawingml/2006/main"/>
           <a:p xmlns:a="http://schemas.openxmlformats.org/drawingml/2006/main">
             <a:pPr algn="l">
+              <a:buNone/>
               <a:defRPr sz="1650" b="0">
                 <a:solidFill>
                   <a:srgbClr val="52616B"/>
@@ -13815,6 +17386,7 @@
           <a:lstStyle xmlns:a="http://schemas.openxmlformats.org/drawingml/2006/main"/>
           <a:p xmlns:a="http://schemas.openxmlformats.org/drawingml/2006/main">
             <a:pPr algn="l">
+              <a:buNone/>
               <a:defRPr sz="2175" b="1">
                 <a:solidFill>
                   <a:srgbClr val="101820"/>
@@ -13871,6 +17443,7 @@
           <a:lstStyle xmlns:a="http://schemas.openxmlformats.org/drawingml/2006/main"/>
           <a:p xmlns:a="http://schemas.openxmlformats.org/drawingml/2006/main">
             <a:pPr algn="l">
+              <a:buNone/>
               <a:defRPr sz="1650" b="0">
                 <a:solidFill>
                   <a:srgbClr val="52616B"/>
@@ -13993,6 +17566,7 @@
           <a:lstStyle xmlns:a="http://schemas.openxmlformats.org/drawingml/2006/main"/>
           <a:p xmlns:a="http://schemas.openxmlformats.org/drawingml/2006/main">
             <a:pPr algn="l">
+              <a:buNone/>
               <a:defRPr sz="2175" b="1">
                 <a:solidFill>
                   <a:srgbClr val="101820"/>
@@ -14049,6 +17623,7 @@
           <a:lstStyle xmlns:a="http://schemas.openxmlformats.org/drawingml/2006/main"/>
           <a:p xmlns:a="http://schemas.openxmlformats.org/drawingml/2006/main">
             <a:pPr algn="l">
+              <a:buNone/>
               <a:defRPr sz="1650" b="0">
                 <a:solidFill>
                   <a:srgbClr val="52616B"/>
@@ -14105,6 +17680,7 @@
           <a:lstStyle xmlns:a="http://schemas.openxmlformats.org/drawingml/2006/main"/>
           <a:p xmlns:a="http://schemas.openxmlformats.org/drawingml/2006/main">
             <a:pPr algn="ctr">
+              <a:buNone/>
               <a:defRPr sz="2100" b="1">
                 <a:solidFill>
                   <a:srgbClr val="101820"/>
@@ -14190,6 +17766,7 @@
           <a:lstStyle xmlns:a="http://schemas.openxmlformats.org/drawingml/2006/main"/>
           <a:p xmlns:a="http://schemas.openxmlformats.org/drawingml/2006/main">
             <a:pPr algn="l">
+              <a:buNone/>
               <a:defRPr sz="1200" b="1">
                 <a:solidFill>
                   <a:srgbClr val="3D8DFF"/>
@@ -14246,6 +17823,7 @@
           <a:lstStyle xmlns:a="http://schemas.openxmlformats.org/drawingml/2006/main"/>
           <a:p xmlns:a="http://schemas.openxmlformats.org/drawingml/2006/main">
             <a:pPr algn="l">
+              <a:buNone/>
               <a:defRPr sz="2700" b="1">
                 <a:solidFill>
                   <a:srgbClr val="101820"/>
@@ -14333,6 +17911,7 @@
           <a:lstStyle xmlns:a="http://schemas.openxmlformats.org/drawingml/2006/main"/>
           <a:p xmlns:a="http://schemas.openxmlformats.org/drawingml/2006/main">
             <a:pPr algn="r">
+              <a:buNone/>
               <a:defRPr sz="1200" b="0">
                 <a:solidFill>
                   <a:srgbClr val="52616B"/>
@@ -14455,6 +18034,7 @@
           <a:lstStyle xmlns:a="http://schemas.openxmlformats.org/drawingml/2006/main"/>
           <a:p xmlns:a="http://schemas.openxmlformats.org/drawingml/2006/main">
             <a:pPr algn="l">
+              <a:buNone/>
               <a:defRPr sz="2175" b="1">
                 <a:solidFill>
                   <a:srgbClr val="101820"/>
@@ -14511,6 +18091,7 @@
           <a:lstStyle xmlns:a="http://schemas.openxmlformats.org/drawingml/2006/main"/>
           <a:p xmlns:a="http://schemas.openxmlformats.org/drawingml/2006/main">
             <a:pPr algn="l">
+              <a:buNone/>
               <a:defRPr sz="1650" b="0">
                 <a:solidFill>
                   <a:srgbClr val="52616B"/>
@@ -14633,6 +18214,7 @@
           <a:lstStyle xmlns:a="http://schemas.openxmlformats.org/drawingml/2006/main"/>
           <a:p xmlns:a="http://schemas.openxmlformats.org/drawingml/2006/main">
             <a:pPr algn="l">
+              <a:buNone/>
               <a:defRPr sz="2175" b="1">
                 <a:solidFill>
                   <a:srgbClr val="101820"/>
@@ -14689,6 +18271,7 @@
           <a:lstStyle xmlns:a="http://schemas.openxmlformats.org/drawingml/2006/main"/>
           <a:p xmlns:a="http://schemas.openxmlformats.org/drawingml/2006/main">
             <a:pPr algn="l">
+              <a:buNone/>
               <a:defRPr sz="1650" b="0">
                 <a:solidFill>
                   <a:srgbClr val="52616B"/>
@@ -14811,6 +18394,7 @@
           <a:lstStyle xmlns:a="http://schemas.openxmlformats.org/drawingml/2006/main"/>
           <a:p xmlns:a="http://schemas.openxmlformats.org/drawingml/2006/main">
             <a:pPr algn="l">
+              <a:buNone/>
               <a:defRPr sz="2175" b="1">
                 <a:solidFill>
                   <a:srgbClr val="101820"/>
@@ -14867,6 +18451,7 @@
           <a:lstStyle xmlns:a="http://schemas.openxmlformats.org/drawingml/2006/main"/>
           <a:p xmlns:a="http://schemas.openxmlformats.org/drawingml/2006/main">
             <a:pPr algn="l">
+              <a:buNone/>
               <a:defRPr sz="1650" b="0">
                 <a:solidFill>
                   <a:srgbClr val="52616B"/>
@@ -14923,6 +18508,7 @@
           <a:lstStyle xmlns:a="http://schemas.openxmlformats.org/drawingml/2006/main"/>
           <a:p xmlns:a="http://schemas.openxmlformats.org/drawingml/2006/main">
             <a:pPr algn="ctr">
+              <a:buNone/>
               <a:defRPr sz="2175" b="1">
                 <a:solidFill>
                   <a:srgbClr val="101820"/>
@@ -15008,6 +18594,7 @@
           <a:lstStyle xmlns:a="http://schemas.openxmlformats.org/drawingml/2006/main"/>
           <a:p xmlns:a="http://schemas.openxmlformats.org/drawingml/2006/main">
             <a:pPr algn="l">
+              <a:buNone/>
               <a:defRPr sz="1200" b="1">
                 <a:solidFill>
                   <a:srgbClr val="3D8DFF"/>
@@ -15064,6 +18651,7 @@
           <a:lstStyle xmlns:a="http://schemas.openxmlformats.org/drawingml/2006/main"/>
           <a:p xmlns:a="http://schemas.openxmlformats.org/drawingml/2006/main">
             <a:pPr algn="l">
+              <a:buNone/>
               <a:defRPr sz="2700" b="1">
                 <a:solidFill>
                   <a:srgbClr val="101820"/>
@@ -15151,6 +18739,7 @@
           <a:lstStyle xmlns:a="http://schemas.openxmlformats.org/drawingml/2006/main"/>
           <a:p xmlns:a="http://schemas.openxmlformats.org/drawingml/2006/main">
             <a:pPr algn="r">
+              <a:buNone/>
               <a:defRPr sz="1200" b="0">
                 <a:solidFill>
                   <a:srgbClr val="52616B"/>
@@ -15207,6 +18796,7 @@
           <a:lstStyle xmlns:a="http://schemas.openxmlformats.org/drawingml/2006/main"/>
           <a:p xmlns:a="http://schemas.openxmlformats.org/drawingml/2006/main">
             <a:pPr algn="l">
+              <a:buNone/>
               <a:defRPr sz="1275" b="1">
                 <a:solidFill>
                   <a:srgbClr val="3D8DFF"/>
@@ -15263,6 +18853,7 @@
           <a:lstStyle xmlns:a="http://schemas.openxmlformats.org/drawingml/2006/main"/>
           <a:p xmlns:a="http://schemas.openxmlformats.org/drawingml/2006/main">
             <a:pPr algn="l">
+              <a:buNone/>
               <a:defRPr sz="2025" b="1">
                 <a:solidFill>
                   <a:srgbClr val="101820"/>
@@ -15350,6 +18941,7 @@
           <a:lstStyle xmlns:a="http://schemas.openxmlformats.org/drawingml/2006/main"/>
           <a:p xmlns:a="http://schemas.openxmlformats.org/drawingml/2006/main">
             <a:pPr algn="l">
+              <a:buNone/>
               <a:defRPr sz="1275" b="1">
                 <a:solidFill>
                   <a:srgbClr val="3D8DFF"/>
@@ -15406,6 +18998,7 @@
           <a:lstStyle xmlns:a="http://schemas.openxmlformats.org/drawingml/2006/main"/>
           <a:p xmlns:a="http://schemas.openxmlformats.org/drawingml/2006/main">
             <a:pPr algn="l">
+              <a:buNone/>
               <a:defRPr sz="2025" b="1">
                 <a:solidFill>
                   <a:srgbClr val="101820"/>
@@ -15429,6 +19022,7 @@
           </a:p>
           <a:p xmlns:a="http://schemas.openxmlformats.org/drawingml/2006/main">
             <a:pPr algn="l">
+              <a:buNone/>
               <a:defRPr sz="2025" b="1">
                 <a:solidFill>
                   <a:srgbClr val="101820"/>
@@ -15485,6 +19079,7 @@
           <a:lstStyle xmlns:a="http://schemas.openxmlformats.org/drawingml/2006/main"/>
           <a:p xmlns:a="http://schemas.openxmlformats.org/drawingml/2006/main">
             <a:pPr algn="l">
+              <a:buNone/>
               <a:defRPr sz="1275" b="1">
                 <a:solidFill>
                   <a:srgbClr val="3D8DFF"/>
@@ -15541,6 +19136,7 @@
           <a:lstStyle xmlns:a="http://schemas.openxmlformats.org/drawingml/2006/main"/>
           <a:p xmlns:a="http://schemas.openxmlformats.org/drawingml/2006/main">
             <a:pPr algn="l">
+              <a:buNone/>
               <a:defRPr sz="2025" b="1">
                 <a:solidFill>
                   <a:srgbClr val="101820"/>
@@ -15564,6 +19160,7 @@
           </a:p>
           <a:p xmlns:a="http://schemas.openxmlformats.org/drawingml/2006/main">
             <a:pPr algn="l">
+              <a:buNone/>
               <a:defRPr sz="2025" b="1">
                 <a:solidFill>
                   <a:srgbClr val="101820"/>
@@ -15620,6 +19217,7 @@
           <a:lstStyle xmlns:a="http://schemas.openxmlformats.org/drawingml/2006/main"/>
           <a:p xmlns:a="http://schemas.openxmlformats.org/drawingml/2006/main">
             <a:pPr algn="l">
+              <a:buNone/>
               <a:defRPr sz="1275" b="1">
                 <a:solidFill>
                   <a:srgbClr val="3D8DFF"/>
@@ -15676,6 +19274,7 @@
           <a:lstStyle xmlns:a="http://schemas.openxmlformats.org/drawingml/2006/main"/>
           <a:p xmlns:a="http://schemas.openxmlformats.org/drawingml/2006/main">
             <a:pPr algn="l">
+              <a:buNone/>
               <a:defRPr sz="2025" b="1">
                 <a:solidFill>
                   <a:srgbClr val="101820"/>
@@ -15699,6 +19298,7 @@
           </a:p>
           <a:p xmlns:a="http://schemas.openxmlformats.org/drawingml/2006/main">
             <a:pPr algn="l">
+              <a:buNone/>
               <a:defRPr sz="2025" b="1">
                 <a:solidFill>
                   <a:srgbClr val="101820"/>
@@ -15755,6 +19355,7 @@
           <a:lstStyle xmlns:a="http://schemas.openxmlformats.org/drawingml/2006/main"/>
           <a:p xmlns:a="http://schemas.openxmlformats.org/drawingml/2006/main">
             <a:pPr algn="l">
+              <a:buNone/>
               <a:defRPr sz="1275" b="1">
                 <a:solidFill>
                   <a:srgbClr val="3D8DFF"/>
@@ -15811,6 +19412,7 @@
           <a:lstStyle xmlns:a="http://schemas.openxmlformats.org/drawingml/2006/main"/>
           <a:p xmlns:a="http://schemas.openxmlformats.org/drawingml/2006/main">
             <a:pPr algn="l">
+              <a:buNone/>
               <a:defRPr sz="2025" b="1">
                 <a:solidFill>
                   <a:srgbClr val="101820"/>
@@ -15834,6 +19436,7 @@
           </a:p>
           <a:p xmlns:a="http://schemas.openxmlformats.org/drawingml/2006/main">
             <a:pPr algn="l">
+              <a:buNone/>
               <a:defRPr sz="2025" b="1">
                 <a:solidFill>
                   <a:srgbClr val="101820"/>
@@ -15923,6 +19526,7 @@
           <a:lstStyle xmlns:a="http://schemas.openxmlformats.org/drawingml/2006/main"/>
           <a:p xmlns:a="http://schemas.openxmlformats.org/drawingml/2006/main">
             <a:pPr algn="ctr">
+              <a:buNone/>
               <a:defRPr sz="1800" b="1">
                 <a:solidFill>
                   <a:srgbClr val="101820"/>

</xml_diff>